<commit_message>
Fix issues found in project review
</commit_message>
<xml_diff>
--- a/project/reports/stakeholder_presentation.pptx
+++ b/project/reports/stakeholder_presentation.pptx
@@ -2,22 +2,22 @@
 <file path=ppt/presentation.xml><?xml version="1.0" encoding="utf-8"?>
 <p:presentation xmlns:p="http://schemas.openxmlformats.org/presentationml/2006/main">
   <p:sldMasterIdLst>
-    <p:sldMasterId xmlns:r="http://schemas.openxmlformats.org/officeDocument/2006/relationships" id="2147483648" r:id="R23a096f78098427b"/>
+    <p:sldMasterId xmlns:r="http://schemas.openxmlformats.org/officeDocument/2006/relationships" id="2147483648" r:id="R75d1dad5a5bf49fe"/>
   </p:sldMasterIdLst>
   <p:notesMasterIdLst>
-    <p:notesMasterId xmlns:r="http://schemas.openxmlformats.org/officeDocument/2006/relationships" r:id="R35732f385f9348f2"/>
+    <p:notesMasterId xmlns:r="http://schemas.openxmlformats.org/officeDocument/2006/relationships" r:id="Recda45485d154703"/>
   </p:notesMasterIdLst>
   <p:sldIdLst>
-    <p:sldId xmlns:r="http://schemas.openxmlformats.org/officeDocument/2006/relationships" id="256" r:id="R7720d8f3fdb048fe"/>
-    <p:sldId xmlns:r="http://schemas.openxmlformats.org/officeDocument/2006/relationships" id="257" r:id="Rd310859f26f14efd"/>
-    <p:sldId xmlns:r="http://schemas.openxmlformats.org/officeDocument/2006/relationships" id="258" r:id="Ra86b09631ac948f4"/>
-    <p:sldId xmlns:r="http://schemas.openxmlformats.org/officeDocument/2006/relationships" id="259" r:id="Ra99f7eb1960e4b39"/>
-    <p:sldId xmlns:r="http://schemas.openxmlformats.org/officeDocument/2006/relationships" id="260" r:id="Rc18503a873af4566"/>
-    <p:sldId xmlns:r="http://schemas.openxmlformats.org/officeDocument/2006/relationships" id="261" r:id="Rbd317b19ac1e4228"/>
-    <p:sldId xmlns:r="http://schemas.openxmlformats.org/officeDocument/2006/relationships" id="262" r:id="Ra990a3e542d64708"/>
-    <p:sldId xmlns:r="http://schemas.openxmlformats.org/officeDocument/2006/relationships" id="263" r:id="R000f687df64848f8"/>
-    <p:sldId xmlns:r="http://schemas.openxmlformats.org/officeDocument/2006/relationships" id="264" r:id="R3e7f772708804f46"/>
-    <p:sldId xmlns:r="http://schemas.openxmlformats.org/officeDocument/2006/relationships" id="265" r:id="R995eb571bdd14833"/>
+    <p:sldId xmlns:r="http://schemas.openxmlformats.org/officeDocument/2006/relationships" id="256" r:id="R34adc388ed794a09"/>
+    <p:sldId xmlns:r="http://schemas.openxmlformats.org/officeDocument/2006/relationships" id="257" r:id="Rd2bf2269dd0e40b5"/>
+    <p:sldId xmlns:r="http://schemas.openxmlformats.org/officeDocument/2006/relationships" id="258" r:id="R1ac72369246445e7"/>
+    <p:sldId xmlns:r="http://schemas.openxmlformats.org/officeDocument/2006/relationships" id="259" r:id="Rb9bca3125aaf4661"/>
+    <p:sldId xmlns:r="http://schemas.openxmlformats.org/officeDocument/2006/relationships" id="260" r:id="R37f983cddc114cdb"/>
+    <p:sldId xmlns:r="http://schemas.openxmlformats.org/officeDocument/2006/relationships" id="261" r:id="Rfb3dd1dd1fc2427f"/>
+    <p:sldId xmlns:r="http://schemas.openxmlformats.org/officeDocument/2006/relationships" id="262" r:id="R616495f722bc4fac"/>
+    <p:sldId xmlns:r="http://schemas.openxmlformats.org/officeDocument/2006/relationships" id="263" r:id="R9f15f4c64dbb4f5e"/>
+    <p:sldId xmlns:r="http://schemas.openxmlformats.org/officeDocument/2006/relationships" id="264" r:id="Raaf476cffe594c20"/>
+    <p:sldId xmlns:r="http://schemas.openxmlformats.org/officeDocument/2006/relationships" id="265" r:id="Rf198ec54926846ec"/>
   </p:sldIdLst>
   <p:sldSz cx="12192000" cy="6858000"/>
   <p:notesSz cx="6858000" cy="9144000"/>
@@ -1061,12 +1061,17 @@
           </a:p>
           <a:p xmlns:a="http://schemas.openxmlformats.org/drawingml/2006/main">
             <a:r>
+              <a:t>- project/reports/metrics.json</a:t>
+            </a:r>
+          </a:p>
+          <a:p xmlns:a="http://schemas.openxmlformats.org/drawingml/2006/main">
+            <a:r>
               <a:t>- project/reports/risk_threshold_sensitivity.csv</a:t>
             </a:r>
           </a:p>
           <a:p xmlns:a="http://schemas.openxmlformats.org/drawingml/2006/main">
             <a:r>
-              <a:t>- project/reports/metrics.json</a:t>
+              <a:t>- project/reports/feature_window_sensitivity.csv</a:t>
             </a:r>
           </a:p>
           <a:p xmlns:a="http://schemas.openxmlformats.org/drawingml/2006/main">
@@ -1309,7 +1314,7 @@
   </p:cSld>
   <p:clrMap bg1="lt1" tx1="dk1" bg2="lt2" tx2="dk2" accent1="accent1" accent2="accent2" accent3="accent3" accent4="accent4" accent5="accent5" accent6="accent6" hlink="hlink" folHlink="folHlink"/>
   <p:sldLayoutIdLst>
-    <p:sldLayoutId xmlns:r="http://schemas.openxmlformats.org/officeDocument/2006/relationships" id="2147483649" r:id="Rb22e62e4f2414bbb"/>
+    <p:sldLayoutId xmlns:r="http://schemas.openxmlformats.org/officeDocument/2006/relationships" id="2147483649" r:id="Rca0b756fd2074172"/>
   </p:sldLayoutIdLst>
   <p:txStyles>
     <p:titleStyle>
@@ -2393,10 +2398,10 @@
               <c:formatCode>0.0</c:formatCode>
               <c:ptCount val="2"/>
               <c:pt idx="0">
-                <c:v>4.021380034852036</c:v>
+                <c:v>4.02</c:v>
               </c:pt>
               <c:pt idx="1">
-                <c:v>6.586536245331256</c:v>
+                <c:v>6.58</c:v>
               </c:pt>
             </c:numLit>
           </c:val>
@@ -2428,10 +2433,10 @@
               <c:formatCode>0.0</c:formatCode>
               <c:ptCount val="2"/>
               <c:pt idx="0">
-                <c:v>5.0736439313003405</c:v>
+                <c:v>5.07</c:v>
               </c:pt>
               <c:pt idx="1">
-                <c:v>8.64132648900294</c:v>
+                <c:v>8.64</c:v>
               </c:pt>
             </c:numLit>
           </c:val>
@@ -2463,10 +2468,10 @@
               <c:formatCode>0.0</c:formatCode>
               <c:ptCount val="2"/>
               <c:pt idx="0">
-                <c:v>5.167941188693652</c:v>
+                <c:v>5.17</c:v>
               </c:pt>
               <c:pt idx="1">
-                <c:v>8.210604486408107</c:v>
+                <c:v>8.21</c:v>
               </c:pt>
             </c:numLit>
           </c:val>
@@ -2663,13 +2668,13 @@
               <c:formatCode>General</c:formatCode>
               <c:ptCount val="4"/>
               <c:pt idx="0">
-                <c:v>72.3</c:v>
+                <c:v>72.7</c:v>
               </c:pt>
               <c:pt idx="1">
-                <c:v>37</c:v>
+                <c:v>37.2</c:v>
               </c:pt>
               <c:pt idx="2">
-                <c:v>60.4</c:v>
+                <c:v>61.3</c:v>
               </c:pt>
               <c:pt idx="3">
                 <c:v>77.7</c:v>
@@ -2678,22 +2683,8 @@
           </c:val>
         </c:ser>
         <c:dLbls>
-          <c:txPr>
-            <a:bodyPr xmlns:a="http://schemas.openxmlformats.org/drawingml/2006/main" anchorCtr="1"/>
-            <a:lstStyle xmlns:a="http://schemas.openxmlformats.org/drawingml/2006/main"/>
-            <a:p xmlns:a="http://schemas.openxmlformats.org/drawingml/2006/main">
-              <a:pPr>
-                <a:defRPr sz="1050" b="1">
-                  <a:solidFill>
-                    <a:srgbClr val="111111"/>
-                  </a:solidFill>
-                </a:defRPr>
-              </a:pPr>
-            </a:p>
-          </c:txPr>
-          <c:dLblPos val="outEnd"/>
           <c:showLegendKey val="0"/>
-          <c:showVal val="1"/>
+          <c:showVal val="0"/>
           <c:showCatName val="0"/>
           <c:showSerName val="0"/>
           <c:showPercent val="0"/>
@@ -2721,7 +2712,7 @@
             </a:ln>
           </c:spPr>
         </c:majorGridlines>
-        <c:numFmt formatCode="0"/>
+        <c:numFmt formatCode="0&quot;%&quot;"/>
         <c:majorTickMark val="none"/>
         <c:minorTickMark val="none"/>
         <c:spPr>
@@ -2843,7 +2834,7 @@
                 <c:v>20-day actual</c:v>
               </c:pt>
               <c:pt idx="1">
-                <c:v>Next-week forecast</c:v>
+                <c:v>Five-session forecast</c:v>
               </c:pt>
               <c:pt idx="2">
                 <c:v>Risk threshold</c:v>
@@ -2858,10 +2849,10 @@
                 <c:v>13.5</c:v>
               </c:pt>
               <c:pt idx="1">
-                <c:v>11.1</c:v>
+                <c:v>11.3</c:v>
               </c:pt>
               <c:pt idx="2">
-                <c:v>17.8</c:v>
+                <c:v>17.1</c:v>
               </c:pt>
             </c:numLit>
           </c:val>
@@ -3020,7 +3011,7 @@
           <p:cNvPr id="9" name="">
             <a:extLst xmlns:a="http://schemas.openxmlformats.org/drawingml/2006/main">
               <a:ext uri="{FF2B5EF4-FFF2-40B4-BE49-F238E27FC236}">
-                <a16:creationId xmlns:a16="http://schemas.microsoft.com/office/drawing/2014/main" id="{1954EB48-3D7E-48A2-A8EC-9025DBD89F6F}"/>
+                <a16:creationId xmlns:a16="http://schemas.microsoft.com/office/drawing/2014/main" id="{AC6E97D1-2975-470E-B0C2-B495A7808B7D}"/>
               </a:ext>
             </a:extLst>
           </p:cNvPr>
@@ -3070,7 +3061,7 @@
           <p:cNvPr id="2" name="deck-title">
             <a:extLst xmlns:a="http://schemas.openxmlformats.org/drawingml/2006/main">
               <a:ext uri="{FF2B5EF4-FFF2-40B4-BE49-F238E27FC236}">
-                <a16:creationId xmlns:a16="http://schemas.microsoft.com/office/drawing/2014/main" id="{C580EAFD-F8CD-4DAA-A078-3329A9994EAA}"/>
+                <a16:creationId xmlns:a16="http://schemas.microsoft.com/office/drawing/2014/main" id="{C2EAC7E1-8267-4823-AA38-08C3DD75A315}"/>
               </a:ext>
             </a:extLst>
           </p:cNvPr>
@@ -3137,7 +3128,7 @@
           <p:cNvPr id="3" name="">
             <a:extLst xmlns:a="http://schemas.openxmlformats.org/drawingml/2006/main">
               <a:ext uri="{FF2B5EF4-FFF2-40B4-BE49-F238E27FC236}">
-                <a16:creationId xmlns:a16="http://schemas.microsoft.com/office/drawing/2014/main" id="{85AE80CE-C324-4416-A51D-90C2D48CEE42}"/>
+                <a16:creationId xmlns:a16="http://schemas.microsoft.com/office/drawing/2014/main" id="{6005C73D-AA6E-43FA-AD45-2C0CA7C5F132}"/>
               </a:ext>
             </a:extLst>
           </p:cNvPr>
@@ -3187,7 +3178,7 @@
           <p:cNvPr id="4" name="">
             <a:extLst xmlns:a="http://schemas.openxmlformats.org/drawingml/2006/main">
               <a:ext uri="{FF2B5EF4-FFF2-40B4-BE49-F238E27FC236}">
-                <a16:creationId xmlns:a16="http://schemas.microsoft.com/office/drawing/2014/main" id="{45D443AA-6144-4502-95E2-61D679EDFD45}"/>
+                <a16:creationId xmlns:a16="http://schemas.microsoft.com/office/drawing/2014/main" id="{36E18B43-CB68-4D67-B54E-A82C0C72C046}"/>
               </a:ext>
             </a:extLst>
           </p:cNvPr>
@@ -3254,7 +3245,7 @@
           <p:cNvPr id="5" name="">
             <a:extLst xmlns:a="http://schemas.openxmlformats.org/drawingml/2006/main">
               <a:ext uri="{FF2B5EF4-FFF2-40B4-BE49-F238E27FC236}">
-                <a16:creationId xmlns:a16="http://schemas.microsoft.com/office/drawing/2014/main" id="{1F296F3A-8225-4D1C-869F-A118E9ED4C4C}"/>
+                <a16:creationId xmlns:a16="http://schemas.microsoft.com/office/drawing/2014/main" id="{DC6D16FF-C3D6-47C8-BE8A-A04334D70A6A}"/>
               </a:ext>
             </a:extLst>
           </p:cNvPr>
@@ -3294,7 +3285,7 @@
         </p:xfrm>
         <a:graphic xmlns:a="http://schemas.openxmlformats.org/drawingml/2006/main">
           <a:graphicData uri="http://schemas.openxmlformats.org/drawingml/2006/chart">
-            <c:chart xmlns:r="http://schemas.openxmlformats.org/officeDocument/2006/relationships" xmlns:c="http://schemas.openxmlformats.org/drawingml/2006/chart" r:id="R9e6e7ea8f89a49e1"/>
+            <c:chart xmlns:r="http://schemas.openxmlformats.org/officeDocument/2006/relationships" xmlns:c="http://schemas.openxmlformats.org/drawingml/2006/chart" r:id="Ra42ba650e2644232"/>
           </a:graphicData>
         </a:graphic>
       </p:graphicFrame>
@@ -3303,7 +3294,7 @@
           <p:cNvPr id="7" name="source-footer">
             <a:extLst xmlns:a="http://schemas.openxmlformats.org/drawingml/2006/main">
               <a:ext uri="{FF2B5EF4-FFF2-40B4-BE49-F238E27FC236}">
-                <a16:creationId xmlns:a16="http://schemas.microsoft.com/office/drawing/2014/main" id="{C0AEC0DE-57D4-42A4-9953-DEC5AC47951C}"/>
+                <a16:creationId xmlns:a16="http://schemas.microsoft.com/office/drawing/2014/main" id="{C56784B8-DDAE-406C-8E40-8AB7074A10D2}"/>
               </a:ext>
             </a:extLst>
           </p:cNvPr>
@@ -3353,7 +3344,7 @@
           <p:cNvPr id="8" name="slide-number">
             <a:extLst xmlns:a="http://schemas.openxmlformats.org/drawingml/2006/main">
               <a:ext uri="{FF2B5EF4-FFF2-40B4-BE49-F238E27FC236}">
-                <a16:creationId xmlns:a16="http://schemas.microsoft.com/office/drawing/2014/main" id="{B1D57707-8153-49D7-80BE-F39985967492}"/>
+                <a16:creationId xmlns:a16="http://schemas.microsoft.com/office/drawing/2014/main" id="{EFFE22AE-014D-4097-8E9A-D2D0DCBCF9F7}"/>
               </a:ext>
             </a:extLst>
           </p:cNvPr>
@@ -3401,7 +3392,7 @@
     </p:spTree>
     <p:extLst>
       <p:ext uri="{BB962C8B-B14F-4D97-AF65-F5344CB8AC3E}">
-        <p14:creationId xmlns:p14="http://schemas.microsoft.com/office/powerpoint/2010/main" val="42289298"/>
+        <p14:creationId xmlns:p14="http://schemas.microsoft.com/office/powerpoint/2010/main" val="1828493695"/>
       </p:ext>
     </p:extLst>
   </p:cSld>
@@ -3432,7 +3423,7 @@
           <p:cNvPr id="11" name="">
             <a:extLst xmlns:a="http://schemas.openxmlformats.org/drawingml/2006/main">
               <a:ext uri="{FF2B5EF4-FFF2-40B4-BE49-F238E27FC236}">
-                <a16:creationId xmlns:a16="http://schemas.microsoft.com/office/drawing/2014/main" id="{FEBB240A-6E6C-49FC-A1FF-E9C62DCF9CA4}"/>
+                <a16:creationId xmlns:a16="http://schemas.microsoft.com/office/drawing/2014/main" id="{FF4311FE-0355-4428-B492-CD40E2EEE0D1}"/>
               </a:ext>
             </a:extLst>
           </p:cNvPr>
@@ -3482,7 +3473,7 @@
           <p:cNvPr id="2" name="">
             <a:extLst xmlns:a="http://schemas.openxmlformats.org/drawingml/2006/main">
               <a:ext uri="{FF2B5EF4-FFF2-40B4-BE49-F238E27FC236}">
-                <a16:creationId xmlns:a16="http://schemas.microsoft.com/office/drawing/2014/main" id="{045C5630-7C15-4D96-9AFD-B9727F9F5E5D}"/>
+                <a16:creationId xmlns:a16="http://schemas.microsoft.com/office/drawing/2014/main" id="{763841F6-58B5-406B-BFDD-DC1E79808C33}"/>
               </a:ext>
             </a:extLst>
           </p:cNvPr>
@@ -3532,7 +3523,7 @@
           <p:cNvPr id="3" name="">
             <a:extLst xmlns:a="http://schemas.openxmlformats.org/drawingml/2006/main">
               <a:ext uri="{FF2B5EF4-FFF2-40B4-BE49-F238E27FC236}">
-                <a16:creationId xmlns:a16="http://schemas.microsoft.com/office/drawing/2014/main" id="{C3BA8B2C-C608-47A4-A87B-B48029599665}"/>
+                <a16:creationId xmlns:a16="http://schemas.microsoft.com/office/drawing/2014/main" id="{D4950D2F-87FB-4208-8814-D8C0D628C034}"/>
               </a:ext>
             </a:extLst>
           </p:cNvPr>
@@ -3563,7 +3554,7 @@
           <p:cNvPr id="4" name="">
             <a:extLst xmlns:a="http://schemas.openxmlformats.org/drawingml/2006/main">
               <a:ext uri="{FF2B5EF4-FFF2-40B4-BE49-F238E27FC236}">
-                <a16:creationId xmlns:a16="http://schemas.microsoft.com/office/drawing/2014/main" id="{AB2836F6-8103-41A5-8E9B-978288346DC7}"/>
+                <a16:creationId xmlns:a16="http://schemas.microsoft.com/office/drawing/2014/main" id="{528FF991-E860-4539-B801-9CFDCB1D1CDE}"/>
               </a:ext>
             </a:extLst>
           </p:cNvPr>
@@ -3603,7 +3594,7 @@
                   <a:srgbClr val="5F6368"/>
                 </a:solidFill>
               </a:rPr>
-              <a:t>Investigate exposure or hedging when the elevated-risk probability reaches 50% or the forecast rises above the training-derived threshold.</a:t>
+              <a:t>Investigate exposure or hedging when the class-weighted elevated-risk score reaches 50%. Use the volatility forecast as supporting context.</a:t>
             </a:r>
           </a:p>
         </p:txBody>
@@ -3613,7 +3604,7 @@
           <p:cNvPr id="5" name="">
             <a:extLst xmlns:a="http://schemas.openxmlformats.org/drawingml/2006/main">
               <a:ext uri="{FF2B5EF4-FFF2-40B4-BE49-F238E27FC236}">
-                <a16:creationId xmlns:a16="http://schemas.microsoft.com/office/drawing/2014/main" id="{9EC7A325-D41C-49FC-A061-8515FD270273}"/>
+                <a16:creationId xmlns:a16="http://schemas.microsoft.com/office/drawing/2014/main" id="{C542C163-892A-44CF-B499-3C2E19A294E6}"/>
               </a:ext>
             </a:extLst>
           </p:cNvPr>
@@ -3644,7 +3635,7 @@
           <p:cNvPr id="6" name="">
             <a:extLst xmlns:a="http://schemas.openxmlformats.org/drawingml/2006/main">
               <a:ext uri="{FF2B5EF4-FFF2-40B4-BE49-F238E27FC236}">
-                <a16:creationId xmlns:a16="http://schemas.microsoft.com/office/drawing/2014/main" id="{4767ABE9-042E-4CA0-90E2-905EEC4CF61C}"/>
+                <a16:creationId xmlns:a16="http://schemas.microsoft.com/office/drawing/2014/main" id="{49552C5B-8EA4-4DAA-B4D2-F39557620245}"/>
               </a:ext>
             </a:extLst>
           </p:cNvPr>
@@ -3694,7 +3685,7 @@
           <p:cNvPr id="7" name="">
             <a:extLst xmlns:a="http://schemas.openxmlformats.org/drawingml/2006/main">
               <a:ext uri="{FF2B5EF4-FFF2-40B4-BE49-F238E27FC236}">
-                <a16:creationId xmlns:a16="http://schemas.microsoft.com/office/drawing/2014/main" id="{12FA2482-496D-496E-BB13-9C8A8A548A92}"/>
+                <a16:creationId xmlns:a16="http://schemas.microsoft.com/office/drawing/2014/main" id="{F5FB5DAA-936B-4A2A-A64D-496C5D622922}"/>
               </a:ext>
             </a:extLst>
           </p:cNvPr>
@@ -3744,7 +3735,7 @@
           <p:cNvPr id="8" name="">
             <a:extLst xmlns:a="http://schemas.openxmlformats.org/drawingml/2006/main">
               <a:ext uri="{FF2B5EF4-FFF2-40B4-BE49-F238E27FC236}">
-                <a16:creationId xmlns:a16="http://schemas.microsoft.com/office/drawing/2014/main" id="{5901D33E-BA36-4506-942B-DD74389101A6}"/>
+                <a16:creationId xmlns:a16="http://schemas.microsoft.com/office/drawing/2014/main" id="{B9B5BED7-589E-40C4-A899-C02DD0C0B757}"/>
               </a:ext>
             </a:extLst>
           </p:cNvPr>
@@ -3794,7 +3785,7 @@
           <p:cNvPr id="9" name="source-footer">
             <a:extLst xmlns:a="http://schemas.openxmlformats.org/drawingml/2006/main">
               <a:ext uri="{FF2B5EF4-FFF2-40B4-BE49-F238E27FC236}">
-                <a16:creationId xmlns:a16="http://schemas.microsoft.com/office/drawing/2014/main" id="{7571FF02-77B6-4139-B7D6-83FFCFB5C03A}"/>
+                <a16:creationId xmlns:a16="http://schemas.microsoft.com/office/drawing/2014/main" id="{2AD4E124-C0A6-4A74-8A2B-1F631432E3EF}"/>
               </a:ext>
             </a:extLst>
           </p:cNvPr>
@@ -3844,7 +3835,7 @@
           <p:cNvPr id="10" name="slide-number">
             <a:extLst xmlns:a="http://schemas.openxmlformats.org/drawingml/2006/main">
               <a:ext uri="{FF2B5EF4-FFF2-40B4-BE49-F238E27FC236}">
-                <a16:creationId xmlns:a16="http://schemas.microsoft.com/office/drawing/2014/main" id="{3C46CD25-3E63-439D-902F-C0C99E4E3D93}"/>
+                <a16:creationId xmlns:a16="http://schemas.microsoft.com/office/drawing/2014/main" id="{B79B07A4-3D4D-452E-8118-2DCC76BBFBEC}"/>
               </a:ext>
             </a:extLst>
           </p:cNvPr>
@@ -3892,7 +3883,7 @@
     </p:spTree>
     <p:extLst>
       <p:ext uri="{BB962C8B-B14F-4D97-AF65-F5344CB8AC3E}">
-        <p14:creationId xmlns:p14="http://schemas.microsoft.com/office/powerpoint/2010/main" val="1596023968"/>
+        <p14:creationId xmlns:p14="http://schemas.microsoft.com/office/powerpoint/2010/main" val="1343967116"/>
       </p:ext>
     </p:extLst>
   </p:cSld>
@@ -3923,7 +3914,7 @@
           <p:cNvPr id="17" name="slide-title">
             <a:extLst xmlns:a="http://schemas.openxmlformats.org/drawingml/2006/main">
               <a:ext uri="{FF2B5EF4-FFF2-40B4-BE49-F238E27FC236}">
-                <a16:creationId xmlns:a16="http://schemas.microsoft.com/office/drawing/2014/main" id="{AF72F7FE-4AAA-4A75-8C2A-B89D7DADEF4A}"/>
+                <a16:creationId xmlns:a16="http://schemas.microsoft.com/office/drawing/2014/main" id="{3B5BADDE-6C93-4628-A056-6229EEA22E84}"/>
               </a:ext>
             </a:extLst>
           </p:cNvPr>
@@ -3973,7 +3964,7 @@
           <p:cNvPr id="2" name="title-rule">
             <a:extLst xmlns:a="http://schemas.openxmlformats.org/drawingml/2006/main">
               <a:ext uri="{FF2B5EF4-FFF2-40B4-BE49-F238E27FC236}">
-                <a16:creationId xmlns:a16="http://schemas.microsoft.com/office/drawing/2014/main" id="{844AB45E-264A-4221-9E8D-FDC90ACA56E7}"/>
+                <a16:creationId xmlns:a16="http://schemas.microsoft.com/office/drawing/2014/main" id="{EDB1B2D8-584F-4421-8916-F36540E9F5F5}"/>
               </a:ext>
             </a:extLst>
           </p:cNvPr>
@@ -4004,7 +3995,7 @@
           <p:cNvPr id="3" name="">
             <a:extLst xmlns:a="http://schemas.openxmlformats.org/drawingml/2006/main">
               <a:ext uri="{FF2B5EF4-FFF2-40B4-BE49-F238E27FC236}">
-                <a16:creationId xmlns:a16="http://schemas.microsoft.com/office/drawing/2014/main" id="{6941ACF8-2527-4E77-8637-6B4BBEC9E45F}"/>
+                <a16:creationId xmlns:a16="http://schemas.microsoft.com/office/drawing/2014/main" id="{6600DDBF-5194-4450-9F20-2C25A2EFCBB0}"/>
               </a:ext>
             </a:extLst>
           </p:cNvPr>
@@ -4054,7 +4045,7 @@
           <p:cNvPr id="4" name="">
             <a:extLst xmlns:a="http://schemas.openxmlformats.org/drawingml/2006/main">
               <a:ext uri="{FF2B5EF4-FFF2-40B4-BE49-F238E27FC236}">
-                <a16:creationId xmlns:a16="http://schemas.microsoft.com/office/drawing/2014/main" id="{9CF6DE31-18C0-44CF-AFE3-B8E69FAC48CC}"/>
+                <a16:creationId xmlns:a16="http://schemas.microsoft.com/office/drawing/2014/main" id="{BBD7939D-ACAB-46BD-AD14-3E428B359731}"/>
               </a:ext>
             </a:extLst>
           </p:cNvPr>
@@ -4085,7 +4076,7 @@
           <p:cNvPr id="5" name="">
             <a:extLst xmlns:a="http://schemas.openxmlformats.org/drawingml/2006/main">
               <a:ext uri="{FF2B5EF4-FFF2-40B4-BE49-F238E27FC236}">
-                <a16:creationId xmlns:a16="http://schemas.microsoft.com/office/drawing/2014/main" id="{834BECAB-20EE-471F-8AC7-B5EE8335D83B}"/>
+                <a16:creationId xmlns:a16="http://schemas.microsoft.com/office/drawing/2014/main" id="{B58C8C12-BB06-4F16-BDD3-0CBF0A873635}"/>
               </a:ext>
             </a:extLst>
           </p:cNvPr>
@@ -4135,7 +4126,7 @@
           <p:cNvPr id="6" name="">
             <a:extLst xmlns:a="http://schemas.openxmlformats.org/drawingml/2006/main">
               <a:ext uri="{FF2B5EF4-FFF2-40B4-BE49-F238E27FC236}">
-                <a16:creationId xmlns:a16="http://schemas.microsoft.com/office/drawing/2014/main" id="{5D58A104-EEE5-4479-BDE2-7ED873B2E2FC}"/>
+                <a16:creationId xmlns:a16="http://schemas.microsoft.com/office/drawing/2014/main" id="{0F1BE8F2-F9B9-4DBC-9B6B-A591CAAF5E7C}"/>
               </a:ext>
             </a:extLst>
           </p:cNvPr>
@@ -4185,7 +4176,7 @@
           <p:cNvPr id="7" name="">
             <a:extLst xmlns:a="http://schemas.openxmlformats.org/drawingml/2006/main">
               <a:ext uri="{FF2B5EF4-FFF2-40B4-BE49-F238E27FC236}">
-                <a16:creationId xmlns:a16="http://schemas.microsoft.com/office/drawing/2014/main" id="{02D6CAB8-B300-41BD-8F79-E225D0880E08}"/>
+                <a16:creationId xmlns:a16="http://schemas.microsoft.com/office/drawing/2014/main" id="{451F61E3-E114-46F3-A85B-735A45009671}"/>
               </a:ext>
             </a:extLst>
           </p:cNvPr>
@@ -4235,7 +4226,7 @@
           <p:cNvPr id="8" name="">
             <a:extLst xmlns:a="http://schemas.openxmlformats.org/drawingml/2006/main">
               <a:ext uri="{FF2B5EF4-FFF2-40B4-BE49-F238E27FC236}">
-                <a16:creationId xmlns:a16="http://schemas.microsoft.com/office/drawing/2014/main" id="{63F9CABE-E78C-4C54-982F-784B0CDBB61E}"/>
+                <a16:creationId xmlns:a16="http://schemas.microsoft.com/office/drawing/2014/main" id="{1B53B3C8-D6B3-4239-BFC4-3979FE8B840F}"/>
               </a:ext>
             </a:extLst>
           </p:cNvPr>
@@ -4275,7 +4266,7 @@
                   <a:srgbClr val="5F6368"/>
                 </a:solidFill>
               </a:rPr>
-              <a:t>Next-week annualized realized volatility</a:t>
+              <a:t>Next-five-session annualized volatility</a:t>
             </a:r>
           </a:p>
         </p:txBody>
@@ -4285,7 +4276,7 @@
           <p:cNvPr id="9" name="">
             <a:extLst xmlns:a="http://schemas.openxmlformats.org/drawingml/2006/main">
               <a:ext uri="{FF2B5EF4-FFF2-40B4-BE49-F238E27FC236}">
-                <a16:creationId xmlns:a16="http://schemas.microsoft.com/office/drawing/2014/main" id="{9E5FD81A-2A1C-4415-93EB-3C3A5AD8C69B}"/>
+                <a16:creationId xmlns:a16="http://schemas.microsoft.com/office/drawing/2014/main" id="{FDBF8857-561C-4DA9-94CE-BE29B4718695}"/>
               </a:ext>
             </a:extLst>
           </p:cNvPr>
@@ -4335,7 +4326,7 @@
           <p:cNvPr id="10" name="">
             <a:extLst xmlns:a="http://schemas.openxmlformats.org/drawingml/2006/main">
               <a:ext uri="{FF2B5EF4-FFF2-40B4-BE49-F238E27FC236}">
-                <a16:creationId xmlns:a16="http://schemas.microsoft.com/office/drawing/2014/main" id="{4655A2DE-EFC2-4300-AE97-03A005D2789B}"/>
+                <a16:creationId xmlns:a16="http://schemas.microsoft.com/office/drawing/2014/main" id="{06D00A25-6740-45B9-B0BB-52E0DCA58BD5}"/>
               </a:ext>
             </a:extLst>
           </p:cNvPr>
@@ -4385,7 +4376,7 @@
           <p:cNvPr id="11" name="">
             <a:extLst xmlns:a="http://schemas.openxmlformats.org/drawingml/2006/main">
               <a:ext uri="{FF2B5EF4-FFF2-40B4-BE49-F238E27FC236}">
-                <a16:creationId xmlns:a16="http://schemas.microsoft.com/office/drawing/2014/main" id="{69418E5F-5754-4B99-802C-A503570AED7D}"/>
+                <a16:creationId xmlns:a16="http://schemas.microsoft.com/office/drawing/2014/main" id="{578FF2AA-B2E8-428A-B2D3-97F724F5E172}"/>
               </a:ext>
             </a:extLst>
           </p:cNvPr>
@@ -4397,7 +4388,7 @@
         <p:spPr>
           <a:xfrm xmlns:a="http://schemas.openxmlformats.org/drawingml/2006/main">
             <a:off x="7181850" y="3676650"/>
-            <a:ext cx="3810000" cy="419100"/>
+            <a:ext cx="3810000" cy="514350"/>
           </a:xfrm>
           <a:prstGeom xmlns:a="http://schemas.openxmlformats.org/drawingml/2006/main" prst="rect">
             <a:avLst/>
@@ -4425,7 +4416,7 @@
                   <a:srgbClr val="5F6368"/>
                 </a:solidFill>
               </a:rPr>
-              <a:t>Probability of an elevated-risk week</a:t>
+              <a:t>Class-weighted risk score—not a literal probability</a:t>
             </a:r>
           </a:p>
         </p:txBody>
@@ -4435,7 +4426,7 @@
           <p:cNvPr id="12" name="">
             <a:extLst xmlns:a="http://schemas.openxmlformats.org/drawingml/2006/main">
               <a:ext uri="{FF2B5EF4-FFF2-40B4-BE49-F238E27FC236}">
-                <a16:creationId xmlns:a16="http://schemas.microsoft.com/office/drawing/2014/main" id="{5B3C47AC-BC40-4B8D-98FA-6C054F4B54C1}"/>
+                <a16:creationId xmlns:a16="http://schemas.microsoft.com/office/drawing/2014/main" id="{6C56422B-206E-4F40-ADBC-CCC6BC61FD6A}"/>
               </a:ext>
             </a:extLst>
           </p:cNvPr>
@@ -4485,7 +4476,7 @@
           <p:cNvPr id="13" name="">
             <a:extLst xmlns:a="http://schemas.openxmlformats.org/drawingml/2006/main">
               <a:ext uri="{FF2B5EF4-FFF2-40B4-BE49-F238E27FC236}">
-                <a16:creationId xmlns:a16="http://schemas.microsoft.com/office/drawing/2014/main" id="{67A546E9-704D-4566-8AF8-FCFF43878D1D}"/>
+                <a16:creationId xmlns:a16="http://schemas.microsoft.com/office/drawing/2014/main" id="{3CDBDF91-6853-41D5-8255-858CE903F76D}"/>
               </a:ext>
             </a:extLst>
           </p:cNvPr>
@@ -4535,7 +4526,7 @@
           <p:cNvPr id="14" name="">
             <a:extLst xmlns:a="http://schemas.openxmlformats.org/drawingml/2006/main">
               <a:ext uri="{FF2B5EF4-FFF2-40B4-BE49-F238E27FC236}">
-                <a16:creationId xmlns:a16="http://schemas.microsoft.com/office/drawing/2014/main" id="{F274BE4F-D0AF-49CA-B9AD-AD36EC66DBA4}"/>
+                <a16:creationId xmlns:a16="http://schemas.microsoft.com/office/drawing/2014/main" id="{A9071BCE-B009-4298-AE65-84DA5C2B71FE}"/>
               </a:ext>
             </a:extLst>
           </p:cNvPr>
@@ -4585,7 +4576,7 @@
           <p:cNvPr id="15" name="source-footer">
             <a:extLst xmlns:a="http://schemas.openxmlformats.org/drawingml/2006/main">
               <a:ext uri="{FF2B5EF4-FFF2-40B4-BE49-F238E27FC236}">
-                <a16:creationId xmlns:a16="http://schemas.microsoft.com/office/drawing/2014/main" id="{80AB657B-FF22-4B33-AF6D-2527FB4407B3}"/>
+                <a16:creationId xmlns:a16="http://schemas.microsoft.com/office/drawing/2014/main" id="{8F038156-A967-4F52-8B88-F5E5141F5495}"/>
               </a:ext>
             </a:extLst>
           </p:cNvPr>
@@ -4635,7 +4626,7 @@
           <p:cNvPr id="16" name="slide-number">
             <a:extLst xmlns:a="http://schemas.openxmlformats.org/drawingml/2006/main">
               <a:ext uri="{FF2B5EF4-FFF2-40B4-BE49-F238E27FC236}">
-                <a16:creationId xmlns:a16="http://schemas.microsoft.com/office/drawing/2014/main" id="{7D2AAD21-A6C6-477F-A0DA-388C17D9C4A4}"/>
+                <a16:creationId xmlns:a16="http://schemas.microsoft.com/office/drawing/2014/main" id="{12E0E9A9-F09D-4C1A-A996-EF3C36A6935D}"/>
               </a:ext>
             </a:extLst>
           </p:cNvPr>
@@ -4683,7 +4674,7 @@
     </p:spTree>
     <p:extLst>
       <p:ext uri="{BB962C8B-B14F-4D97-AF65-F5344CB8AC3E}">
-        <p14:creationId xmlns:p14="http://schemas.microsoft.com/office/powerpoint/2010/main" val="2088694512"/>
+        <p14:creationId xmlns:p14="http://schemas.microsoft.com/office/powerpoint/2010/main" val="2133204112"/>
       </p:ext>
     </p:extLst>
   </p:cSld>
@@ -4714,7 +4705,7 @@
           <p:cNvPr id="21" name="slide-title">
             <a:extLst xmlns:a="http://schemas.openxmlformats.org/drawingml/2006/main">
               <a:ext uri="{FF2B5EF4-FFF2-40B4-BE49-F238E27FC236}">
-                <a16:creationId xmlns:a16="http://schemas.microsoft.com/office/drawing/2014/main" id="{8503531F-9C3B-4367-AD90-5895EBF1809F}"/>
+                <a16:creationId xmlns:a16="http://schemas.microsoft.com/office/drawing/2014/main" id="{07C4D049-B2D3-409F-B6A1-6C3991664012}"/>
               </a:ext>
             </a:extLst>
           </p:cNvPr>
@@ -4764,7 +4755,7 @@
           <p:cNvPr id="2" name="title-rule">
             <a:extLst xmlns:a="http://schemas.openxmlformats.org/drawingml/2006/main">
               <a:ext uri="{FF2B5EF4-FFF2-40B4-BE49-F238E27FC236}">
-                <a16:creationId xmlns:a16="http://schemas.microsoft.com/office/drawing/2014/main" id="{35C59B2B-8642-4ABE-88AE-29394A06E42D}"/>
+                <a16:creationId xmlns:a16="http://schemas.microsoft.com/office/drawing/2014/main" id="{5641C039-D37E-40A1-B480-876D050531F8}"/>
               </a:ext>
             </a:extLst>
           </p:cNvPr>
@@ -4802,7 +4793,7 @@
         </p:xfrm>
         <a:graphic xmlns:a="http://schemas.openxmlformats.org/drawingml/2006/main">
           <a:graphicData uri="http://schemas.openxmlformats.org/drawingml/2006/chart">
-            <c:chart xmlns:r="http://schemas.openxmlformats.org/officeDocument/2006/relationships" xmlns:c="http://schemas.openxmlformats.org/drawingml/2006/chart" r:id="R3faeffabb39c467f"/>
+            <c:chart xmlns:r="http://schemas.openxmlformats.org/officeDocument/2006/relationships" xmlns:c="http://schemas.openxmlformats.org/drawingml/2006/chart" r:id="R5cb10ea5043740d3"/>
           </a:graphicData>
         </a:graphic>
       </p:graphicFrame>
@@ -4811,7 +4802,7 @@
           <p:cNvPr id="4" name="">
             <a:extLst xmlns:a="http://schemas.openxmlformats.org/drawingml/2006/main">
               <a:ext uri="{FF2B5EF4-FFF2-40B4-BE49-F238E27FC236}">
-                <a16:creationId xmlns:a16="http://schemas.microsoft.com/office/drawing/2014/main" id="{55D2D736-8197-4AF9-B658-B7E1E3227541}"/>
+                <a16:creationId xmlns:a16="http://schemas.microsoft.com/office/drawing/2014/main" id="{CCD13FC6-4C93-4F91-B53F-0B096A08FAB9}"/>
               </a:ext>
             </a:extLst>
           </p:cNvPr>
@@ -4842,7 +4833,7 @@
           <p:cNvPr id="5" name="">
             <a:extLst xmlns:a="http://schemas.openxmlformats.org/drawingml/2006/main">
               <a:ext uri="{FF2B5EF4-FFF2-40B4-BE49-F238E27FC236}">
-                <a16:creationId xmlns:a16="http://schemas.microsoft.com/office/drawing/2014/main" id="{D3D91CE0-E016-4470-9F40-8E938F0783C0}"/>
+                <a16:creationId xmlns:a16="http://schemas.microsoft.com/office/drawing/2014/main" id="{B034C421-9513-426D-AA41-7A0F118C789D}"/>
               </a:ext>
             </a:extLst>
           </p:cNvPr>
@@ -4875,7 +4866,7 @@
           <p:cNvPr id="6" name="">
             <a:extLst xmlns:a="http://schemas.openxmlformats.org/drawingml/2006/main">
               <a:ext uri="{FF2B5EF4-FFF2-40B4-BE49-F238E27FC236}">
-                <a16:creationId xmlns:a16="http://schemas.microsoft.com/office/drawing/2014/main" id="{F5E0E46F-6867-4C19-A38F-1123DB243107}"/>
+                <a16:creationId xmlns:a16="http://schemas.microsoft.com/office/drawing/2014/main" id="{C6CECD0A-FA2A-4B74-AEFF-15659BB4FA26}"/>
               </a:ext>
             </a:extLst>
           </p:cNvPr>
@@ -4925,7 +4916,7 @@
           <p:cNvPr id="7" name="">
             <a:extLst xmlns:a="http://schemas.openxmlformats.org/drawingml/2006/main">
               <a:ext uri="{FF2B5EF4-FFF2-40B4-BE49-F238E27FC236}">
-                <a16:creationId xmlns:a16="http://schemas.microsoft.com/office/drawing/2014/main" id="{775A31E6-DF1A-4D0F-9B18-6E497E6D58FB}"/>
+                <a16:creationId xmlns:a16="http://schemas.microsoft.com/office/drawing/2014/main" id="{E6C54B45-0C66-42FB-BEFB-A5682DBDD557}"/>
               </a:ext>
             </a:extLst>
           </p:cNvPr>
@@ -4975,7 +4966,7 @@
           <p:cNvPr id="8" name="">
             <a:extLst xmlns:a="http://schemas.openxmlformats.org/drawingml/2006/main">
               <a:ext uri="{FF2B5EF4-FFF2-40B4-BE49-F238E27FC236}">
-                <a16:creationId xmlns:a16="http://schemas.microsoft.com/office/drawing/2014/main" id="{C2EF52C9-70B0-41CF-B8EE-1074A42D1827}"/>
+                <a16:creationId xmlns:a16="http://schemas.microsoft.com/office/drawing/2014/main" id="{30FF59F0-3FB0-482E-A615-19D6E164054A}"/>
               </a:ext>
             </a:extLst>
           </p:cNvPr>
@@ -5025,7 +5016,7 @@
           <p:cNvPr id="9" name="">
             <a:extLst xmlns:a="http://schemas.openxmlformats.org/drawingml/2006/main">
               <a:ext uri="{FF2B5EF4-FFF2-40B4-BE49-F238E27FC236}">
-                <a16:creationId xmlns:a16="http://schemas.microsoft.com/office/drawing/2014/main" id="{20DEB7FB-D55B-4E3D-903E-7B24B0054545}"/>
+                <a16:creationId xmlns:a16="http://schemas.microsoft.com/office/drawing/2014/main" id="{84A8F2E2-B9E5-4E32-A4F0-6B778F11A15F}"/>
               </a:ext>
             </a:extLst>
           </p:cNvPr>
@@ -5056,7 +5047,7 @@
           <p:cNvPr id="10" name="">
             <a:extLst xmlns:a="http://schemas.openxmlformats.org/drawingml/2006/main">
               <a:ext uri="{FF2B5EF4-FFF2-40B4-BE49-F238E27FC236}">
-                <a16:creationId xmlns:a16="http://schemas.microsoft.com/office/drawing/2014/main" id="{023B1B7A-5D38-4EF6-BCF7-C20BBFEC1800}"/>
+                <a16:creationId xmlns:a16="http://schemas.microsoft.com/office/drawing/2014/main" id="{D9B2961D-0A0B-4FB9-A254-1477E541F288}"/>
               </a:ext>
             </a:extLst>
           </p:cNvPr>
@@ -5089,7 +5080,7 @@
           <p:cNvPr id="11" name="">
             <a:extLst xmlns:a="http://schemas.openxmlformats.org/drawingml/2006/main">
               <a:ext uri="{FF2B5EF4-FFF2-40B4-BE49-F238E27FC236}">
-                <a16:creationId xmlns:a16="http://schemas.microsoft.com/office/drawing/2014/main" id="{3AB9A7E0-D094-4D06-97CB-9AAACCE6DBD5}"/>
+                <a16:creationId xmlns:a16="http://schemas.microsoft.com/office/drawing/2014/main" id="{8A4D2654-04AF-46B2-A347-E2CFC4DF26C7}"/>
               </a:ext>
             </a:extLst>
           </p:cNvPr>
@@ -5139,7 +5130,7 @@
           <p:cNvPr id="12" name="">
             <a:extLst xmlns:a="http://schemas.openxmlformats.org/drawingml/2006/main">
               <a:ext uri="{FF2B5EF4-FFF2-40B4-BE49-F238E27FC236}">
-                <a16:creationId xmlns:a16="http://schemas.microsoft.com/office/drawing/2014/main" id="{18AF3EE2-45AC-40B5-B707-EBF2697DE3B0}"/>
+                <a16:creationId xmlns:a16="http://schemas.microsoft.com/office/drawing/2014/main" id="{8A68C99E-7653-4263-9BF0-D1DCCBAEB8B2}"/>
               </a:ext>
             </a:extLst>
           </p:cNvPr>
@@ -5189,7 +5180,7 @@
           <p:cNvPr id="13" name="">
             <a:extLst xmlns:a="http://schemas.openxmlformats.org/drawingml/2006/main">
               <a:ext uri="{FF2B5EF4-FFF2-40B4-BE49-F238E27FC236}">
-                <a16:creationId xmlns:a16="http://schemas.microsoft.com/office/drawing/2014/main" id="{25CA4A91-3396-4CAF-B8ED-D66150735DFF}"/>
+                <a16:creationId xmlns:a16="http://schemas.microsoft.com/office/drawing/2014/main" id="{89BE287F-97D4-4F53-9D6C-E168EFF44529}"/>
               </a:ext>
             </a:extLst>
           </p:cNvPr>
@@ -5239,7 +5230,7 @@
           <p:cNvPr id="14" name="">
             <a:extLst xmlns:a="http://schemas.openxmlformats.org/drawingml/2006/main">
               <a:ext uri="{FF2B5EF4-FFF2-40B4-BE49-F238E27FC236}">
-                <a16:creationId xmlns:a16="http://schemas.microsoft.com/office/drawing/2014/main" id="{95705421-B792-438E-AC18-1C0FE393B1C3}"/>
+                <a16:creationId xmlns:a16="http://schemas.microsoft.com/office/drawing/2014/main" id="{CFFB7240-1CFA-4A8E-A38C-13B025A2A642}"/>
               </a:ext>
             </a:extLst>
           </p:cNvPr>
@@ -5270,7 +5261,7 @@
           <p:cNvPr id="15" name="">
             <a:extLst xmlns:a="http://schemas.openxmlformats.org/drawingml/2006/main">
               <a:ext uri="{FF2B5EF4-FFF2-40B4-BE49-F238E27FC236}">
-                <a16:creationId xmlns:a16="http://schemas.microsoft.com/office/drawing/2014/main" id="{DF123203-E6B1-4B9B-AFA1-2E7D78FA9E34}"/>
+                <a16:creationId xmlns:a16="http://schemas.microsoft.com/office/drawing/2014/main" id="{F302BD4C-7315-49B4-AAEE-778AFA832812}"/>
               </a:ext>
             </a:extLst>
           </p:cNvPr>
@@ -5303,7 +5294,7 @@
           <p:cNvPr id="16" name="">
             <a:extLst xmlns:a="http://schemas.openxmlformats.org/drawingml/2006/main">
               <a:ext uri="{FF2B5EF4-FFF2-40B4-BE49-F238E27FC236}">
-                <a16:creationId xmlns:a16="http://schemas.microsoft.com/office/drawing/2014/main" id="{0B60B361-7C93-4989-A6BE-260764D9903B}"/>
+                <a16:creationId xmlns:a16="http://schemas.microsoft.com/office/drawing/2014/main" id="{CE39FB11-B55E-4FAE-9CBE-75F40DD4C008}"/>
               </a:ext>
             </a:extLst>
           </p:cNvPr>
@@ -5353,7 +5344,7 @@
           <p:cNvPr id="17" name="">
             <a:extLst xmlns:a="http://schemas.openxmlformats.org/drawingml/2006/main">
               <a:ext uri="{FF2B5EF4-FFF2-40B4-BE49-F238E27FC236}">
-                <a16:creationId xmlns:a16="http://schemas.microsoft.com/office/drawing/2014/main" id="{A0F79F90-6555-4770-974B-1FC791ABE2BF}"/>
+                <a16:creationId xmlns:a16="http://schemas.microsoft.com/office/drawing/2014/main" id="{A3A87578-EB73-4446-BAAD-EACDB5F45217}"/>
               </a:ext>
             </a:extLst>
           </p:cNvPr>
@@ -5403,7 +5394,7 @@
           <p:cNvPr id="18" name="">
             <a:extLst xmlns:a="http://schemas.openxmlformats.org/drawingml/2006/main">
               <a:ext uri="{FF2B5EF4-FFF2-40B4-BE49-F238E27FC236}">
-                <a16:creationId xmlns:a16="http://schemas.microsoft.com/office/drawing/2014/main" id="{AE0056FE-008A-4E4D-91F3-65E88308AB82}"/>
+                <a16:creationId xmlns:a16="http://schemas.microsoft.com/office/drawing/2014/main" id="{CC0C7822-1227-4220-B60E-10144D69FF4E}"/>
               </a:ext>
             </a:extLst>
           </p:cNvPr>
@@ -5453,7 +5444,7 @@
           <p:cNvPr id="19" name="source-footer">
             <a:extLst xmlns:a="http://schemas.openxmlformats.org/drawingml/2006/main">
               <a:ext uri="{FF2B5EF4-FFF2-40B4-BE49-F238E27FC236}">
-                <a16:creationId xmlns:a16="http://schemas.microsoft.com/office/drawing/2014/main" id="{B91D36DB-4C56-4F15-AA1B-711EBA8A4102}"/>
+                <a16:creationId xmlns:a16="http://schemas.microsoft.com/office/drawing/2014/main" id="{F623165D-EE2B-4951-8B94-A58B6DE5C933}"/>
               </a:ext>
             </a:extLst>
           </p:cNvPr>
@@ -5503,7 +5494,7 @@
           <p:cNvPr id="20" name="slide-number">
             <a:extLst xmlns:a="http://schemas.openxmlformats.org/drawingml/2006/main">
               <a:ext uri="{FF2B5EF4-FFF2-40B4-BE49-F238E27FC236}">
-                <a16:creationId xmlns:a16="http://schemas.microsoft.com/office/drawing/2014/main" id="{D6A07598-C804-4568-89D9-821F8530E15D}"/>
+                <a16:creationId xmlns:a16="http://schemas.microsoft.com/office/drawing/2014/main" id="{B461DDF3-D464-4F4C-B351-F8016BD62DA0}"/>
               </a:ext>
             </a:extLst>
           </p:cNvPr>
@@ -5551,7 +5542,7 @@
     </p:spTree>
     <p:extLst>
       <p:ext uri="{BB962C8B-B14F-4D97-AF65-F5344CB8AC3E}">
-        <p14:creationId xmlns:p14="http://schemas.microsoft.com/office/powerpoint/2010/main" val="1965348886"/>
+        <p14:creationId xmlns:p14="http://schemas.microsoft.com/office/powerpoint/2010/main" val="1770653683"/>
       </p:ext>
     </p:extLst>
   </p:cSld>
@@ -5582,7 +5573,7 @@
           <p:cNvPr id="21" name="slide-title">
             <a:extLst xmlns:a="http://schemas.openxmlformats.org/drawingml/2006/main">
               <a:ext uri="{FF2B5EF4-FFF2-40B4-BE49-F238E27FC236}">
-                <a16:creationId xmlns:a16="http://schemas.microsoft.com/office/drawing/2014/main" id="{9156B46F-8CCC-48B9-9758-6831E499B230}"/>
+                <a16:creationId xmlns:a16="http://schemas.microsoft.com/office/drawing/2014/main" id="{07BD6A91-9968-4421-A7A1-11D1C5E543C6}"/>
               </a:ext>
             </a:extLst>
           </p:cNvPr>
@@ -5632,7 +5623,7 @@
           <p:cNvPr id="2" name="title-rule">
             <a:extLst xmlns:a="http://schemas.openxmlformats.org/drawingml/2006/main">
               <a:ext uri="{FF2B5EF4-FFF2-40B4-BE49-F238E27FC236}">
-                <a16:creationId xmlns:a16="http://schemas.microsoft.com/office/drawing/2014/main" id="{6E0B0AF2-6D63-478A-A57B-6676C00023FB}"/>
+                <a16:creationId xmlns:a16="http://schemas.microsoft.com/office/drawing/2014/main" id="{2F93BABF-1600-497A-9404-031CD623AB29}"/>
               </a:ext>
             </a:extLst>
           </p:cNvPr>
@@ -5663,7 +5654,7 @@
           <p:cNvPr id="3" name="">
             <a:extLst xmlns:a="http://schemas.openxmlformats.org/drawingml/2006/main">
               <a:ext uri="{FF2B5EF4-FFF2-40B4-BE49-F238E27FC236}">
-                <a16:creationId xmlns:a16="http://schemas.microsoft.com/office/drawing/2014/main" id="{ADF8F3F5-BF78-4401-BFF8-3271DE349920}"/>
+                <a16:creationId xmlns:a16="http://schemas.microsoft.com/office/drawing/2014/main" id="{5E972AB0-2E7E-45D4-9811-415ADE57B6DD}"/>
               </a:ext>
             </a:extLst>
           </p:cNvPr>
@@ -5694,7 +5685,7 @@
           <p:cNvPr id="4" name="">
             <a:extLst xmlns:a="http://schemas.openxmlformats.org/drawingml/2006/main">
               <a:ext uri="{FF2B5EF4-FFF2-40B4-BE49-F238E27FC236}">
-                <a16:creationId xmlns:a16="http://schemas.microsoft.com/office/drawing/2014/main" id="{8F432411-0D2D-4CF5-A6E3-282EA2C15618}"/>
+                <a16:creationId xmlns:a16="http://schemas.microsoft.com/office/drawing/2014/main" id="{E027C280-EA8D-4462-8428-AFA2406E1819}"/>
               </a:ext>
             </a:extLst>
           </p:cNvPr>
@@ -5744,7 +5735,7 @@
           <p:cNvPr id="5" name="">
             <a:extLst xmlns:a="http://schemas.openxmlformats.org/drawingml/2006/main">
               <a:ext uri="{FF2B5EF4-FFF2-40B4-BE49-F238E27FC236}">
-                <a16:creationId xmlns:a16="http://schemas.microsoft.com/office/drawing/2014/main" id="{66C2A8E7-B8A2-48A9-9B10-40B949B89D14}"/>
+                <a16:creationId xmlns:a16="http://schemas.microsoft.com/office/drawing/2014/main" id="{E18064B5-2278-40E2-BBA9-2937D8E713DD}"/>
               </a:ext>
             </a:extLst>
           </p:cNvPr>
@@ -5794,7 +5785,7 @@
           <p:cNvPr id="6" name="">
             <a:extLst xmlns:a="http://schemas.openxmlformats.org/drawingml/2006/main">
               <a:ext uri="{FF2B5EF4-FFF2-40B4-BE49-F238E27FC236}">
-                <a16:creationId xmlns:a16="http://schemas.microsoft.com/office/drawing/2014/main" id="{6DB672CB-3A9F-47EE-83E2-EB450886E377}"/>
+                <a16:creationId xmlns:a16="http://schemas.microsoft.com/office/drawing/2014/main" id="{24D60E30-CDD7-4D42-8F10-D691F7B9C30F}"/>
               </a:ext>
             </a:extLst>
           </p:cNvPr>
@@ -5844,7 +5835,7 @@
           <p:cNvPr id="7" name="">
             <a:extLst xmlns:a="http://schemas.openxmlformats.org/drawingml/2006/main">
               <a:ext uri="{FF2B5EF4-FFF2-40B4-BE49-F238E27FC236}">
-                <a16:creationId xmlns:a16="http://schemas.microsoft.com/office/drawing/2014/main" id="{1DACCEBE-9EE8-416E-838B-F973B565D60D}"/>
+                <a16:creationId xmlns:a16="http://schemas.microsoft.com/office/drawing/2014/main" id="{DE0F1581-2BC9-4E7D-A26B-5418B243C5C2}"/>
               </a:ext>
             </a:extLst>
           </p:cNvPr>
@@ -5875,7 +5866,7 @@
           <p:cNvPr id="8" name="">
             <a:extLst xmlns:a="http://schemas.openxmlformats.org/drawingml/2006/main">
               <a:ext uri="{FF2B5EF4-FFF2-40B4-BE49-F238E27FC236}">
-                <a16:creationId xmlns:a16="http://schemas.microsoft.com/office/drawing/2014/main" id="{EA817165-3B6F-43EF-81B3-F945A5C620B2}"/>
+                <a16:creationId xmlns:a16="http://schemas.microsoft.com/office/drawing/2014/main" id="{A302FBB5-4111-4986-B4E9-13DACA18BAEA}"/>
               </a:ext>
             </a:extLst>
           </p:cNvPr>
@@ -5925,7 +5916,7 @@
           <p:cNvPr id="9" name="">
             <a:extLst xmlns:a="http://schemas.openxmlformats.org/drawingml/2006/main">
               <a:ext uri="{FF2B5EF4-FFF2-40B4-BE49-F238E27FC236}">
-                <a16:creationId xmlns:a16="http://schemas.microsoft.com/office/drawing/2014/main" id="{6798B360-0C3E-48B7-8151-9F5934BCDE22}"/>
+                <a16:creationId xmlns:a16="http://schemas.microsoft.com/office/drawing/2014/main" id="{5C5E8557-A5E6-4468-BAB6-84F1A1FE86FF}"/>
               </a:ext>
             </a:extLst>
           </p:cNvPr>
@@ -5975,7 +5966,7 @@
           <p:cNvPr id="10" name="">
             <a:extLst xmlns:a="http://schemas.openxmlformats.org/drawingml/2006/main">
               <a:ext uri="{FF2B5EF4-FFF2-40B4-BE49-F238E27FC236}">
-                <a16:creationId xmlns:a16="http://schemas.microsoft.com/office/drawing/2014/main" id="{B32FA527-5D12-4F7D-AB10-73C27E6D455A}"/>
+                <a16:creationId xmlns:a16="http://schemas.microsoft.com/office/drawing/2014/main" id="{A78069EA-CAA3-477B-AFA4-971452831277}"/>
               </a:ext>
             </a:extLst>
           </p:cNvPr>
@@ -6025,7 +6016,7 @@
           <p:cNvPr id="11" name="">
             <a:extLst xmlns:a="http://schemas.openxmlformats.org/drawingml/2006/main">
               <a:ext uri="{FF2B5EF4-FFF2-40B4-BE49-F238E27FC236}">
-                <a16:creationId xmlns:a16="http://schemas.microsoft.com/office/drawing/2014/main" id="{047D05F4-AC2D-4378-9E6E-D3B39836E764}"/>
+                <a16:creationId xmlns:a16="http://schemas.microsoft.com/office/drawing/2014/main" id="{BA3A6B92-E082-4F6B-AFAE-F24304929BC3}"/>
               </a:ext>
             </a:extLst>
           </p:cNvPr>
@@ -6056,7 +6047,7 @@
           <p:cNvPr id="12" name="">
             <a:extLst xmlns:a="http://schemas.openxmlformats.org/drawingml/2006/main">
               <a:ext uri="{FF2B5EF4-FFF2-40B4-BE49-F238E27FC236}">
-                <a16:creationId xmlns:a16="http://schemas.microsoft.com/office/drawing/2014/main" id="{B4D6B43D-6EEC-4FAF-B5BD-EAB0291C5A17}"/>
+                <a16:creationId xmlns:a16="http://schemas.microsoft.com/office/drawing/2014/main" id="{8652DF04-A7C8-4416-866C-B3DFF5DED80D}"/>
               </a:ext>
             </a:extLst>
           </p:cNvPr>
@@ -6106,7 +6097,7 @@
           <p:cNvPr id="13" name="">
             <a:extLst xmlns:a="http://schemas.openxmlformats.org/drawingml/2006/main">
               <a:ext uri="{FF2B5EF4-FFF2-40B4-BE49-F238E27FC236}">
-                <a16:creationId xmlns:a16="http://schemas.microsoft.com/office/drawing/2014/main" id="{3E6F20B6-5B29-40D1-8519-504ACFA551DE}"/>
+                <a16:creationId xmlns:a16="http://schemas.microsoft.com/office/drawing/2014/main" id="{528DE832-83B4-4053-BFF7-DB160EAA4D18}"/>
               </a:ext>
             </a:extLst>
           </p:cNvPr>
@@ -6156,7 +6147,7 @@
           <p:cNvPr id="14" name="">
             <a:extLst xmlns:a="http://schemas.openxmlformats.org/drawingml/2006/main">
               <a:ext uri="{FF2B5EF4-FFF2-40B4-BE49-F238E27FC236}">
-                <a16:creationId xmlns:a16="http://schemas.microsoft.com/office/drawing/2014/main" id="{992D484C-023A-43A6-90D3-6D70FB9AD972}"/>
+                <a16:creationId xmlns:a16="http://schemas.microsoft.com/office/drawing/2014/main" id="{7893B542-8DF7-4F0C-89B1-0B591872E6F7}"/>
               </a:ext>
             </a:extLst>
           </p:cNvPr>
@@ -6206,7 +6197,7 @@
           <p:cNvPr id="15" name="">
             <a:extLst xmlns:a="http://schemas.openxmlformats.org/drawingml/2006/main">
               <a:ext uri="{FF2B5EF4-FFF2-40B4-BE49-F238E27FC236}">
-                <a16:creationId xmlns:a16="http://schemas.microsoft.com/office/drawing/2014/main" id="{69ECC80C-89F6-47CD-88BD-216D957C7B9A}"/>
+                <a16:creationId xmlns:a16="http://schemas.microsoft.com/office/drawing/2014/main" id="{C831A912-4238-41B0-9612-D4C4D8CA1C97}"/>
               </a:ext>
             </a:extLst>
           </p:cNvPr>
@@ -6237,7 +6228,7 @@
           <p:cNvPr id="16" name="">
             <a:extLst xmlns:a="http://schemas.openxmlformats.org/drawingml/2006/main">
               <a:ext uri="{FF2B5EF4-FFF2-40B4-BE49-F238E27FC236}">
-                <a16:creationId xmlns:a16="http://schemas.microsoft.com/office/drawing/2014/main" id="{E290A2ED-B0E1-4842-9C45-615D82606700}"/>
+                <a16:creationId xmlns:a16="http://schemas.microsoft.com/office/drawing/2014/main" id="{A85CCBCF-32C1-4C54-863B-1E2622863723}"/>
               </a:ext>
             </a:extLst>
           </p:cNvPr>
@@ -6287,7 +6278,7 @@
           <p:cNvPr id="17" name="">
             <a:extLst xmlns:a="http://schemas.openxmlformats.org/drawingml/2006/main">
               <a:ext uri="{FF2B5EF4-FFF2-40B4-BE49-F238E27FC236}">
-                <a16:creationId xmlns:a16="http://schemas.microsoft.com/office/drawing/2014/main" id="{AC58B7A3-1C57-4C57-B8D8-54FDC15DB0F7}"/>
+                <a16:creationId xmlns:a16="http://schemas.microsoft.com/office/drawing/2014/main" id="{39054799-64A0-429A-BEB4-BFA0FAE9FC82}"/>
               </a:ext>
             </a:extLst>
           </p:cNvPr>
@@ -6337,19 +6328,19 @@
           <p:cNvPr id="18" name="">
             <a:extLst xmlns:a="http://schemas.openxmlformats.org/drawingml/2006/main">
               <a:ext uri="{FF2B5EF4-FFF2-40B4-BE49-F238E27FC236}">
-                <a16:creationId xmlns:a16="http://schemas.microsoft.com/office/drawing/2014/main" id="{54E68F01-1E66-45AC-A0BF-C2D2EBA4F11E}"/>
-              </a:ext>
-            </a:extLst>
-          </p:cNvPr>
-          <p:cNvSpPr>
-            <a:spLocks xmlns:a="http://schemas.openxmlformats.org/drawingml/2006/main" noGrp="1"/>
-          </p:cNvSpPr>
-          <p:nvPr/>
-        </p:nvSpPr>
-        <p:spPr>
-          <a:xfrm xmlns:a="http://schemas.openxmlformats.org/drawingml/2006/main">
-            <a:off x="495300" y="5314950"/>
-            <a:ext cx="9048750" cy="381000"/>
+                <a16:creationId xmlns:a16="http://schemas.microsoft.com/office/drawing/2014/main" id="{2719D0B3-3E3E-4F30-A239-6BDF14C6B1FC}"/>
+              </a:ext>
+            </a:extLst>
+          </p:cNvPr>
+          <p:cNvSpPr>
+            <a:spLocks xmlns:a="http://schemas.openxmlformats.org/drawingml/2006/main" noGrp="1"/>
+          </p:cNvSpPr>
+          <p:nvPr/>
+        </p:nvSpPr>
+        <p:spPr>
+          <a:xfrm xmlns:a="http://schemas.openxmlformats.org/drawingml/2006/main">
+            <a:off x="495300" y="5219700"/>
+            <a:ext cx="10668000" cy="590550"/>
           </a:xfrm>
           <a:prstGeom xmlns:a="http://schemas.openxmlformats.org/drawingml/2006/main" prst="rect">
             <a:avLst/>
@@ -6377,7 +6368,7 @@
                   <a:srgbClr val="111111"/>
                 </a:solidFill>
               </a:rPr>
-              <a:t>Leakage control: risk thresholds are learned from training data only.</a:t>
+              <a:t>Leakage control: threshold and outlier parameters use training data only; five sessions are embargoed.</a:t>
             </a:r>
           </a:p>
         </p:txBody>
@@ -6387,7 +6378,7 @@
           <p:cNvPr id="19" name="source-footer">
             <a:extLst xmlns:a="http://schemas.openxmlformats.org/drawingml/2006/main">
               <a:ext uri="{FF2B5EF4-FFF2-40B4-BE49-F238E27FC236}">
-                <a16:creationId xmlns:a16="http://schemas.microsoft.com/office/drawing/2014/main" id="{2700E97E-7481-41C8-8B9B-EE1753ECAF26}"/>
+                <a16:creationId xmlns:a16="http://schemas.microsoft.com/office/drawing/2014/main" id="{D7505769-64D6-4D81-93DA-78A354028490}"/>
               </a:ext>
             </a:extLst>
           </p:cNvPr>
@@ -6427,7 +6418,7 @@
                   <a:srgbClr val="5F6368"/>
                 </a:solidFill>
               </a:rPr>
-              <a:t>Method: five-day horizon, lagged/rolling features, chronological 80/20 split</a:t>
+              <a:t>Method: five-session horizon, trailing features, purged chronological 80/20 split</a:t>
             </a:r>
           </a:p>
         </p:txBody>
@@ -6437,7 +6428,7 @@
           <p:cNvPr id="20" name="slide-number">
             <a:extLst xmlns:a="http://schemas.openxmlformats.org/drawingml/2006/main">
               <a:ext uri="{FF2B5EF4-FFF2-40B4-BE49-F238E27FC236}">
-                <a16:creationId xmlns:a16="http://schemas.microsoft.com/office/drawing/2014/main" id="{61DDA153-F989-4784-B748-8AF564D9F008}"/>
+                <a16:creationId xmlns:a16="http://schemas.microsoft.com/office/drawing/2014/main" id="{A2C1A6F4-4111-4448-A57A-7B30310A7343}"/>
               </a:ext>
             </a:extLst>
           </p:cNvPr>
@@ -6485,7 +6476,7 @@
     </p:spTree>
     <p:extLst>
       <p:ext uri="{BB962C8B-B14F-4D97-AF65-F5344CB8AC3E}">
-        <p14:creationId xmlns:p14="http://schemas.microsoft.com/office/powerpoint/2010/main" val="1417643449"/>
+        <p14:creationId xmlns:p14="http://schemas.microsoft.com/office/powerpoint/2010/main" val="1242598328"/>
       </p:ext>
     </p:extLst>
   </p:cSld>
@@ -6516,7 +6507,7 @@
           <p:cNvPr id="22" name="slide-title">
             <a:extLst xmlns:a="http://schemas.openxmlformats.org/drawingml/2006/main">
               <a:ext uri="{FF2B5EF4-FFF2-40B4-BE49-F238E27FC236}">
-                <a16:creationId xmlns:a16="http://schemas.microsoft.com/office/drawing/2014/main" id="{D27C3676-D6DF-48EC-BB59-088C6514183C}"/>
+                <a16:creationId xmlns:a16="http://schemas.microsoft.com/office/drawing/2014/main" id="{40FD57EE-F292-46C6-9873-84048C22492D}"/>
               </a:ext>
             </a:extLst>
           </p:cNvPr>
@@ -6556,7 +6547,7 @@
                   <a:srgbClr val="111111"/>
                 </a:solidFill>
               </a:rPr>
-              <a:t>Ridge cut forecast MAE by 20.7% versus recent volatility</a:t>
+              <a:t>Ridge cut forecast MAE by 20.8% versus recent volatility</a:t>
             </a:r>
           </a:p>
         </p:txBody>
@@ -6566,7 +6557,7 @@
           <p:cNvPr id="2" name="title-rule">
             <a:extLst xmlns:a="http://schemas.openxmlformats.org/drawingml/2006/main">
               <a:ext uri="{FF2B5EF4-FFF2-40B4-BE49-F238E27FC236}">
-                <a16:creationId xmlns:a16="http://schemas.microsoft.com/office/drawing/2014/main" id="{F6A58A47-7BF5-4784-BBE1-B4BCA045BC9F}"/>
+                <a16:creationId xmlns:a16="http://schemas.microsoft.com/office/drawing/2014/main" id="{67F766FD-086D-45BE-8382-655AB8F17559}"/>
               </a:ext>
             </a:extLst>
           </p:cNvPr>
@@ -6597,7 +6588,7 @@
           <p:cNvPr id="3" name="">
             <a:extLst xmlns:a="http://schemas.openxmlformats.org/drawingml/2006/main">
               <a:ext uri="{FF2B5EF4-FFF2-40B4-BE49-F238E27FC236}">
-                <a16:creationId xmlns:a16="http://schemas.microsoft.com/office/drawing/2014/main" id="{3D71B1CC-D33F-425F-B15A-79F6C7DC575D}"/>
+                <a16:creationId xmlns:a16="http://schemas.microsoft.com/office/drawing/2014/main" id="{A3BEFECF-4060-4F95-B23A-0A2D9985B2C3}"/>
               </a:ext>
             </a:extLst>
           </p:cNvPr>
@@ -6654,7 +6645,7 @@
         </p:xfrm>
         <a:graphic xmlns:a="http://schemas.openxmlformats.org/drawingml/2006/main">
           <a:graphicData uri="http://schemas.openxmlformats.org/drawingml/2006/chart">
-            <c:chart xmlns:r="http://schemas.openxmlformats.org/officeDocument/2006/relationships" xmlns:c="http://schemas.openxmlformats.org/drawingml/2006/chart" r:id="Rdaf766897ff741ac"/>
+            <c:chart xmlns:r="http://schemas.openxmlformats.org/officeDocument/2006/relationships" xmlns:c="http://schemas.openxmlformats.org/drawingml/2006/chart" r:id="Rab9e56160a004b53"/>
           </a:graphicData>
         </a:graphic>
       </p:graphicFrame>
@@ -6663,7 +6654,7 @@
           <p:cNvPr id="5" name="">
             <a:extLst xmlns:a="http://schemas.openxmlformats.org/drawingml/2006/main">
               <a:ext uri="{FF2B5EF4-FFF2-40B4-BE49-F238E27FC236}">
-                <a16:creationId xmlns:a16="http://schemas.microsoft.com/office/drawing/2014/main" id="{2A298943-FF4D-4EE9-987E-CF76582E3459}"/>
+                <a16:creationId xmlns:a16="http://schemas.microsoft.com/office/drawing/2014/main" id="{5760FB9B-572C-4C10-B6CB-D4189A62B618}"/>
               </a:ext>
             </a:extLst>
           </p:cNvPr>
@@ -6694,7 +6685,7 @@
           <p:cNvPr id="6" name="">
             <a:extLst xmlns:a="http://schemas.openxmlformats.org/drawingml/2006/main">
               <a:ext uri="{FF2B5EF4-FFF2-40B4-BE49-F238E27FC236}">
-                <a16:creationId xmlns:a16="http://schemas.microsoft.com/office/drawing/2014/main" id="{1A7D67D2-8A37-42B6-A8D3-089DDC956E0E}"/>
+                <a16:creationId xmlns:a16="http://schemas.microsoft.com/office/drawing/2014/main" id="{156AA36A-14BB-43E7-BEA8-BA686DC8D9E8}"/>
               </a:ext>
             </a:extLst>
           </p:cNvPr>
@@ -6727,7 +6718,7 @@
           <p:cNvPr id="7" name="">
             <a:extLst xmlns:a="http://schemas.openxmlformats.org/drawingml/2006/main">
               <a:ext uri="{FF2B5EF4-FFF2-40B4-BE49-F238E27FC236}">
-                <a16:creationId xmlns:a16="http://schemas.microsoft.com/office/drawing/2014/main" id="{88BCA1EC-82DE-4547-A03D-F02E194786F6}"/>
+                <a16:creationId xmlns:a16="http://schemas.microsoft.com/office/drawing/2014/main" id="{62F406A6-D075-4C31-B993-D1BFBD601FAF}"/>
               </a:ext>
             </a:extLst>
           </p:cNvPr>
@@ -6767,7 +6758,7 @@
                   <a:srgbClr val="111111"/>
                 </a:solidFill>
               </a:rPr>
-              <a:t>0.0402</a:t>
+              <a:t>4.02 pp</a:t>
             </a:r>
           </a:p>
         </p:txBody>
@@ -6777,7 +6768,7 @@
           <p:cNvPr id="8" name="">
             <a:extLst xmlns:a="http://schemas.openxmlformats.org/drawingml/2006/main">
               <a:ext uri="{FF2B5EF4-FFF2-40B4-BE49-F238E27FC236}">
-                <a16:creationId xmlns:a16="http://schemas.microsoft.com/office/drawing/2014/main" id="{DAFE8C7C-3B7F-4E75-8B13-00D12B10CCCA}"/>
+                <a16:creationId xmlns:a16="http://schemas.microsoft.com/office/drawing/2014/main" id="{893AAE1B-A713-4B00-8F2B-7933F44B3F75}"/>
               </a:ext>
             </a:extLst>
           </p:cNvPr>
@@ -6827,7 +6818,7 @@
           <p:cNvPr id="9" name="">
             <a:extLst xmlns:a="http://schemas.openxmlformats.org/drawingml/2006/main">
               <a:ext uri="{FF2B5EF4-FFF2-40B4-BE49-F238E27FC236}">
-                <a16:creationId xmlns:a16="http://schemas.microsoft.com/office/drawing/2014/main" id="{00844E4A-DD1F-4078-BF3C-92CE0DD137B0}"/>
+                <a16:creationId xmlns:a16="http://schemas.microsoft.com/office/drawing/2014/main" id="{4D046DD4-1278-4D8E-8E10-E4719ED85AFF}"/>
               </a:ext>
             </a:extLst>
           </p:cNvPr>
@@ -6867,7 +6858,7 @@
                   <a:srgbClr val="5F6368"/>
                 </a:solidFill>
               </a:rPr>
-              <a:t>Lower is better</a:t>
+              <a:t>Annualized-vol error</a:t>
             </a:r>
           </a:p>
         </p:txBody>
@@ -6877,7 +6868,7 @@
           <p:cNvPr id="10" name="">
             <a:extLst xmlns:a="http://schemas.openxmlformats.org/drawingml/2006/main">
               <a:ext uri="{FF2B5EF4-FFF2-40B4-BE49-F238E27FC236}">
-                <a16:creationId xmlns:a16="http://schemas.microsoft.com/office/drawing/2014/main" id="{03A45AED-85EA-43A7-A410-168CA69D0B67}"/>
+                <a16:creationId xmlns:a16="http://schemas.microsoft.com/office/drawing/2014/main" id="{F82A7F0A-BB39-4F42-83B7-CD434E5279D9}"/>
               </a:ext>
             </a:extLst>
           </p:cNvPr>
@@ -6908,7 +6899,7 @@
           <p:cNvPr id="11" name="">
             <a:extLst xmlns:a="http://schemas.openxmlformats.org/drawingml/2006/main">
               <a:ext uri="{FF2B5EF4-FFF2-40B4-BE49-F238E27FC236}">
-                <a16:creationId xmlns:a16="http://schemas.microsoft.com/office/drawing/2014/main" id="{A52B5E02-0B28-4A16-8DEA-01D8C4CDB3F7}"/>
+                <a16:creationId xmlns:a16="http://schemas.microsoft.com/office/drawing/2014/main" id="{89CB5994-464B-4A16-9F2C-CB92ED5C3D67}"/>
               </a:ext>
             </a:extLst>
           </p:cNvPr>
@@ -6941,7 +6932,7 @@
           <p:cNvPr id="12" name="">
             <a:extLst xmlns:a="http://schemas.openxmlformats.org/drawingml/2006/main">
               <a:ext uri="{FF2B5EF4-FFF2-40B4-BE49-F238E27FC236}">
-                <a16:creationId xmlns:a16="http://schemas.microsoft.com/office/drawing/2014/main" id="{5EC1CC6B-CDCA-47BD-8266-1931B85B7DBE}"/>
+                <a16:creationId xmlns:a16="http://schemas.microsoft.com/office/drawing/2014/main" id="{01C84F19-17C9-470D-B58A-8BCEFB777683}"/>
               </a:ext>
             </a:extLst>
           </p:cNvPr>
@@ -6981,7 +6972,7 @@
                   <a:srgbClr val="111111"/>
                 </a:solidFill>
               </a:rPr>
-              <a:t>0.335</a:t>
+              <a:t>0.336</a:t>
             </a:r>
           </a:p>
         </p:txBody>
@@ -6991,7 +6982,7 @@
           <p:cNvPr id="13" name="">
             <a:extLst xmlns:a="http://schemas.openxmlformats.org/drawingml/2006/main">
               <a:ext uri="{FF2B5EF4-FFF2-40B4-BE49-F238E27FC236}">
-                <a16:creationId xmlns:a16="http://schemas.microsoft.com/office/drawing/2014/main" id="{77F41C9F-944B-444C-A071-2408712459FF}"/>
+                <a16:creationId xmlns:a16="http://schemas.microsoft.com/office/drawing/2014/main" id="{48B3F9D3-53A8-4041-9FD0-C32F71AC7D2A}"/>
               </a:ext>
             </a:extLst>
           </p:cNvPr>
@@ -7041,7 +7032,7 @@
           <p:cNvPr id="14" name="">
             <a:extLst xmlns:a="http://schemas.openxmlformats.org/drawingml/2006/main">
               <a:ext uri="{FF2B5EF4-FFF2-40B4-BE49-F238E27FC236}">
-                <a16:creationId xmlns:a16="http://schemas.microsoft.com/office/drawing/2014/main" id="{8EE4BE45-27A6-42E6-88D7-0E4A79A62718}"/>
+                <a16:creationId xmlns:a16="http://schemas.microsoft.com/office/drawing/2014/main" id="{8EDDB36E-7818-4F20-95AF-8A02F8FFFB47}"/>
               </a:ext>
             </a:extLst>
           </p:cNvPr>
@@ -7091,7 +7082,7 @@
           <p:cNvPr id="15" name="">
             <a:extLst xmlns:a="http://schemas.openxmlformats.org/drawingml/2006/main">
               <a:ext uri="{FF2B5EF4-FFF2-40B4-BE49-F238E27FC236}">
-                <a16:creationId xmlns:a16="http://schemas.microsoft.com/office/drawing/2014/main" id="{ECC23326-39CE-4FF0-9B48-1B5D1B4EC72B}"/>
+                <a16:creationId xmlns:a16="http://schemas.microsoft.com/office/drawing/2014/main" id="{17AA6A61-CB45-42D3-A23B-78863A8D65E3}"/>
               </a:ext>
             </a:extLst>
           </p:cNvPr>
@@ -7122,7 +7113,7 @@
           <p:cNvPr id="16" name="">
             <a:extLst xmlns:a="http://schemas.openxmlformats.org/drawingml/2006/main">
               <a:ext uri="{FF2B5EF4-FFF2-40B4-BE49-F238E27FC236}">
-                <a16:creationId xmlns:a16="http://schemas.microsoft.com/office/drawing/2014/main" id="{78C020AA-F527-41AC-A29A-E0E0B6FD71EA}"/>
+                <a16:creationId xmlns:a16="http://schemas.microsoft.com/office/drawing/2014/main" id="{3D9DDECE-399A-47AE-9DCA-62581D5DC049}"/>
               </a:ext>
             </a:extLst>
           </p:cNvPr>
@@ -7155,7 +7146,7 @@
           <p:cNvPr id="17" name="">
             <a:extLst xmlns:a="http://schemas.openxmlformats.org/drawingml/2006/main">
               <a:ext uri="{FF2B5EF4-FFF2-40B4-BE49-F238E27FC236}">
-                <a16:creationId xmlns:a16="http://schemas.microsoft.com/office/drawing/2014/main" id="{851597B2-1D58-4DE0-BE30-3C8110EB157F}"/>
+                <a16:creationId xmlns:a16="http://schemas.microsoft.com/office/drawing/2014/main" id="{E51051DD-D6B6-400F-B237-86A8E3269D7B}"/>
               </a:ext>
             </a:extLst>
           </p:cNvPr>
@@ -7195,7 +7186,7 @@
                   <a:srgbClr val="111111"/>
                 </a:solidFill>
               </a:rPr>
-              <a:t>20.7%</a:t>
+              <a:t>20.8%</a:t>
             </a:r>
           </a:p>
         </p:txBody>
@@ -7205,7 +7196,7 @@
           <p:cNvPr id="18" name="">
             <a:extLst xmlns:a="http://schemas.openxmlformats.org/drawingml/2006/main">
               <a:ext uri="{FF2B5EF4-FFF2-40B4-BE49-F238E27FC236}">
-                <a16:creationId xmlns:a16="http://schemas.microsoft.com/office/drawing/2014/main" id="{2E7209C2-ECB2-4E9E-9E4E-9306433CEF56}"/>
+                <a16:creationId xmlns:a16="http://schemas.microsoft.com/office/drawing/2014/main" id="{1D4AE7BB-17B4-4630-AA1B-0909696A99E6}"/>
               </a:ext>
             </a:extLst>
           </p:cNvPr>
@@ -7255,7 +7246,7 @@
           <p:cNvPr id="19" name="">
             <a:extLst xmlns:a="http://schemas.openxmlformats.org/drawingml/2006/main">
               <a:ext uri="{FF2B5EF4-FFF2-40B4-BE49-F238E27FC236}">
-                <a16:creationId xmlns:a16="http://schemas.microsoft.com/office/drawing/2014/main" id="{6984B8FE-5603-49F2-80E7-F475ABF21AED}"/>
+                <a16:creationId xmlns:a16="http://schemas.microsoft.com/office/drawing/2014/main" id="{470D60C9-489F-4569-85A3-2D5911C5B08C}"/>
               </a:ext>
             </a:extLst>
           </p:cNvPr>
@@ -7305,7 +7296,7 @@
           <p:cNvPr id="20" name="source-footer">
             <a:extLst xmlns:a="http://schemas.openxmlformats.org/drawingml/2006/main">
               <a:ext uri="{FF2B5EF4-FFF2-40B4-BE49-F238E27FC236}">
-                <a16:creationId xmlns:a16="http://schemas.microsoft.com/office/drawing/2014/main" id="{76E86557-6CE7-4482-8BB6-F0B8539192DE}"/>
+                <a16:creationId xmlns:a16="http://schemas.microsoft.com/office/drawing/2014/main" id="{7205AB3B-4A87-47D0-A92C-8B605513CD3A}"/>
               </a:ext>
             </a:extLst>
           </p:cNvPr>
@@ -7355,7 +7346,7 @@
           <p:cNvPr id="21" name="slide-number">
             <a:extLst xmlns:a="http://schemas.openxmlformats.org/drawingml/2006/main">
               <a:ext uri="{FF2B5EF4-FFF2-40B4-BE49-F238E27FC236}">
-                <a16:creationId xmlns:a16="http://schemas.microsoft.com/office/drawing/2014/main" id="{AB31BC34-29FA-4F3C-BCFE-4888C61D2778}"/>
+                <a16:creationId xmlns:a16="http://schemas.microsoft.com/office/drawing/2014/main" id="{24D1CBE1-52E9-4285-B8E1-1C082738B947}"/>
               </a:ext>
             </a:extLst>
           </p:cNvPr>
@@ -7403,7 +7394,7 @@
     </p:spTree>
     <p:extLst>
       <p:ext uri="{BB962C8B-B14F-4D97-AF65-F5344CB8AC3E}">
-        <p14:creationId xmlns:p14="http://schemas.microsoft.com/office/powerpoint/2010/main" val="612658699"/>
+        <p14:creationId xmlns:p14="http://schemas.microsoft.com/office/powerpoint/2010/main" val="1352800485"/>
       </p:ext>
     </p:extLst>
   </p:cSld>
@@ -7431,10 +7422,10 @@
       </p:grpSpPr>
       <p:sp>
         <p:nvSpPr>
-          <p:cNvPr id="12" name="slide-title">
-            <a:extLst xmlns:a="http://schemas.openxmlformats.org/drawingml/2006/main">
-              <a:ext uri="{FF2B5EF4-FFF2-40B4-BE49-F238E27FC236}">
-                <a16:creationId xmlns:a16="http://schemas.microsoft.com/office/drawing/2014/main" id="{88D7B6E5-8DF9-44BE-9D72-59C18022AEB7}"/>
+          <p:cNvPr id="16" name="slide-title">
+            <a:extLst xmlns:a="http://schemas.openxmlformats.org/drawingml/2006/main">
+              <a:ext uri="{FF2B5EF4-FFF2-40B4-BE49-F238E27FC236}">
+                <a16:creationId xmlns:a16="http://schemas.microsoft.com/office/drawing/2014/main" id="{BC8F46A0-F85E-49A0-BA1C-0618B00C2E1B}"/>
               </a:ext>
             </a:extLst>
           </p:cNvPr>
@@ -7474,7 +7465,7 @@
                   <a:srgbClr val="111111"/>
                 </a:solidFill>
               </a:rPr>
-              <a:t>The warning model catches 60% of elevated-risk weeks</a:t>
+              <a:t>The warning model catches 61% of elevated-risk windows</a:t>
             </a:r>
           </a:p>
         </p:txBody>
@@ -7484,7 +7475,7 @@
           <p:cNvPr id="2" name="title-rule">
             <a:extLst xmlns:a="http://schemas.openxmlformats.org/drawingml/2006/main">
               <a:ext uri="{FF2B5EF4-FFF2-40B4-BE49-F238E27FC236}">
-                <a16:creationId xmlns:a16="http://schemas.microsoft.com/office/drawing/2014/main" id="{86638F38-320D-4647-9D5D-571CEF621EDC}"/>
+                <a16:creationId xmlns:a16="http://schemas.microsoft.com/office/drawing/2014/main" id="{260F4CA5-18EA-430F-AD45-15E9320E060B}"/>
               </a:ext>
             </a:extLst>
           </p:cNvPr>
@@ -7512,7 +7503,7 @@
       </p:sp>
       <p:graphicFrame>
         <p:nvGraphicFramePr>
-          <p:cNvPr id="14" name="Chart"/>
+          <p:cNvPr id="18" name="Chart"/>
           <p:cNvGraphicFramePr/>
           <p:nvPr/>
         </p:nvGraphicFramePr>
@@ -7522,7 +7513,7 @@
         </p:xfrm>
         <a:graphic xmlns:a="http://schemas.openxmlformats.org/drawingml/2006/main">
           <a:graphicData uri="http://schemas.openxmlformats.org/drawingml/2006/chart">
-            <c:chart xmlns:r="http://schemas.openxmlformats.org/officeDocument/2006/relationships" xmlns:c="http://schemas.openxmlformats.org/drawingml/2006/chart" r:id="Ra121dab637354e34"/>
+            <c:chart xmlns:r="http://schemas.openxmlformats.org/officeDocument/2006/relationships" xmlns:c="http://schemas.openxmlformats.org/drawingml/2006/chart" r:id="R69f54f72f33e4400"/>
           </a:graphicData>
         </a:graphic>
       </p:graphicFrame>
@@ -7531,7 +7522,207 @@
           <p:cNvPr id="4" name="">
             <a:extLst xmlns:a="http://schemas.openxmlformats.org/drawingml/2006/main">
               <a:ext uri="{FF2B5EF4-FFF2-40B4-BE49-F238E27FC236}">
-                <a16:creationId xmlns:a16="http://schemas.microsoft.com/office/drawing/2014/main" id="{89EE2281-0CFB-4871-B4DE-95D12BBDC399}"/>
+                <a16:creationId xmlns:a16="http://schemas.microsoft.com/office/drawing/2014/main" id="{53E792A2-67EB-4A02-B08E-4D427E72A6D5}"/>
+              </a:ext>
+            </a:extLst>
+          </p:cNvPr>
+          <p:cNvSpPr>
+            <a:spLocks xmlns:a="http://schemas.openxmlformats.org/drawingml/2006/main" noGrp="1"/>
+          </p:cNvSpPr>
+          <p:nvPr/>
+        </p:nvSpPr>
+        <p:spPr>
+          <a:xfrm xmlns:a="http://schemas.openxmlformats.org/drawingml/2006/main">
+            <a:off x="6069045" y="2076450"/>
+            <a:ext cx="704850" cy="247650"/>
+          </a:xfrm>
+          <a:prstGeom xmlns:a="http://schemas.openxmlformats.org/drawingml/2006/main" prst="rect">
+            <a:avLst/>
+          </a:prstGeom>
+          <a:noFill xmlns:a="http://schemas.openxmlformats.org/drawingml/2006/main"/>
+          <a:ln xmlns:a="http://schemas.openxmlformats.org/drawingml/2006/main" w="0">
+            <a:noFill/>
+            <a:prstDash val="solid"/>
+          </a:ln>
+        </p:spPr>
+        <p:txBody>
+          <a:bodyPr xmlns:a="http://schemas.openxmlformats.org/drawingml/2006/main"/>
+          <a:lstStyle xmlns:a="http://schemas.openxmlformats.org/drawingml/2006/main"/>
+          <a:p xmlns:a="http://schemas.openxmlformats.org/drawingml/2006/main">
+            <a:pPr algn="l">
+              <a:defRPr sz="1050" b="1">
+                <a:solidFill>
+                  <a:srgbClr val="111111"/>
+                </a:solidFill>
+              </a:defRPr>
+            </a:pPr>
+            <a:r>
+              <a:rPr sz="1050" b="1">
+                <a:solidFill>
+                  <a:srgbClr val="111111"/>
+                </a:solidFill>
+              </a:rPr>
+              <a:t>77.7%</a:t>
+            </a:r>
+          </a:p>
+        </p:txBody>
+      </p:sp>
+      <p:sp>
+        <p:nvSpPr>
+          <p:cNvPr id="5" name="">
+            <a:extLst xmlns:a="http://schemas.openxmlformats.org/drawingml/2006/main">
+              <a:ext uri="{FF2B5EF4-FFF2-40B4-BE49-F238E27FC236}">
+                <a16:creationId xmlns:a16="http://schemas.microsoft.com/office/drawing/2014/main" id="{75664806-8B0B-46A2-ABA7-A41798048333}"/>
+              </a:ext>
+            </a:extLst>
+          </p:cNvPr>
+          <p:cNvSpPr>
+            <a:spLocks xmlns:a="http://schemas.openxmlformats.org/drawingml/2006/main" noGrp="1"/>
+          </p:cNvSpPr>
+          <p:nvPr/>
+        </p:nvSpPr>
+        <p:spPr>
+          <a:xfrm xmlns:a="http://schemas.openxmlformats.org/drawingml/2006/main">
+            <a:off x="5152939" y="3076575"/>
+            <a:ext cx="704850" cy="247650"/>
+          </a:xfrm>
+          <a:prstGeom xmlns:a="http://schemas.openxmlformats.org/drawingml/2006/main" prst="rect">
+            <a:avLst/>
+          </a:prstGeom>
+          <a:noFill xmlns:a="http://schemas.openxmlformats.org/drawingml/2006/main"/>
+          <a:ln xmlns:a="http://schemas.openxmlformats.org/drawingml/2006/main" w="0">
+            <a:noFill/>
+            <a:prstDash val="solid"/>
+          </a:ln>
+        </p:spPr>
+        <p:txBody>
+          <a:bodyPr xmlns:a="http://schemas.openxmlformats.org/drawingml/2006/main"/>
+          <a:lstStyle xmlns:a="http://schemas.openxmlformats.org/drawingml/2006/main"/>
+          <a:p xmlns:a="http://schemas.openxmlformats.org/drawingml/2006/main">
+            <a:pPr algn="l">
+              <a:defRPr sz="1050" b="1">
+                <a:solidFill>
+                  <a:srgbClr val="111111"/>
+                </a:solidFill>
+              </a:defRPr>
+            </a:pPr>
+            <a:r>
+              <a:rPr sz="1050" b="1">
+                <a:solidFill>
+                  <a:srgbClr val="111111"/>
+                </a:solidFill>
+              </a:rPr>
+              <a:t>61.3%</a:t>
+            </a:r>
+          </a:p>
+        </p:txBody>
+      </p:sp>
+      <p:sp>
+        <p:nvSpPr>
+          <p:cNvPr id="6" name="">
+            <a:extLst xmlns:a="http://schemas.openxmlformats.org/drawingml/2006/main">
+              <a:ext uri="{FF2B5EF4-FFF2-40B4-BE49-F238E27FC236}">
+                <a16:creationId xmlns:a16="http://schemas.microsoft.com/office/drawing/2014/main" id="{CB3966C2-5783-40BC-8F92-9ACC70E890AE}"/>
+              </a:ext>
+            </a:extLst>
+          </p:cNvPr>
+          <p:cNvSpPr>
+            <a:spLocks xmlns:a="http://schemas.openxmlformats.org/drawingml/2006/main" noGrp="1"/>
+          </p:cNvSpPr>
+          <p:nvPr/>
+        </p:nvSpPr>
+        <p:spPr>
+          <a:xfrm xmlns:a="http://schemas.openxmlformats.org/drawingml/2006/main">
+            <a:off x="3807606" y="4067175"/>
+            <a:ext cx="704850" cy="247650"/>
+          </a:xfrm>
+          <a:prstGeom xmlns:a="http://schemas.openxmlformats.org/drawingml/2006/main" prst="rect">
+            <a:avLst/>
+          </a:prstGeom>
+          <a:noFill xmlns:a="http://schemas.openxmlformats.org/drawingml/2006/main"/>
+          <a:ln xmlns:a="http://schemas.openxmlformats.org/drawingml/2006/main" w="0">
+            <a:noFill/>
+            <a:prstDash val="solid"/>
+          </a:ln>
+        </p:spPr>
+        <p:txBody>
+          <a:bodyPr xmlns:a="http://schemas.openxmlformats.org/drawingml/2006/main"/>
+          <a:lstStyle xmlns:a="http://schemas.openxmlformats.org/drawingml/2006/main"/>
+          <a:p xmlns:a="http://schemas.openxmlformats.org/drawingml/2006/main">
+            <a:pPr algn="l">
+              <a:defRPr sz="1050" b="1">
+                <a:solidFill>
+                  <a:srgbClr val="111111"/>
+                </a:solidFill>
+              </a:defRPr>
+            </a:pPr>
+            <a:r>
+              <a:rPr sz="1050" b="1">
+                <a:solidFill>
+                  <a:srgbClr val="111111"/>
+                </a:solidFill>
+              </a:rPr>
+              <a:t>37.2%</a:t>
+            </a:r>
+          </a:p>
+        </p:txBody>
+      </p:sp>
+      <p:sp>
+        <p:nvSpPr>
+          <p:cNvPr id="7" name="">
+            <a:extLst xmlns:a="http://schemas.openxmlformats.org/drawingml/2006/main">
+              <a:ext uri="{FF2B5EF4-FFF2-40B4-BE49-F238E27FC236}">
+                <a16:creationId xmlns:a16="http://schemas.microsoft.com/office/drawing/2014/main" id="{3B6EB6E5-DE91-4F5F-A9CE-AEBE9AC2B866}"/>
+              </a:ext>
+            </a:extLst>
+          </p:cNvPr>
+          <p:cNvSpPr>
+            <a:spLocks xmlns:a="http://schemas.openxmlformats.org/drawingml/2006/main" noGrp="1"/>
+          </p:cNvSpPr>
+          <p:nvPr/>
+        </p:nvSpPr>
+        <p:spPr>
+          <a:xfrm xmlns:a="http://schemas.openxmlformats.org/drawingml/2006/main">
+            <a:off x="5790776" y="5067300"/>
+            <a:ext cx="704850" cy="247650"/>
+          </a:xfrm>
+          <a:prstGeom xmlns:a="http://schemas.openxmlformats.org/drawingml/2006/main" prst="rect">
+            <a:avLst/>
+          </a:prstGeom>
+          <a:noFill xmlns:a="http://schemas.openxmlformats.org/drawingml/2006/main"/>
+          <a:ln xmlns:a="http://schemas.openxmlformats.org/drawingml/2006/main" w="0">
+            <a:noFill/>
+            <a:prstDash val="solid"/>
+          </a:ln>
+        </p:spPr>
+        <p:txBody>
+          <a:bodyPr xmlns:a="http://schemas.openxmlformats.org/drawingml/2006/main"/>
+          <a:lstStyle xmlns:a="http://schemas.openxmlformats.org/drawingml/2006/main"/>
+          <a:p xmlns:a="http://schemas.openxmlformats.org/drawingml/2006/main">
+            <a:pPr algn="l">
+              <a:defRPr sz="1050" b="1">
+                <a:solidFill>
+                  <a:srgbClr val="111111"/>
+                </a:solidFill>
+              </a:defRPr>
+            </a:pPr>
+            <a:r>
+              <a:rPr sz="1050" b="1">
+                <a:solidFill>
+                  <a:srgbClr val="111111"/>
+                </a:solidFill>
+              </a:rPr>
+              <a:t>72.7%</a:t>
+            </a:r>
+          </a:p>
+        </p:txBody>
+      </p:sp>
+      <p:sp>
+        <p:nvSpPr>
+          <p:cNvPr id="8" name="">
+            <a:extLst xmlns:a="http://schemas.openxmlformats.org/drawingml/2006/main">
+              <a:ext uri="{FF2B5EF4-FFF2-40B4-BE49-F238E27FC236}">
+                <a16:creationId xmlns:a16="http://schemas.microsoft.com/office/drawing/2014/main" id="{ADFC9049-645B-42A0-9DB5-ED55305000E0}"/>
               </a:ext>
             </a:extLst>
           </p:cNvPr>
@@ -7559,10 +7750,10 @@
       </p:sp>
       <p:sp>
         <p:nvSpPr>
-          <p:cNvPr id="5" name="">
-            <a:extLst xmlns:a="http://schemas.openxmlformats.org/drawingml/2006/main">
-              <a:ext uri="{FF2B5EF4-FFF2-40B4-BE49-F238E27FC236}">
-                <a16:creationId xmlns:a16="http://schemas.microsoft.com/office/drawing/2014/main" id="{5A4E2CCF-5D0C-4335-8DAC-159EA021C5B6}"/>
+          <p:cNvPr id="9" name="">
+            <a:extLst xmlns:a="http://schemas.openxmlformats.org/drawingml/2006/main">
+              <a:ext uri="{FF2B5EF4-FFF2-40B4-BE49-F238E27FC236}">
+                <a16:creationId xmlns:a16="http://schemas.microsoft.com/office/drawing/2014/main" id="{621279A4-B350-4203-BF9C-BA28DD638DA8}"/>
               </a:ext>
             </a:extLst>
           </p:cNvPr>
@@ -7602,17 +7793,17 @@
                   <a:srgbClr val="3D8DFF"/>
                 </a:solidFill>
               </a:rPr>
-              <a:t>67</a:t>
-            </a:r>
-          </a:p>
-        </p:txBody>
-      </p:sp>
-      <p:sp>
-        <p:nvSpPr>
-          <p:cNvPr id="6" name="">
-            <a:extLst xmlns:a="http://schemas.openxmlformats.org/drawingml/2006/main">
-              <a:ext uri="{FF2B5EF4-FFF2-40B4-BE49-F238E27FC236}">
-                <a16:creationId xmlns:a16="http://schemas.microsoft.com/office/drawing/2014/main" id="{92F309AB-77B6-4966-83E2-738BD235F343}"/>
+              <a:t>68</a:t>
+            </a:r>
+          </a:p>
+        </p:txBody>
+      </p:sp>
+      <p:sp>
+        <p:nvSpPr>
+          <p:cNvPr id="10" name="">
+            <a:extLst xmlns:a="http://schemas.openxmlformats.org/drawingml/2006/main">
+              <a:ext uri="{FF2B5EF4-FFF2-40B4-BE49-F238E27FC236}">
+                <a16:creationId xmlns:a16="http://schemas.microsoft.com/office/drawing/2014/main" id="{99E94018-72B5-49A6-8B82-A1D424396826}"/>
               </a:ext>
             </a:extLst>
           </p:cNvPr>
@@ -7652,17 +7843,17 @@
                   <a:srgbClr val="111111"/>
                 </a:solidFill>
               </a:rPr>
-              <a:t>elevated-risk weeks caught</a:t>
-            </a:r>
-          </a:p>
-        </p:txBody>
-      </p:sp>
-      <p:sp>
-        <p:nvSpPr>
-          <p:cNvPr id="7" name="">
-            <a:extLst xmlns:a="http://schemas.openxmlformats.org/drawingml/2006/main">
-              <a:ext uri="{FF2B5EF4-FFF2-40B4-BE49-F238E27FC236}">
-                <a16:creationId xmlns:a16="http://schemas.microsoft.com/office/drawing/2014/main" id="{EF303A9F-B959-4ACD-8864-1EA31C92EC3D}"/>
+              <a:t>elevated-risk windows caught</a:t>
+            </a:r>
+          </a:p>
+        </p:txBody>
+      </p:sp>
+      <p:sp>
+        <p:nvSpPr>
+          <p:cNvPr id="11" name="">
+            <a:extLst xmlns:a="http://schemas.openxmlformats.org/drawingml/2006/main">
+              <a:ext uri="{FF2B5EF4-FFF2-40B4-BE49-F238E27FC236}">
+                <a16:creationId xmlns:a16="http://schemas.microsoft.com/office/drawing/2014/main" id="{C241990E-2664-48D4-A7C1-47E1C6068F4C}"/>
               </a:ext>
             </a:extLst>
           </p:cNvPr>
@@ -7702,17 +7893,17 @@
                   <a:srgbClr val="5F6368"/>
                 </a:solidFill>
               </a:rPr>
-              <a:t>44 elevated-risk weeks were missed</a:t>
-            </a:r>
-          </a:p>
-        </p:txBody>
-      </p:sp>
-      <p:sp>
-        <p:nvSpPr>
-          <p:cNvPr id="8" name="">
-            <a:extLst xmlns:a="http://schemas.openxmlformats.org/drawingml/2006/main">
-              <a:ext uri="{FF2B5EF4-FFF2-40B4-BE49-F238E27FC236}">
-                <a16:creationId xmlns:a16="http://schemas.microsoft.com/office/drawing/2014/main" id="{80E1592F-3926-44E6-934F-1A4F52649D78}"/>
+              <a:t>43 elevated-risk windows were missed</a:t>
+            </a:r>
+          </a:p>
+        </p:txBody>
+      </p:sp>
+      <p:sp>
+        <p:nvSpPr>
+          <p:cNvPr id="12" name="">
+            <a:extLst xmlns:a="http://schemas.openxmlformats.org/drawingml/2006/main">
+              <a:ext uri="{FF2B5EF4-FFF2-40B4-BE49-F238E27FC236}">
+                <a16:creationId xmlns:a16="http://schemas.microsoft.com/office/drawing/2014/main" id="{11B0E6E1-B271-4E09-88A0-D6830D3466C5}"/>
               </a:ext>
             </a:extLst>
           </p:cNvPr>
@@ -7759,10 +7950,10 @@
       </p:sp>
       <p:sp>
         <p:nvSpPr>
-          <p:cNvPr id="9" name="">
-            <a:extLst xmlns:a="http://schemas.openxmlformats.org/drawingml/2006/main">
-              <a:ext uri="{FF2B5EF4-FFF2-40B4-BE49-F238E27FC236}">
-                <a16:creationId xmlns:a16="http://schemas.microsoft.com/office/drawing/2014/main" id="{259BC698-8948-4236-B95D-4E9E9707D1CD}"/>
+          <p:cNvPr id="13" name="">
+            <a:extLst xmlns:a="http://schemas.openxmlformats.org/drawingml/2006/main">
+              <a:ext uri="{FF2B5EF4-FFF2-40B4-BE49-F238E27FC236}">
+                <a16:creationId xmlns:a16="http://schemas.microsoft.com/office/drawing/2014/main" id="{A29C9BC8-5434-41F6-B384-0A41F1E1B556}"/>
               </a:ext>
             </a:extLst>
           </p:cNvPr>
@@ -7802,17 +7993,17 @@
                   <a:srgbClr val="5F6368"/>
                 </a:solidFill>
               </a:rPr>
-              <a:t>Elevated-risk weeks are only 13.3% of the test set. The prior baseline reaches high raw accuracy by predicting only the majority class—but catches zero elevated-risk weeks.</a:t>
-            </a:r>
-          </a:p>
-        </p:txBody>
-      </p:sp>
-      <p:sp>
-        <p:nvSpPr>
-          <p:cNvPr id="10" name="source-footer">
-            <a:extLst xmlns:a="http://schemas.openxmlformats.org/drawingml/2006/main">
-              <a:ext uri="{FF2B5EF4-FFF2-40B4-BE49-F238E27FC236}">
-                <a16:creationId xmlns:a16="http://schemas.microsoft.com/office/drawing/2014/main" id="{61B06101-7EE1-46A5-B1CC-AA06FD1D7559}"/>
+              <a:t>Elevated-risk windows are only 13.3% of the holdout. The prior baseline predicts only the majority class and catches zero elevated-risk windows.</a:t>
+            </a:r>
+          </a:p>
+        </p:txBody>
+      </p:sp>
+      <p:sp>
+        <p:nvSpPr>
+          <p:cNvPr id="14" name="source-footer">
+            <a:extLst xmlns:a="http://schemas.openxmlformats.org/drawingml/2006/main">
+              <a:ext uri="{FF2B5EF4-FFF2-40B4-BE49-F238E27FC236}">
+                <a16:creationId xmlns:a16="http://schemas.microsoft.com/office/drawing/2014/main" id="{2A423BC6-A896-4E4E-9088-0941D3617DF0}"/>
               </a:ext>
             </a:extLst>
           </p:cNvPr>
@@ -7859,10 +8050,10 @@
       </p:sp>
       <p:sp>
         <p:nvSpPr>
-          <p:cNvPr id="11" name="slide-number">
-            <a:extLst xmlns:a="http://schemas.openxmlformats.org/drawingml/2006/main">
-              <a:ext uri="{FF2B5EF4-FFF2-40B4-BE49-F238E27FC236}">
-                <a16:creationId xmlns:a16="http://schemas.microsoft.com/office/drawing/2014/main" id="{4AADB77A-FFDA-4BED-B789-D1416A62626F}"/>
+          <p:cNvPr id="15" name="slide-number">
+            <a:extLst xmlns:a="http://schemas.openxmlformats.org/drawingml/2006/main">
+              <a:ext uri="{FF2B5EF4-FFF2-40B4-BE49-F238E27FC236}">
+                <a16:creationId xmlns:a16="http://schemas.microsoft.com/office/drawing/2014/main" id="{7B719F6F-DAA0-42CB-B61B-ECA8B62BD36A}"/>
               </a:ext>
             </a:extLst>
           </p:cNvPr>
@@ -7910,7 +8101,7 @@
     </p:spTree>
     <p:extLst>
       <p:ext uri="{BB962C8B-B14F-4D97-AF65-F5344CB8AC3E}">
-        <p14:creationId xmlns:p14="http://schemas.microsoft.com/office/powerpoint/2010/main" val="744171448"/>
+        <p14:creationId xmlns:p14="http://schemas.microsoft.com/office/powerpoint/2010/main" val="571836273"/>
       </p:ext>
     </p:extLst>
   </p:cSld>
@@ -7938,10 +8129,10 @@
       </p:grpSpPr>
       <p:sp>
         <p:nvSpPr>
-          <p:cNvPr id="9" name="slide-title">
-            <a:extLst xmlns:a="http://schemas.openxmlformats.org/drawingml/2006/main">
-              <a:ext uri="{FF2B5EF4-FFF2-40B4-BE49-F238E27FC236}">
-                <a16:creationId xmlns:a16="http://schemas.microsoft.com/office/drawing/2014/main" id="{93267890-983A-488D-AC22-C263245E1F1B}"/>
+          <p:cNvPr id="18" name="slide-title">
+            <a:extLst xmlns:a="http://schemas.openxmlformats.org/drawingml/2006/main">
+              <a:ext uri="{FF2B5EF4-FFF2-40B4-BE49-F238E27FC236}">
+                <a16:creationId xmlns:a16="http://schemas.microsoft.com/office/drawing/2014/main" id="{CE8590AE-C5C9-4419-860D-AE2717965F18}"/>
               </a:ext>
             </a:extLst>
           </p:cNvPr>
@@ -7981,7 +8172,7 @@
                   <a:srgbClr val="111111"/>
                 </a:solidFill>
               </a:rPr>
-              <a:t>The risk label is useful—but threshold-dependent</a:t>
+              <a:t>Robustness checks temper confidence—not the conclusion</a:t>
             </a:r>
           </a:p>
         </p:txBody>
@@ -7991,7 +8182,7 @@
           <p:cNvPr id="2" name="title-rule">
             <a:extLst xmlns:a="http://schemas.openxmlformats.org/drawingml/2006/main">
               <a:ext uri="{FF2B5EF4-FFF2-40B4-BE49-F238E27FC236}">
-                <a16:creationId xmlns:a16="http://schemas.microsoft.com/office/drawing/2014/main" id="{49E11D2A-F2F1-427E-8E51-072A021D43E5}"/>
+                <a16:creationId xmlns:a16="http://schemas.microsoft.com/office/drawing/2014/main" id="{2B06F888-1C8D-450D-BAEC-58120724FE84}"/>
               </a:ext>
             </a:extLst>
           </p:cNvPr>
@@ -8022,7 +8213,7 @@
           <p:cNvPr id="3" name="">
             <a:extLst xmlns:a="http://schemas.openxmlformats.org/drawingml/2006/main">
               <a:ext uri="{FF2B5EF4-FFF2-40B4-BE49-F238E27FC236}">
-                <a16:creationId xmlns:a16="http://schemas.microsoft.com/office/drawing/2014/main" id="{B8EE883A-2717-4887-AC08-C70668FCD000}"/>
+                <a16:creationId xmlns:a16="http://schemas.microsoft.com/office/drawing/2014/main" id="{36038A6A-47E6-4B3F-B670-18D2AFCD1709}"/>
               </a:ext>
             </a:extLst>
           </p:cNvPr>
@@ -8034,7 +8225,7 @@
         <p:spPr>
           <a:xfrm xmlns:a="http://schemas.openxmlformats.org/drawingml/2006/main">
             <a:off x="495300" y="1200150"/>
-            <a:ext cx="10668000" cy="476250"/>
+            <a:ext cx="10668000" cy="400050"/>
           </a:xfrm>
           <a:prstGeom xmlns:a="http://schemas.openxmlformats.org/drawingml/2006/main" prst="rect">
             <a:avLst/>
@@ -8062,519 +8253,60 @@
                   <a:srgbClr val="5F6368"/>
                 </a:solidFill>
               </a:rPr>
-              <a:t>Training-derived quantiles move the volatility threshold and change the precision–recall tradeoff.</a:t>
-            </a:r>
-          </a:p>
-        </p:txBody>
-      </p:sp>
-      <p:graphicFrame>
-        <p:nvGraphicFramePr>
-          <p:cNvPr id="12" name=""/>
-          <p:cNvGraphicFramePr/>
-          <p:nvPr/>
-        </p:nvGraphicFramePr>
-        <p:xfrm>
-          <a:off xmlns:a="http://schemas.openxmlformats.org/drawingml/2006/main" x="495300" y="2076450"/>
-          <a:ext xmlns:a="http://schemas.openxmlformats.org/drawingml/2006/main" cx="11201400" cy="2667000"/>
-        </p:xfrm>
-        <a:graphic xmlns:a="http://schemas.openxmlformats.org/drawingml/2006/main">
-          <a:graphicData uri="http://schemas.openxmlformats.org/drawingml/2006/table">
-            <a:tbl>
-              <a:tblPr firstRow="1" bandRow="1"/>
-              <a:tblGrid>
-                <a:gridCol w="1866900"/>
-                <a:gridCol w="2095500"/>
-                <a:gridCol w="2095500"/>
-                <a:gridCol w="1714500"/>
-                <a:gridCol w="1714500"/>
-                <a:gridCol w="1714500"/>
-              </a:tblGrid>
-              <a:tr h="666750">
-                <a:tc>
-                  <a:txBody>
-                    <a:bodyPr/>
-                    <a:lstStyle/>
-                    <a:p>
-                      <a:r>
-                        <a:rPr sz="1200" b="1">
-                          <a:solidFill>
-                            <a:srgbClr val="FFFFFF"/>
-                          </a:solidFill>
-                        </a:rPr>
-                        <a:t>Risk quantile</a:t>
-                      </a:r>
-                    </a:p>
-                  </a:txBody>
-                  <a:tcPr marL="91440" marR="91440" marT="45720" marB="45720">
-                    <a:solidFill>
-                      <a:srgbClr val="111111"/>
-                    </a:solidFill>
-                  </a:tcPr>
-                </a:tc>
-                <a:tc>
-                  <a:txBody>
-                    <a:bodyPr/>
-                    <a:lstStyle/>
-                    <a:p>
-                      <a:r>
-                        <a:rPr sz="1200" b="1">
-                          <a:solidFill>
-                            <a:srgbClr val="FFFFFF"/>
-                          </a:solidFill>
-                        </a:rPr>
-                        <a:t>Volatility threshold</a:t>
-                      </a:r>
-                    </a:p>
-                  </a:txBody>
-                  <a:tcPr marL="91440" marR="91440" marT="45720" marB="45720">
-                    <a:solidFill>
-                      <a:srgbClr val="111111"/>
-                    </a:solidFill>
-                  </a:tcPr>
-                </a:tc>
-                <a:tc>
-                  <a:txBody>
-                    <a:bodyPr/>
-                    <a:lstStyle/>
-                    <a:p>
-                      <a:r>
-                        <a:rPr sz="1200" b="1">
-                          <a:solidFill>
-                            <a:srgbClr val="FFFFFF"/>
-                          </a:solidFill>
-                        </a:rPr>
-                        <a:t>Balanced accuracy</a:t>
-                      </a:r>
-                    </a:p>
-                  </a:txBody>
-                  <a:tcPr marL="91440" marR="91440" marT="45720" marB="45720">
-                    <a:solidFill>
-                      <a:srgbClr val="111111"/>
-                    </a:solidFill>
-                  </a:tcPr>
-                </a:tc>
-                <a:tc>
-                  <a:txBody>
-                    <a:bodyPr/>
-                    <a:lstStyle/>
-                    <a:p>
-                      <a:r>
-                        <a:rPr sz="1200" b="1">
-                          <a:solidFill>
-                            <a:srgbClr val="FFFFFF"/>
-                          </a:solidFill>
-                        </a:rPr>
-                        <a:t>Precision</a:t>
-                      </a:r>
-                    </a:p>
-                  </a:txBody>
-                  <a:tcPr marL="91440" marR="91440" marT="45720" marB="45720">
-                    <a:solidFill>
-                      <a:srgbClr val="111111"/>
-                    </a:solidFill>
-                  </a:tcPr>
-                </a:tc>
-                <a:tc>
-                  <a:txBody>
-                    <a:bodyPr/>
-                    <a:lstStyle/>
-                    <a:p>
-                      <a:r>
-                        <a:rPr sz="1200" b="1">
-                          <a:solidFill>
-                            <a:srgbClr val="FFFFFF"/>
-                          </a:solidFill>
-                        </a:rPr>
-                        <a:t>Recall</a:t>
-                      </a:r>
-                    </a:p>
-                  </a:txBody>
-                  <a:tcPr marL="91440" marR="91440" marT="45720" marB="45720">
-                    <a:solidFill>
-                      <a:srgbClr val="111111"/>
-                    </a:solidFill>
-                  </a:tcPr>
-                </a:tc>
-                <a:tc>
-                  <a:txBody>
-                    <a:bodyPr/>
-                    <a:lstStyle/>
-                    <a:p>
-                      <a:r>
-                        <a:rPr sz="1200" b="1">
-                          <a:solidFill>
-                            <a:srgbClr val="FFFFFF"/>
-                          </a:solidFill>
-                        </a:rPr>
-                        <a:t>F1</a:t>
-                      </a:r>
-                    </a:p>
-                  </a:txBody>
-                  <a:tcPr marL="91440" marR="91440" marT="45720" marB="45720">
-                    <a:solidFill>
-                      <a:srgbClr val="111111"/>
-                    </a:solidFill>
-                  </a:tcPr>
-                </a:tc>
-              </a:tr>
-              <a:tr h="666750">
-                <a:tc>
-                  <a:txBody>
-                    <a:bodyPr/>
-                    <a:lstStyle/>
-                    <a:p>
-                      <a:r>
-                        <a:rPr sz="1275">
-                          <a:solidFill>
-                            <a:srgbClr val="111111"/>
-                          </a:solidFill>
-                        </a:rPr>
-                        <a:t>70%</a:t>
-                      </a:r>
-                    </a:p>
-                  </a:txBody>
-                  <a:tcPr marL="91440" marR="91440" marT="45720" marB="45720"/>
-                </a:tc>
-                <a:tc>
-                  <a:txBody>
-                    <a:bodyPr/>
-                    <a:lstStyle/>
-                    <a:p>
-                      <a:r>
-                        <a:rPr sz="1275">
-                          <a:solidFill>
-                            <a:srgbClr val="111111"/>
-                          </a:solidFill>
-                        </a:rPr>
-                        <a:t>16.3%</a:t>
-                      </a:r>
-                    </a:p>
-                  </a:txBody>
-                  <a:tcPr marL="91440" marR="91440" marT="45720" marB="45720"/>
-                </a:tc>
-                <a:tc>
-                  <a:txBody>
-                    <a:bodyPr/>
-                    <a:lstStyle/>
-                    <a:p>
-                      <a:r>
-                        <a:rPr sz="1275">
-                          <a:solidFill>
-                            <a:srgbClr val="111111"/>
-                          </a:solidFill>
-                        </a:rPr>
-                        <a:t>70.6%</a:t>
-                      </a:r>
-                    </a:p>
-                  </a:txBody>
-                  <a:tcPr marL="91440" marR="91440" marT="45720" marB="45720"/>
-                </a:tc>
-                <a:tc>
-                  <a:txBody>
-                    <a:bodyPr/>
-                    <a:lstStyle/>
-                    <a:p>
-                      <a:r>
-                        <a:rPr sz="1275">
-                          <a:solidFill>
-                            <a:srgbClr val="111111"/>
-                          </a:solidFill>
-                        </a:rPr>
-                        <a:t>44.8%</a:t>
-                      </a:r>
-                    </a:p>
-                  </a:txBody>
-                  <a:tcPr marL="91440" marR="91440" marT="45720" marB="45720"/>
-                </a:tc>
-                <a:tc>
-                  <a:txBody>
-                    <a:bodyPr/>
-                    <a:lstStyle/>
-                    <a:p>
-                      <a:r>
-                        <a:rPr sz="1275">
-                          <a:solidFill>
-                            <a:srgbClr val="111111"/>
-                          </a:solidFill>
-                        </a:rPr>
-                        <a:t>58.4%</a:t>
-                      </a:r>
-                    </a:p>
-                  </a:txBody>
-                  <a:tcPr marL="91440" marR="91440" marT="45720" marB="45720"/>
-                </a:tc>
-                <a:tc>
-                  <a:txBody>
-                    <a:bodyPr/>
-                    <a:lstStyle/>
-                    <a:p>
-                      <a:r>
-                        <a:rPr sz="1275">
-                          <a:solidFill>
-                            <a:srgbClr val="111111"/>
-                          </a:solidFill>
-                        </a:rPr>
-                        <a:t>50.7%</a:t>
-                      </a:r>
-                    </a:p>
-                  </a:txBody>
-                  <a:tcPr marL="91440" marR="91440" marT="45720" marB="45720"/>
-                </a:tc>
-              </a:tr>
-              <a:tr h="666750">
-                <a:tc>
-                  <a:txBody>
-                    <a:bodyPr/>
-                    <a:lstStyle/>
-                    <a:p>
-                      <a:r>
-                        <a:rPr sz="1275">
-                          <a:solidFill>
-                            <a:srgbClr val="111111"/>
-                          </a:solidFill>
-                        </a:rPr>
-                        <a:t>75%</a:t>
-                      </a:r>
-                    </a:p>
-                  </a:txBody>
-                  <a:tcPr marL="91440" marR="91440" marT="45720" marB="45720">
-                    <a:solidFill>
-                      <a:srgbClr val="EAF5FB"/>
-                    </a:solidFill>
-                  </a:tcPr>
-                </a:tc>
-                <a:tc>
-                  <a:txBody>
-                    <a:bodyPr/>
-                    <a:lstStyle/>
-                    <a:p>
-                      <a:r>
-                        <a:rPr sz="1275">
-                          <a:solidFill>
-                            <a:srgbClr val="111111"/>
-                          </a:solidFill>
-                        </a:rPr>
-                        <a:t>17.8%</a:t>
-                      </a:r>
-                    </a:p>
-                  </a:txBody>
-                  <a:tcPr marL="91440" marR="91440" marT="45720" marB="45720">
-                    <a:solidFill>
-                      <a:srgbClr val="EAF5FB"/>
-                    </a:solidFill>
-                  </a:tcPr>
-                </a:tc>
-                <a:tc>
-                  <a:txBody>
-                    <a:bodyPr/>
-                    <a:lstStyle/>
-                    <a:p>
-                      <a:r>
-                        <a:rPr sz="1275">
-                          <a:solidFill>
-                            <a:srgbClr val="111111"/>
-                          </a:solidFill>
-                        </a:rPr>
-                        <a:t>72.3%</a:t>
-                      </a:r>
-                    </a:p>
-                  </a:txBody>
-                  <a:tcPr marL="91440" marR="91440" marT="45720" marB="45720">
-                    <a:solidFill>
-                      <a:srgbClr val="EAF5FB"/>
-                    </a:solidFill>
-                  </a:tcPr>
-                </a:tc>
-                <a:tc>
-                  <a:txBody>
-                    <a:bodyPr/>
-                    <a:lstStyle/>
-                    <a:p>
-                      <a:r>
-                        <a:rPr sz="1275">
-                          <a:solidFill>
-                            <a:srgbClr val="111111"/>
-                          </a:solidFill>
-                        </a:rPr>
-                        <a:t>37.0%</a:t>
-                      </a:r>
-                    </a:p>
-                  </a:txBody>
-                  <a:tcPr marL="91440" marR="91440" marT="45720" marB="45720">
-                    <a:solidFill>
-                      <a:srgbClr val="EAF5FB"/>
-                    </a:solidFill>
-                  </a:tcPr>
-                </a:tc>
-                <a:tc>
-                  <a:txBody>
-                    <a:bodyPr/>
-                    <a:lstStyle/>
-                    <a:p>
-                      <a:r>
-                        <a:rPr sz="1275">
-                          <a:solidFill>
-                            <a:srgbClr val="111111"/>
-                          </a:solidFill>
-                        </a:rPr>
-                        <a:t>60.4%</a:t>
-                      </a:r>
-                    </a:p>
-                  </a:txBody>
-                  <a:tcPr marL="91440" marR="91440" marT="45720" marB="45720">
-                    <a:solidFill>
-                      <a:srgbClr val="EAF5FB"/>
-                    </a:solidFill>
-                  </a:tcPr>
-                </a:tc>
-                <a:tc>
-                  <a:txBody>
-                    <a:bodyPr/>
-                    <a:lstStyle/>
-                    <a:p>
-                      <a:r>
-                        <a:rPr sz="1275">
-                          <a:solidFill>
-                            <a:srgbClr val="111111"/>
-                          </a:solidFill>
-                        </a:rPr>
-                        <a:t>45.9%</a:t>
-                      </a:r>
-                    </a:p>
-                  </a:txBody>
-                  <a:tcPr marL="91440" marR="91440" marT="45720" marB="45720">
-                    <a:solidFill>
-                      <a:srgbClr val="EAF5FB"/>
-                    </a:solidFill>
-                  </a:tcPr>
-                </a:tc>
-              </a:tr>
-              <a:tr h="666750">
-                <a:tc>
-                  <a:txBody>
-                    <a:bodyPr/>
-                    <a:lstStyle/>
-                    <a:p>
-                      <a:r>
-                        <a:rPr sz="1275">
-                          <a:solidFill>
-                            <a:srgbClr val="111111"/>
-                          </a:solidFill>
-                        </a:rPr>
-                        <a:t>80%</a:t>
-                      </a:r>
-                    </a:p>
-                  </a:txBody>
-                  <a:tcPr marL="91440" marR="91440" marT="45720" marB="45720"/>
-                </a:tc>
-                <a:tc>
-                  <a:txBody>
-                    <a:bodyPr/>
-                    <a:lstStyle/>
-                    <a:p>
-                      <a:r>
-                        <a:rPr sz="1275">
-                          <a:solidFill>
-                            <a:srgbClr val="111111"/>
-                          </a:solidFill>
-                        </a:rPr>
-                        <a:t>19.7%</a:t>
-                      </a:r>
-                    </a:p>
-                  </a:txBody>
-                  <a:tcPr marL="91440" marR="91440" marT="45720" marB="45720"/>
-                </a:tc>
-                <a:tc>
-                  <a:txBody>
-                    <a:bodyPr/>
-                    <a:lstStyle/>
-                    <a:p>
-                      <a:r>
-                        <a:rPr sz="1275">
-                          <a:solidFill>
-                            <a:srgbClr val="111111"/>
-                          </a:solidFill>
-                        </a:rPr>
-                        <a:t>72.6%</a:t>
-                      </a:r>
-                    </a:p>
-                  </a:txBody>
-                  <a:tcPr marL="91440" marR="91440" marT="45720" marB="45720"/>
-                </a:tc>
-                <a:tc>
-                  <a:txBody>
-                    <a:bodyPr/>
-                    <a:lstStyle/>
-                    <a:p>
-                      <a:r>
-                        <a:rPr sz="1275">
-                          <a:solidFill>
-                            <a:srgbClr val="111111"/>
-                          </a:solidFill>
-                        </a:rPr>
-                        <a:t>32.8%</a:t>
-                      </a:r>
-                    </a:p>
-                  </a:txBody>
-                  <a:tcPr marL="91440" marR="91440" marT="45720" marB="45720"/>
-                </a:tc>
-                <a:tc>
-                  <a:txBody>
-                    <a:bodyPr/>
-                    <a:lstStyle/>
-                    <a:p>
-                      <a:r>
-                        <a:rPr sz="1275">
-                          <a:solidFill>
-                            <a:srgbClr val="111111"/>
-                          </a:solidFill>
-                        </a:rPr>
-                        <a:t>57.1%</a:t>
-                      </a:r>
-                    </a:p>
-                  </a:txBody>
-                  <a:tcPr marL="91440" marR="91440" marT="45720" marB="45720"/>
-                </a:tc>
-                <a:tc>
-                  <a:txBody>
-                    <a:bodyPr/>
-                    <a:lstStyle/>
-                    <a:p>
-                      <a:r>
-                        <a:rPr sz="1275">
-                          <a:solidFill>
-                            <a:srgbClr val="111111"/>
-                          </a:solidFill>
-                        </a:rPr>
-                        <a:t>41.7%</a:t>
-                      </a:r>
-                    </a:p>
-                  </a:txBody>
-                  <a:tcPr marL="91440" marR="91440" marT="45720" marB="45720"/>
-                </a:tc>
-              </a:tr>
-            </a:tbl>
-          </a:graphicData>
-        </a:graphic>
-      </p:graphicFrame>
+              <a:t>Overlapping targets, changing regimes, and tail errors all need explicit checks.</a:t>
+            </a:r>
+          </a:p>
+        </p:txBody>
+      </p:sp>
+      <p:sp>
+        <p:nvSpPr>
+          <p:cNvPr id="4" name="">
+            <a:extLst xmlns:a="http://schemas.openxmlformats.org/drawingml/2006/main">
+              <a:ext uri="{FF2B5EF4-FFF2-40B4-BE49-F238E27FC236}">
+                <a16:creationId xmlns:a16="http://schemas.microsoft.com/office/drawing/2014/main" id="{CADDC21D-4A37-402B-85AC-849327A4EABA}"/>
+              </a:ext>
+            </a:extLst>
+          </p:cNvPr>
+          <p:cNvSpPr>
+            <a:spLocks xmlns:a="http://schemas.openxmlformats.org/drawingml/2006/main" noGrp="1"/>
+          </p:cNvSpPr>
+          <p:nvPr/>
+        </p:nvSpPr>
+        <p:spPr>
+          <a:xfrm xmlns:a="http://schemas.openxmlformats.org/drawingml/2006/main">
+            <a:off x="495300" y="1828800"/>
+            <a:ext cx="11201400" cy="1066800"/>
+          </a:xfrm>
+          <a:prstGeom xmlns:a="http://schemas.openxmlformats.org/drawingml/2006/main" prst="rect">
+            <a:avLst/>
+          </a:prstGeom>
+          <a:solidFill xmlns:a="http://schemas.openxmlformats.org/drawingml/2006/main">
+            <a:srgbClr val="EDEDED"/>
+          </a:solidFill>
+          <a:ln xmlns:a="http://schemas.openxmlformats.org/drawingml/2006/main" w="0">
+            <a:noFill/>
+            <a:prstDash val="solid"/>
+          </a:ln>
+        </p:spPr>
+      </p:sp>
       <p:sp>
         <p:nvSpPr>
           <p:cNvPr id="5" name="">
             <a:extLst xmlns:a="http://schemas.openxmlformats.org/drawingml/2006/main">
               <a:ext uri="{FF2B5EF4-FFF2-40B4-BE49-F238E27FC236}">
-                <a16:creationId xmlns:a16="http://schemas.microsoft.com/office/drawing/2014/main" id="{BE9225AC-17CD-47AE-992A-1EA0FD2D38EE}"/>
-              </a:ext>
-            </a:extLst>
-          </p:cNvPr>
-          <p:cNvSpPr>
-            <a:spLocks xmlns:a="http://schemas.openxmlformats.org/drawingml/2006/main" noGrp="1"/>
-          </p:cNvSpPr>
-          <p:nvPr/>
-        </p:nvSpPr>
-        <p:spPr>
-          <a:xfrm xmlns:a="http://schemas.openxmlformats.org/drawingml/2006/main">
-            <a:off x="495300" y="5219700"/>
-            <a:ext cx="1905000" cy="304800"/>
+                <a16:creationId xmlns:a16="http://schemas.microsoft.com/office/drawing/2014/main" id="{5D8DA213-63FF-4148-A333-20565EFCEE9F}"/>
+              </a:ext>
+            </a:extLst>
+          </p:cNvPr>
+          <p:cNvSpPr>
+            <a:spLocks xmlns:a="http://schemas.openxmlformats.org/drawingml/2006/main" noGrp="1"/>
+          </p:cNvSpPr>
+          <p:nvPr/>
+        </p:nvSpPr>
+        <p:spPr>
+          <a:xfrm xmlns:a="http://schemas.openxmlformats.org/drawingml/2006/main">
+            <a:off x="742950" y="2038350"/>
+            <a:ext cx="2133600" cy="514350"/>
           </a:xfrm>
           <a:prstGeom xmlns:a="http://schemas.openxmlformats.org/drawingml/2006/main" prst="rect">
             <a:avLst/>
@@ -8590,19 +8322,19 @@
           <a:lstStyle xmlns:a="http://schemas.openxmlformats.org/drawingml/2006/main"/>
           <a:p xmlns:a="http://schemas.openxmlformats.org/drawingml/2006/main">
             <a:pPr algn="l">
-              <a:defRPr sz="1800" b="1">
+              <a:defRPr sz="2550" b="1">
                 <a:solidFill>
                   <a:srgbClr val="111111"/>
                 </a:solidFill>
               </a:defRPr>
             </a:pPr>
             <a:r>
-              <a:rPr sz="1800" b="1">
+              <a:rPr sz="2550" b="1">
                 <a:solidFill>
                   <a:srgbClr val="111111"/>
                 </a:solidFill>
               </a:rPr>
-              <a:t>Interpretation</a:t>
+              <a:t>52–68%</a:t>
             </a:r>
           </a:p>
         </p:txBody>
@@ -8612,19 +8344,19 @@
           <p:cNvPr id="6" name="">
             <a:extLst xmlns:a="http://schemas.openxmlformats.org/drawingml/2006/main">
               <a:ext uri="{FF2B5EF4-FFF2-40B4-BE49-F238E27FC236}">
-                <a16:creationId xmlns:a16="http://schemas.microsoft.com/office/drawing/2014/main" id="{C016B5F0-EDF4-4365-B5F0-DEBA3E4EF6FE}"/>
-              </a:ext>
-            </a:extLst>
-          </p:cNvPr>
-          <p:cNvSpPr>
-            <a:spLocks xmlns:a="http://schemas.openxmlformats.org/drawingml/2006/main" noGrp="1"/>
-          </p:cNvSpPr>
-          <p:nvPr/>
-        </p:nvSpPr>
-        <p:spPr>
-          <a:xfrm xmlns:a="http://schemas.openxmlformats.org/drawingml/2006/main">
-            <a:off x="2457450" y="5219700"/>
-            <a:ext cx="8763000" cy="609600"/>
+                <a16:creationId xmlns:a16="http://schemas.microsoft.com/office/drawing/2014/main" id="{D352AB67-A805-4A09-9669-032233480538}"/>
+              </a:ext>
+            </a:extLst>
+          </p:cNvPr>
+          <p:cNvSpPr>
+            <a:spLocks xmlns:a="http://schemas.openxmlformats.org/drawingml/2006/main" noGrp="1"/>
+          </p:cNvSpPr>
+          <p:nvPr/>
+        </p:nvSpPr>
+        <p:spPr>
+          <a:xfrm xmlns:a="http://schemas.openxmlformats.org/drawingml/2006/main">
+            <a:off x="3181350" y="2019300"/>
+            <a:ext cx="3714750" cy="285750"/>
           </a:xfrm>
           <a:prstGeom xmlns:a="http://schemas.openxmlformats.org/drawingml/2006/main" prst="rect">
             <a:avLst/>
@@ -8640,29 +8372,441 @@
           <a:lstStyle xmlns:a="http://schemas.openxmlformats.org/drawingml/2006/main"/>
           <a:p xmlns:a="http://schemas.openxmlformats.org/drawingml/2006/main">
             <a:pPr algn="l">
-              <a:defRPr sz="1575" b="0">
-                <a:solidFill>
-                  <a:srgbClr val="5F6368"/>
-                </a:solidFill>
-              </a:defRPr>
-            </a:pPr>
-            <a:r>
-              <a:rPr sz="1575" b="0">
-                <a:solidFill>
-                  <a:srgbClr val="5F6368"/>
-                </a:solidFill>
-              </a:rPr>
-              <a:t>The 75th percentile balances warning recall and false alarms, but it is not a universal definition of market danger.</a:t>
-            </a:r>
-          </a:p>
-        </p:txBody>
-      </p:sp>
-      <p:sp>
-        <p:nvSpPr>
-          <p:cNvPr id="7" name="source-footer">
-            <a:extLst xmlns:a="http://schemas.openxmlformats.org/drawingml/2006/main">
-              <a:ext uri="{FF2B5EF4-FFF2-40B4-BE49-F238E27FC236}">
-                <a16:creationId xmlns:a16="http://schemas.microsoft.com/office/drawing/2014/main" id="{C0932C5B-F4F5-451F-980B-BD65BD5042F1}"/>
+              <a:defRPr sz="1500" b="1">
+                <a:solidFill>
+                  <a:srgbClr val="111111"/>
+                </a:solidFill>
+              </a:defRPr>
+            </a:pPr>
+            <a:r>
+              <a:rPr sz="1500" b="1">
+                <a:solidFill>
+                  <a:srgbClr val="111111"/>
+                </a:solidFill>
+              </a:rPr>
+              <a:t>NON-OVERLAPPING RECALL</a:t>
+            </a:r>
+          </a:p>
+        </p:txBody>
+      </p:sp>
+      <p:sp>
+        <p:nvSpPr>
+          <p:cNvPr id="7" name="">
+            <a:extLst xmlns:a="http://schemas.openxmlformats.org/drawingml/2006/main">
+              <a:ext uri="{FF2B5EF4-FFF2-40B4-BE49-F238E27FC236}">
+                <a16:creationId xmlns:a16="http://schemas.microsoft.com/office/drawing/2014/main" id="{15470F50-05BB-4C84-B296-A574974DD8FC}"/>
+              </a:ext>
+            </a:extLst>
+          </p:cNvPr>
+          <p:cNvSpPr>
+            <a:spLocks xmlns:a="http://schemas.openxmlformats.org/drawingml/2006/main" noGrp="1"/>
+          </p:cNvSpPr>
+          <p:nvPr/>
+        </p:nvSpPr>
+        <p:spPr>
+          <a:xfrm xmlns:a="http://schemas.openxmlformats.org/drawingml/2006/main">
+            <a:off x="3181350" y="2343150"/>
+            <a:ext cx="8020050" cy="419100"/>
+          </a:xfrm>
+          <a:prstGeom xmlns:a="http://schemas.openxmlformats.org/drawingml/2006/main" prst="rect">
+            <a:avLst/>
+          </a:prstGeom>
+          <a:noFill xmlns:a="http://schemas.openxmlformats.org/drawingml/2006/main"/>
+          <a:ln xmlns:a="http://schemas.openxmlformats.org/drawingml/2006/main" w="0">
+            <a:noFill/>
+            <a:prstDash val="solid"/>
+          </a:ln>
+        </p:spPr>
+        <p:txBody>
+          <a:bodyPr xmlns:a="http://schemas.openxmlformats.org/drawingml/2006/main"/>
+          <a:lstStyle xmlns:a="http://schemas.openxmlformats.org/drawingml/2006/main"/>
+          <a:p xmlns:a="http://schemas.openxmlformats.org/drawingml/2006/main">
+            <a:pPr algn="l">
+              <a:defRPr sz="1350" b="0">
+                <a:solidFill>
+                  <a:srgbClr val="5F6368"/>
+                </a:solidFill>
+              </a:defRPr>
+            </a:pPr>
+            <a:r>
+              <a:rPr sz="1350" b="0">
+                <a:solidFill>
+                  <a:srgbClr val="5F6368"/>
+                </a:solidFill>
+              </a:rPr>
+              <a:t>Five offsets sample every fifth forecast window; no offset reverses the warning model's usefulness.</a:t>
+            </a:r>
+          </a:p>
+        </p:txBody>
+      </p:sp>
+      <p:sp>
+        <p:nvSpPr>
+          <p:cNvPr id="8" name="">
+            <a:extLst xmlns:a="http://schemas.openxmlformats.org/drawingml/2006/main">
+              <a:ext uri="{FF2B5EF4-FFF2-40B4-BE49-F238E27FC236}">
+                <a16:creationId xmlns:a16="http://schemas.microsoft.com/office/drawing/2014/main" id="{4E3EB5E7-1AD7-4F8B-B18C-C91EFABB843F}"/>
+              </a:ext>
+            </a:extLst>
+          </p:cNvPr>
+          <p:cNvSpPr>
+            <a:spLocks xmlns:a="http://schemas.openxmlformats.org/drawingml/2006/main" noGrp="1"/>
+          </p:cNvSpPr>
+          <p:nvPr/>
+        </p:nvSpPr>
+        <p:spPr>
+          <a:xfrm xmlns:a="http://schemas.openxmlformats.org/drawingml/2006/main">
+            <a:off x="495300" y="3181350"/>
+            <a:ext cx="11201400" cy="1066800"/>
+          </a:xfrm>
+          <a:prstGeom xmlns:a="http://schemas.openxmlformats.org/drawingml/2006/main" prst="rect">
+            <a:avLst/>
+          </a:prstGeom>
+          <a:solidFill xmlns:a="http://schemas.openxmlformats.org/drawingml/2006/main">
+            <a:srgbClr val="EAF5FB"/>
+          </a:solidFill>
+          <a:ln xmlns:a="http://schemas.openxmlformats.org/drawingml/2006/main" w="0">
+            <a:noFill/>
+            <a:prstDash val="solid"/>
+          </a:ln>
+        </p:spPr>
+      </p:sp>
+      <p:sp>
+        <p:nvSpPr>
+          <p:cNvPr id="9" name="">
+            <a:extLst xmlns:a="http://schemas.openxmlformats.org/drawingml/2006/main">
+              <a:ext uri="{FF2B5EF4-FFF2-40B4-BE49-F238E27FC236}">
+                <a16:creationId xmlns:a16="http://schemas.microsoft.com/office/drawing/2014/main" id="{A3569E1B-6AAA-40FA-9A9C-1D75FFE372A7}"/>
+              </a:ext>
+            </a:extLst>
+          </p:cNvPr>
+          <p:cNvSpPr>
+            <a:spLocks xmlns:a="http://schemas.openxmlformats.org/drawingml/2006/main" noGrp="1"/>
+          </p:cNvSpPr>
+          <p:nvPr/>
+        </p:nvSpPr>
+        <p:spPr>
+          <a:xfrm xmlns:a="http://schemas.openxmlformats.org/drawingml/2006/main">
+            <a:off x="742950" y="3390900"/>
+            <a:ext cx="2133600" cy="514350"/>
+          </a:xfrm>
+          <a:prstGeom xmlns:a="http://schemas.openxmlformats.org/drawingml/2006/main" prst="rect">
+            <a:avLst/>
+          </a:prstGeom>
+          <a:noFill xmlns:a="http://schemas.openxmlformats.org/drawingml/2006/main"/>
+          <a:ln xmlns:a="http://schemas.openxmlformats.org/drawingml/2006/main" w="0">
+            <a:noFill/>
+            <a:prstDash val="solid"/>
+          </a:ln>
+        </p:spPr>
+        <p:txBody>
+          <a:bodyPr xmlns:a="http://schemas.openxmlformats.org/drawingml/2006/main"/>
+          <a:lstStyle xmlns:a="http://schemas.openxmlformats.org/drawingml/2006/main"/>
+          <a:p xmlns:a="http://schemas.openxmlformats.org/drawingml/2006/main">
+            <a:pPr algn="l">
+              <a:defRPr sz="2550" b="1">
+                <a:solidFill>
+                  <a:srgbClr val="3D8DFF"/>
+                </a:solidFill>
+              </a:defRPr>
+            </a:pPr>
+            <a:r>
+              <a:rPr sz="2550" b="1">
+                <a:solidFill>
+                  <a:srgbClr val="3D8DFF"/>
+                </a:solidFill>
+              </a:rPr>
+              <a:t>74.1%</a:t>
+            </a:r>
+          </a:p>
+        </p:txBody>
+      </p:sp>
+      <p:sp>
+        <p:nvSpPr>
+          <p:cNvPr id="10" name="">
+            <a:extLst xmlns:a="http://schemas.openxmlformats.org/drawingml/2006/main">
+              <a:ext uri="{FF2B5EF4-FFF2-40B4-BE49-F238E27FC236}">
+                <a16:creationId xmlns:a16="http://schemas.microsoft.com/office/drawing/2014/main" id="{3821A62E-0623-43DC-823F-D9881B6C2214}"/>
+              </a:ext>
+            </a:extLst>
+          </p:cNvPr>
+          <p:cNvSpPr>
+            <a:spLocks xmlns:a="http://schemas.openxmlformats.org/drawingml/2006/main" noGrp="1"/>
+          </p:cNvSpPr>
+          <p:nvPr/>
+        </p:nvSpPr>
+        <p:spPr>
+          <a:xfrm xmlns:a="http://schemas.openxmlformats.org/drawingml/2006/main">
+            <a:off x="3181350" y="3371850"/>
+            <a:ext cx="3714750" cy="285750"/>
+          </a:xfrm>
+          <a:prstGeom xmlns:a="http://schemas.openxmlformats.org/drawingml/2006/main" prst="rect">
+            <a:avLst/>
+          </a:prstGeom>
+          <a:noFill xmlns:a="http://schemas.openxmlformats.org/drawingml/2006/main"/>
+          <a:ln xmlns:a="http://schemas.openxmlformats.org/drawingml/2006/main" w="0">
+            <a:noFill/>
+            <a:prstDash val="solid"/>
+          </a:ln>
+        </p:spPr>
+        <p:txBody>
+          <a:bodyPr xmlns:a="http://schemas.openxmlformats.org/drawingml/2006/main"/>
+          <a:lstStyle xmlns:a="http://schemas.openxmlformats.org/drawingml/2006/main"/>
+          <a:p xmlns:a="http://schemas.openxmlformats.org/drawingml/2006/main">
+            <a:pPr algn="l">
+              <a:defRPr sz="1500" b="1">
+                <a:solidFill>
+                  <a:srgbClr val="111111"/>
+                </a:solidFill>
+              </a:defRPr>
+            </a:pPr>
+            <a:r>
+              <a:rPr sz="1500" b="1">
+                <a:solidFill>
+                  <a:srgbClr val="111111"/>
+                </a:solidFill>
+              </a:rPr>
+              <a:t>WALK-FORWARD RECALL</a:t>
+            </a:r>
+          </a:p>
+        </p:txBody>
+      </p:sp>
+      <p:sp>
+        <p:nvSpPr>
+          <p:cNvPr id="11" name="">
+            <a:extLst xmlns:a="http://schemas.openxmlformats.org/drawingml/2006/main">
+              <a:ext uri="{FF2B5EF4-FFF2-40B4-BE49-F238E27FC236}">
+                <a16:creationId xmlns:a16="http://schemas.microsoft.com/office/drawing/2014/main" id="{31A0BA6F-530D-4D07-AE32-434144C9016D}"/>
+              </a:ext>
+            </a:extLst>
+          </p:cNvPr>
+          <p:cNvSpPr>
+            <a:spLocks xmlns:a="http://schemas.openxmlformats.org/drawingml/2006/main" noGrp="1"/>
+          </p:cNvSpPr>
+          <p:nvPr/>
+        </p:nvSpPr>
+        <p:spPr>
+          <a:xfrm xmlns:a="http://schemas.openxmlformats.org/drawingml/2006/main">
+            <a:off x="3181350" y="3695700"/>
+            <a:ext cx="8020050" cy="419100"/>
+          </a:xfrm>
+          <a:prstGeom xmlns:a="http://schemas.openxmlformats.org/drawingml/2006/main" prst="rect">
+            <a:avLst/>
+          </a:prstGeom>
+          <a:noFill xmlns:a="http://schemas.openxmlformats.org/drawingml/2006/main"/>
+          <a:ln xmlns:a="http://schemas.openxmlformats.org/drawingml/2006/main" w="0">
+            <a:noFill/>
+            <a:prstDash val="solid"/>
+          </a:ln>
+        </p:spPr>
+        <p:txBody>
+          <a:bodyPr xmlns:a="http://schemas.openxmlformats.org/drawingml/2006/main"/>
+          <a:lstStyle xmlns:a="http://schemas.openxmlformats.org/drawingml/2006/main"/>
+          <a:p xmlns:a="http://schemas.openxmlformats.org/drawingml/2006/main">
+            <a:pPr algn="l">
+              <a:defRPr sz="1350" b="0">
+                <a:solidFill>
+                  <a:srgbClr val="5F6368"/>
+                </a:solidFill>
+              </a:defRPr>
+            </a:pPr>
+            <a:r>
+              <a:rPr sz="1350" b="0">
+                <a:solidFill>
+                  <a:srgbClr val="5F6368"/>
+                </a:solidFill>
+              </a:rPr>
+              <a:t>Four expanding folds with a five-session embargo; balanced accuracy 79.3%.</a:t>
+            </a:r>
+          </a:p>
+        </p:txBody>
+      </p:sp>
+      <p:sp>
+        <p:nvSpPr>
+          <p:cNvPr id="12" name="">
+            <a:extLst xmlns:a="http://schemas.openxmlformats.org/drawingml/2006/main">
+              <a:ext uri="{FF2B5EF4-FFF2-40B4-BE49-F238E27FC236}">
+                <a16:creationId xmlns:a16="http://schemas.microsoft.com/office/drawing/2014/main" id="{6BEBE590-19CF-40E6-8697-5BFE418C1558}"/>
+              </a:ext>
+            </a:extLst>
+          </p:cNvPr>
+          <p:cNvSpPr>
+            <a:spLocks xmlns:a="http://schemas.openxmlformats.org/drawingml/2006/main" noGrp="1"/>
+          </p:cNvSpPr>
+          <p:nvPr/>
+        </p:nvSpPr>
+        <p:spPr>
+          <a:xfrm xmlns:a="http://schemas.openxmlformats.org/drawingml/2006/main">
+            <a:off x="495300" y="4533900"/>
+            <a:ext cx="11201400" cy="1066800"/>
+          </a:xfrm>
+          <a:prstGeom xmlns:a="http://schemas.openxmlformats.org/drawingml/2006/main" prst="rect">
+            <a:avLst/>
+          </a:prstGeom>
+          <a:solidFill xmlns:a="http://schemas.openxmlformats.org/drawingml/2006/main">
+            <a:srgbClr val="EDEDED"/>
+          </a:solidFill>
+          <a:ln xmlns:a="http://schemas.openxmlformats.org/drawingml/2006/main" w="0">
+            <a:noFill/>
+            <a:prstDash val="solid"/>
+          </a:ln>
+        </p:spPr>
+      </p:sp>
+      <p:sp>
+        <p:nvSpPr>
+          <p:cNvPr id="13" name="">
+            <a:extLst xmlns:a="http://schemas.openxmlformats.org/drawingml/2006/main">
+              <a:ext uri="{FF2B5EF4-FFF2-40B4-BE49-F238E27FC236}">
+                <a16:creationId xmlns:a16="http://schemas.microsoft.com/office/drawing/2014/main" id="{CE5870A3-A9B1-4E41-ADAE-B6BBE874E2C5}"/>
+              </a:ext>
+            </a:extLst>
+          </p:cNvPr>
+          <p:cNvSpPr>
+            <a:spLocks xmlns:a="http://schemas.openxmlformats.org/drawingml/2006/main" noGrp="1"/>
+          </p:cNvSpPr>
+          <p:nvPr/>
+        </p:nvSpPr>
+        <p:spPr>
+          <a:xfrm xmlns:a="http://schemas.openxmlformats.org/drawingml/2006/main">
+            <a:off x="742950" y="4743450"/>
+            <a:ext cx="2133600" cy="514350"/>
+          </a:xfrm>
+          <a:prstGeom xmlns:a="http://schemas.openxmlformats.org/drawingml/2006/main" prst="rect">
+            <a:avLst/>
+          </a:prstGeom>
+          <a:noFill xmlns:a="http://schemas.openxmlformats.org/drawingml/2006/main"/>
+          <a:ln xmlns:a="http://schemas.openxmlformats.org/drawingml/2006/main" w="0">
+            <a:noFill/>
+            <a:prstDash val="solid"/>
+          </a:ln>
+        </p:spPr>
+        <p:txBody>
+          <a:bodyPr xmlns:a="http://schemas.openxmlformats.org/drawingml/2006/main"/>
+          <a:lstStyle xmlns:a="http://schemas.openxmlformats.org/drawingml/2006/main"/>
+          <a:p xmlns:a="http://schemas.openxmlformats.org/drawingml/2006/main">
+            <a:pPr algn="l">
+              <a:defRPr sz="2550" b="1">
+                <a:solidFill>
+                  <a:srgbClr val="111111"/>
+                </a:solidFill>
+              </a:defRPr>
+            </a:pPr>
+            <a:r>
+              <a:rPr sz="2550" b="1">
+                <a:solidFill>
+                  <a:srgbClr val="111111"/>
+                </a:solidFill>
+              </a:rPr>
+              <a:t>+8.5 pp</a:t>
+            </a:r>
+          </a:p>
+        </p:txBody>
+      </p:sp>
+      <p:sp>
+        <p:nvSpPr>
+          <p:cNvPr id="14" name="">
+            <a:extLst xmlns:a="http://schemas.openxmlformats.org/drawingml/2006/main">
+              <a:ext uri="{FF2B5EF4-FFF2-40B4-BE49-F238E27FC236}">
+                <a16:creationId xmlns:a16="http://schemas.microsoft.com/office/drawing/2014/main" id="{DCE93229-1198-4A5A-8FBF-A9C415EEDB8A}"/>
+              </a:ext>
+            </a:extLst>
+          </p:cNvPr>
+          <p:cNvSpPr>
+            <a:spLocks xmlns:a="http://schemas.openxmlformats.org/drawingml/2006/main" noGrp="1"/>
+          </p:cNvSpPr>
+          <p:nvPr/>
+        </p:nvSpPr>
+        <p:spPr>
+          <a:xfrm xmlns:a="http://schemas.openxmlformats.org/drawingml/2006/main">
+            <a:off x="3181350" y="4724400"/>
+            <a:ext cx="3714750" cy="285750"/>
+          </a:xfrm>
+          <a:prstGeom xmlns:a="http://schemas.openxmlformats.org/drawingml/2006/main" prst="rect">
+            <a:avLst/>
+          </a:prstGeom>
+          <a:noFill xmlns:a="http://schemas.openxmlformats.org/drawingml/2006/main"/>
+          <a:ln xmlns:a="http://schemas.openxmlformats.org/drawingml/2006/main" w="0">
+            <a:noFill/>
+            <a:prstDash val="solid"/>
+          </a:ln>
+        </p:spPr>
+        <p:txBody>
+          <a:bodyPr xmlns:a="http://schemas.openxmlformats.org/drawingml/2006/main"/>
+          <a:lstStyle xmlns:a="http://schemas.openxmlformats.org/drawingml/2006/main"/>
+          <a:p xmlns:a="http://schemas.openxmlformats.org/drawingml/2006/main">
+            <a:pPr algn="l">
+              <a:defRPr sz="1500" b="1">
+                <a:solidFill>
+                  <a:srgbClr val="111111"/>
+                </a:solidFill>
+              </a:defRPr>
+            </a:pPr>
+            <a:r>
+              <a:rPr sz="1500" b="1">
+                <a:solidFill>
+                  <a:srgbClr val="111111"/>
+                </a:solidFill>
+              </a:rPr>
+              <a:t>TOP-DECILE UNDERPREDICTION</a:t>
+            </a:r>
+          </a:p>
+        </p:txBody>
+      </p:sp>
+      <p:sp>
+        <p:nvSpPr>
+          <p:cNvPr id="15" name="">
+            <a:extLst xmlns:a="http://schemas.openxmlformats.org/drawingml/2006/main">
+              <a:ext uri="{FF2B5EF4-FFF2-40B4-BE49-F238E27FC236}">
+                <a16:creationId xmlns:a16="http://schemas.microsoft.com/office/drawing/2014/main" id="{12A3BD33-8812-412B-A529-CD80C177057A}"/>
+              </a:ext>
+            </a:extLst>
+          </p:cNvPr>
+          <p:cNvSpPr>
+            <a:spLocks xmlns:a="http://schemas.openxmlformats.org/drawingml/2006/main" noGrp="1"/>
+          </p:cNvSpPr>
+          <p:nvPr/>
+        </p:nvSpPr>
+        <p:spPr>
+          <a:xfrm xmlns:a="http://schemas.openxmlformats.org/drawingml/2006/main">
+            <a:off x="3181350" y="5048250"/>
+            <a:ext cx="8020050" cy="419100"/>
+          </a:xfrm>
+          <a:prstGeom xmlns:a="http://schemas.openxmlformats.org/drawingml/2006/main" prst="rect">
+            <a:avLst/>
+          </a:prstGeom>
+          <a:noFill xmlns:a="http://schemas.openxmlformats.org/drawingml/2006/main"/>
+          <a:ln xmlns:a="http://schemas.openxmlformats.org/drawingml/2006/main" w="0">
+            <a:noFill/>
+            <a:prstDash val="solid"/>
+          </a:ln>
+        </p:spPr>
+        <p:txBody>
+          <a:bodyPr xmlns:a="http://schemas.openxmlformats.org/drawingml/2006/main"/>
+          <a:lstStyle xmlns:a="http://schemas.openxmlformats.org/drawingml/2006/main"/>
+          <a:p xmlns:a="http://schemas.openxmlformats.org/drawingml/2006/main">
+            <a:pPr algn="l">
+              <a:defRPr sz="1350" b="0">
+                <a:solidFill>
+                  <a:srgbClr val="5F6368"/>
+                </a:solidFill>
+              </a:defRPr>
+            </a:pPr>
+            <a:r>
+              <a:rPr sz="1350" b="0">
+                <a:solidFill>
+                  <a:srgbClr val="5F6368"/>
+                </a:solidFill>
+              </a:rPr>
+              <a:t>Ridge understates the most volatile windows, so tail-risk decisions still require human judgment.</a:t>
+            </a:r>
+          </a:p>
+        </p:txBody>
+      </p:sp>
+      <p:sp>
+        <p:nvSpPr>
+          <p:cNvPr id="16" name="source-footer">
+            <a:extLst xmlns:a="http://schemas.openxmlformats.org/drawingml/2006/main">
+              <a:ext uri="{FF2B5EF4-FFF2-40B4-BE49-F238E27FC236}">
+                <a16:creationId xmlns:a16="http://schemas.microsoft.com/office/drawing/2014/main" id="{9E035846-F58A-4324-B526-24817CD9A2B0}"/>
               </a:ext>
             </a:extLst>
           </p:cNvPr>
@@ -8702,17 +8846,17 @@
                   <a:srgbClr val="5F6368"/>
                 </a:solidFill>
               </a:rPr>
-              <a:t>Sensitivity: thresholds estimated only from training observations</a:t>
-            </a:r>
-          </a:p>
-        </p:txBody>
-      </p:sp>
-      <p:sp>
-        <p:nvSpPr>
-          <p:cNvPr id="8" name="slide-number">
-            <a:extLst xmlns:a="http://schemas.openxmlformats.org/drawingml/2006/main">
-              <a:ext uri="{FF2B5EF4-FFF2-40B4-BE49-F238E27FC236}">
-                <a16:creationId xmlns:a16="http://schemas.microsoft.com/office/drawing/2014/main" id="{2D887865-1DC7-4851-A582-8862C7BFD374}"/>
+              <a:t>Also tested: 70%–80% risk quantiles, alternate feature windows, and outlier-flag ablation</a:t>
+            </a:r>
+          </a:p>
+        </p:txBody>
+      </p:sp>
+      <p:sp>
+        <p:nvSpPr>
+          <p:cNvPr id="17" name="slide-number">
+            <a:extLst xmlns:a="http://schemas.openxmlformats.org/drawingml/2006/main">
+              <a:ext uri="{FF2B5EF4-FFF2-40B4-BE49-F238E27FC236}">
+                <a16:creationId xmlns:a16="http://schemas.microsoft.com/office/drawing/2014/main" id="{2829962F-E949-4E0F-BEF9-D4BD1EE60CED}"/>
               </a:ext>
             </a:extLst>
           </p:cNvPr>
@@ -8760,7 +8904,7 @@
     </p:spTree>
     <p:extLst>
       <p:ext uri="{BB962C8B-B14F-4D97-AF65-F5344CB8AC3E}">
-        <p14:creationId xmlns:p14="http://schemas.microsoft.com/office/powerpoint/2010/main" val="1624927183"/>
+        <p14:creationId xmlns:p14="http://schemas.microsoft.com/office/powerpoint/2010/main" val="1628543782"/>
       </p:ext>
     </p:extLst>
   </p:cSld>
@@ -8791,7 +8935,7 @@
           <p:cNvPr id="12" name="slide-title">
             <a:extLst xmlns:a="http://schemas.openxmlformats.org/drawingml/2006/main">
               <a:ext uri="{FF2B5EF4-FFF2-40B4-BE49-F238E27FC236}">
-                <a16:creationId xmlns:a16="http://schemas.microsoft.com/office/drawing/2014/main" id="{CE74CC14-852C-46BE-89C1-E2AB97DC33CB}"/>
+                <a16:creationId xmlns:a16="http://schemas.microsoft.com/office/drawing/2014/main" id="{C5E6E17A-E71F-4788-9C2C-998651B28A37}"/>
               </a:ext>
             </a:extLst>
           </p:cNvPr>
@@ -8841,7 +8985,7 @@
           <p:cNvPr id="2" name="title-rule">
             <a:extLst xmlns:a="http://schemas.openxmlformats.org/drawingml/2006/main">
               <a:ext uri="{FF2B5EF4-FFF2-40B4-BE49-F238E27FC236}">
-                <a16:creationId xmlns:a16="http://schemas.microsoft.com/office/drawing/2014/main" id="{98FB1ADE-DA8D-4D0A-AFEB-A8FC1530FF6E}"/>
+                <a16:creationId xmlns:a16="http://schemas.microsoft.com/office/drawing/2014/main" id="{E778ECDA-D2CD-4C6C-A76A-0F042BE94CAC}"/>
               </a:ext>
             </a:extLst>
           </p:cNvPr>
@@ -8872,7 +9016,7 @@
           <p:cNvPr id="3" name="">
             <a:extLst xmlns:a="http://schemas.openxmlformats.org/drawingml/2006/main">
               <a:ext uri="{FF2B5EF4-FFF2-40B4-BE49-F238E27FC236}">
-                <a16:creationId xmlns:a16="http://schemas.microsoft.com/office/drawing/2014/main" id="{AA8B45C5-9E3E-43C2-832F-6B3AFA3F7AE3}"/>
+                <a16:creationId xmlns:a16="http://schemas.microsoft.com/office/drawing/2014/main" id="{4BD1EA8B-9689-4C30-9625-F1B67BDB986F}"/>
               </a:ext>
             </a:extLst>
           </p:cNvPr>
@@ -8922,7 +9066,7 @@
           <p:cNvPr id="4" name="">
             <a:extLst xmlns:a="http://schemas.openxmlformats.org/drawingml/2006/main">
               <a:ext uri="{FF2B5EF4-FFF2-40B4-BE49-F238E27FC236}">
-                <a16:creationId xmlns:a16="http://schemas.microsoft.com/office/drawing/2014/main" id="{8BCC03D5-448F-4AB2-9CCE-1C269938F9BA}"/>
+                <a16:creationId xmlns:a16="http://schemas.microsoft.com/office/drawing/2014/main" id="{EFCD8AE7-6FC5-4999-87B4-6F16BAEC5367}"/>
               </a:ext>
             </a:extLst>
           </p:cNvPr>
@@ -8972,7 +9116,7 @@
           <p:cNvPr id="5" name="">
             <a:extLst xmlns:a="http://schemas.openxmlformats.org/drawingml/2006/main">
               <a:ext uri="{FF2B5EF4-FFF2-40B4-BE49-F238E27FC236}">
-                <a16:creationId xmlns:a16="http://schemas.microsoft.com/office/drawing/2014/main" id="{D4D4D75B-A628-4062-BD6A-2D5D353D1018}"/>
+                <a16:creationId xmlns:a16="http://schemas.microsoft.com/office/drawing/2014/main" id="{8EB2AD18-5BF3-4058-96B3-DF44D581328A}"/>
               </a:ext>
             </a:extLst>
           </p:cNvPr>
@@ -9022,7 +9166,7 @@
           <p:cNvPr id="6" name="">
             <a:extLst xmlns:a="http://schemas.openxmlformats.org/drawingml/2006/main">
               <a:ext uri="{FF2B5EF4-FFF2-40B4-BE49-F238E27FC236}">
-                <a16:creationId xmlns:a16="http://schemas.microsoft.com/office/drawing/2014/main" id="{642C9DCE-FAD5-41A3-BBA8-D7D95E90297D}"/>
+                <a16:creationId xmlns:a16="http://schemas.microsoft.com/office/drawing/2014/main" id="{5D120BBF-914C-4D44-ACE9-04499E85AABB}"/>
               </a:ext>
             </a:extLst>
           </p:cNvPr>
@@ -9072,7 +9216,7 @@
           <p:cNvPr id="7" name="">
             <a:extLst xmlns:a="http://schemas.openxmlformats.org/drawingml/2006/main">
               <a:ext uri="{FF2B5EF4-FFF2-40B4-BE49-F238E27FC236}">
-                <a16:creationId xmlns:a16="http://schemas.microsoft.com/office/drawing/2014/main" id="{F55C1141-9B92-4446-9F2F-8766E95F1655}"/>
+                <a16:creationId xmlns:a16="http://schemas.microsoft.com/office/drawing/2014/main" id="{56F695F0-D11F-4D96-AADD-ED2808220F26}"/>
               </a:ext>
             </a:extLst>
           </p:cNvPr>
@@ -9129,7 +9273,7 @@
         </p:xfrm>
         <a:graphic xmlns:a="http://schemas.openxmlformats.org/drawingml/2006/main">
           <a:graphicData uri="http://schemas.openxmlformats.org/drawingml/2006/chart">
-            <c:chart xmlns:r="http://schemas.openxmlformats.org/officeDocument/2006/relationships" xmlns:c="http://schemas.openxmlformats.org/drawingml/2006/chart" r:id="R93864e77772b451a"/>
+            <c:chart xmlns:r="http://schemas.openxmlformats.org/officeDocument/2006/relationships" xmlns:c="http://schemas.openxmlformats.org/drawingml/2006/chart" r:id="Raf06eb0f4fa44b94"/>
           </a:graphicData>
         </a:graphic>
       </p:graphicFrame>
@@ -9138,19 +9282,19 @@
           <p:cNvPr id="9" name="">
             <a:extLst xmlns:a="http://schemas.openxmlformats.org/drawingml/2006/main">
               <a:ext uri="{FF2B5EF4-FFF2-40B4-BE49-F238E27FC236}">
-                <a16:creationId xmlns:a16="http://schemas.microsoft.com/office/drawing/2014/main" id="{74C60384-C55E-4DA0-8AE7-C4412FAE51BD}"/>
-              </a:ext>
-            </a:extLst>
-          </p:cNvPr>
-          <p:cNvSpPr>
-            <a:spLocks xmlns:a="http://schemas.openxmlformats.org/drawingml/2006/main" noGrp="1"/>
-          </p:cNvSpPr>
-          <p:nvPr/>
-        </p:nvSpPr>
-        <p:spPr>
-          <a:xfrm xmlns:a="http://schemas.openxmlformats.org/drawingml/2006/main">
-            <a:off x="6781800" y="5638800"/>
-            <a:ext cx="4286250" cy="323850"/>
+                <a16:creationId xmlns:a16="http://schemas.microsoft.com/office/drawing/2014/main" id="{883D007B-D91C-4103-8764-80F17E37887C}"/>
+              </a:ext>
+            </a:extLst>
+          </p:cNvPr>
+          <p:cNvSpPr>
+            <a:spLocks xmlns:a="http://schemas.openxmlformats.org/drawingml/2006/main" noGrp="1"/>
+          </p:cNvSpPr>
+          <p:nvPr/>
+        </p:nvSpPr>
+        <p:spPr>
+          <a:xfrm xmlns:a="http://schemas.openxmlformats.org/drawingml/2006/main">
+            <a:off x="6400800" y="5638800"/>
+            <a:ext cx="5048250" cy="323850"/>
           </a:xfrm>
           <a:prstGeom xmlns:a="http://schemas.openxmlformats.org/drawingml/2006/main" prst="rect">
             <a:avLst/>
@@ -9178,7 +9322,7 @@
                   <a:srgbClr val="111111"/>
                 </a:solidFill>
               </a:rPr>
-              <a:t>Elevated-risk probability: 22.2%</a:t>
+              <a:t>Risk score: 25.2% · elevated at 50%</a:t>
             </a:r>
           </a:p>
         </p:txBody>
@@ -9188,7 +9332,7 @@
           <p:cNvPr id="10" name="source-footer">
             <a:extLst xmlns:a="http://schemas.openxmlformats.org/drawingml/2006/main">
               <a:ext uri="{FF2B5EF4-FFF2-40B4-BE49-F238E27FC236}">
-                <a16:creationId xmlns:a16="http://schemas.microsoft.com/office/drawing/2014/main" id="{E82B1CB1-870C-4301-96F3-F3D0F686B234}"/>
+                <a16:creationId xmlns:a16="http://schemas.microsoft.com/office/drawing/2014/main" id="{0FF25A67-2CCB-42BA-B3D7-9006C605424E}"/>
               </a:ext>
             </a:extLst>
           </p:cNvPr>
@@ -9238,7 +9382,7 @@
           <p:cNvPr id="11" name="slide-number">
             <a:extLst xmlns:a="http://schemas.openxmlformats.org/drawingml/2006/main">
               <a:ext uri="{FF2B5EF4-FFF2-40B4-BE49-F238E27FC236}">
-                <a16:creationId xmlns:a16="http://schemas.microsoft.com/office/drawing/2014/main" id="{2BC164CA-787C-435B-B108-81AD234C4A8D}"/>
+                <a16:creationId xmlns:a16="http://schemas.microsoft.com/office/drawing/2014/main" id="{B01AB558-5219-40DA-B8B0-8A4FB1645E23}"/>
               </a:ext>
             </a:extLst>
           </p:cNvPr>
@@ -9286,7 +9430,7 @@
     </p:spTree>
     <p:extLst>
       <p:ext uri="{BB962C8B-B14F-4D97-AF65-F5344CB8AC3E}">
-        <p14:creationId xmlns:p14="http://schemas.microsoft.com/office/powerpoint/2010/main" val="1836972355"/>
+        <p14:creationId xmlns:p14="http://schemas.microsoft.com/office/powerpoint/2010/main" val="1548212541"/>
       </p:ext>
     </p:extLst>
   </p:cSld>
@@ -9317,7 +9461,7 @@
           <p:cNvPr id="17" name="slide-title">
             <a:extLst xmlns:a="http://schemas.openxmlformats.org/drawingml/2006/main">
               <a:ext uri="{FF2B5EF4-FFF2-40B4-BE49-F238E27FC236}">
-                <a16:creationId xmlns:a16="http://schemas.microsoft.com/office/drawing/2014/main" id="{5D91210A-F7A8-4AC3-B09F-C5730E813A83}"/>
+                <a16:creationId xmlns:a16="http://schemas.microsoft.com/office/drawing/2014/main" id="{455A281B-5CB0-44B0-9E76-0613DBD07EBE}"/>
               </a:ext>
             </a:extLst>
           </p:cNvPr>
@@ -9367,7 +9511,7 @@
           <p:cNvPr id="2" name="title-rule">
             <a:extLst xmlns:a="http://schemas.openxmlformats.org/drawingml/2006/main">
               <a:ext uri="{FF2B5EF4-FFF2-40B4-BE49-F238E27FC236}">
-                <a16:creationId xmlns:a16="http://schemas.microsoft.com/office/drawing/2014/main" id="{F3654C6F-9B98-47E8-81D5-30ED2FE4C09D}"/>
+                <a16:creationId xmlns:a16="http://schemas.microsoft.com/office/drawing/2014/main" id="{D31152EC-2A6A-4B66-A0AB-11B7AAF96597}"/>
               </a:ext>
             </a:extLst>
           </p:cNvPr>
@@ -9398,7 +9542,7 @@
           <p:cNvPr id="3" name="">
             <a:extLst xmlns:a="http://schemas.openxmlformats.org/drawingml/2006/main">
               <a:ext uri="{FF2B5EF4-FFF2-40B4-BE49-F238E27FC236}">
-                <a16:creationId xmlns:a16="http://schemas.microsoft.com/office/drawing/2014/main" id="{B5DF1D98-7FD2-4A65-A74E-25B6920EC603}"/>
+                <a16:creationId xmlns:a16="http://schemas.microsoft.com/office/drawing/2014/main" id="{D5188FE3-79C5-471C-BD5E-925F734DC161}"/>
               </a:ext>
             </a:extLst>
           </p:cNvPr>
@@ -9429,7 +9573,7 @@
           <p:cNvPr id="4" name="">
             <a:extLst xmlns:a="http://schemas.openxmlformats.org/drawingml/2006/main">
               <a:ext uri="{FF2B5EF4-FFF2-40B4-BE49-F238E27FC236}">
-                <a16:creationId xmlns:a16="http://schemas.microsoft.com/office/drawing/2014/main" id="{DFEA5F90-DF4C-4E25-8BF4-E906E183A1F1}"/>
+                <a16:creationId xmlns:a16="http://schemas.microsoft.com/office/drawing/2014/main" id="{7D2A724C-92E2-4B19-9E6E-114B5970CF3A}"/>
               </a:ext>
             </a:extLst>
           </p:cNvPr>
@@ -9479,7 +9623,7 @@
           <p:cNvPr id="5" name="">
             <a:extLst xmlns:a="http://schemas.openxmlformats.org/drawingml/2006/main">
               <a:ext uri="{FF2B5EF4-FFF2-40B4-BE49-F238E27FC236}">
-                <a16:creationId xmlns:a16="http://schemas.microsoft.com/office/drawing/2014/main" id="{29294A5C-9849-4548-BAF4-328030C4F850}"/>
+                <a16:creationId xmlns:a16="http://schemas.microsoft.com/office/drawing/2014/main" id="{BDBDA223-242A-4909-804C-F106CAF71B02}"/>
               </a:ext>
             </a:extLst>
           </p:cNvPr>
@@ -9529,7 +9673,7 @@
           <p:cNvPr id="6" name="">
             <a:extLst xmlns:a="http://schemas.openxmlformats.org/drawingml/2006/main">
               <a:ext uri="{FF2B5EF4-FFF2-40B4-BE49-F238E27FC236}">
-                <a16:creationId xmlns:a16="http://schemas.microsoft.com/office/drawing/2014/main" id="{FC2AE36E-184F-4BE2-BB15-33BA26CDFE82}"/>
+                <a16:creationId xmlns:a16="http://schemas.microsoft.com/office/drawing/2014/main" id="{A8DAFB97-7497-4BB2-9DE8-B8265E0D7386}"/>
               </a:ext>
             </a:extLst>
           </p:cNvPr>
@@ -9560,7 +9704,7 @@
           <p:cNvPr id="7" name="">
             <a:extLst xmlns:a="http://schemas.openxmlformats.org/drawingml/2006/main">
               <a:ext uri="{FF2B5EF4-FFF2-40B4-BE49-F238E27FC236}">
-                <a16:creationId xmlns:a16="http://schemas.microsoft.com/office/drawing/2014/main" id="{249214DC-5071-4E9A-AFB8-527F3B88CC52}"/>
+                <a16:creationId xmlns:a16="http://schemas.microsoft.com/office/drawing/2014/main" id="{848B60C8-4DB2-4075-95F6-D6D97BFDF4CF}"/>
               </a:ext>
             </a:extLst>
           </p:cNvPr>
@@ -9610,7 +9754,7 @@
           <p:cNvPr id="8" name="">
             <a:extLst xmlns:a="http://schemas.openxmlformats.org/drawingml/2006/main">
               <a:ext uri="{FF2B5EF4-FFF2-40B4-BE49-F238E27FC236}">
-                <a16:creationId xmlns:a16="http://schemas.microsoft.com/office/drawing/2014/main" id="{9C66DD70-8518-4BD2-9AE1-0EEFAA838D6E}"/>
+                <a16:creationId xmlns:a16="http://schemas.microsoft.com/office/drawing/2014/main" id="{88A6A63F-A8CC-4E1C-8753-8367EE42E7F6}"/>
               </a:ext>
             </a:extLst>
           </p:cNvPr>
@@ -9660,7 +9804,7 @@
           <p:cNvPr id="9" name="">
             <a:extLst xmlns:a="http://schemas.openxmlformats.org/drawingml/2006/main">
               <a:ext uri="{FF2B5EF4-FFF2-40B4-BE49-F238E27FC236}">
-                <a16:creationId xmlns:a16="http://schemas.microsoft.com/office/drawing/2014/main" id="{8F193CE6-A9DB-4F18-BDD2-CA86BFC6BE32}"/>
+                <a16:creationId xmlns:a16="http://schemas.microsoft.com/office/drawing/2014/main" id="{82CCEB89-AA30-41D6-8D86-D773CBFA7B3E}"/>
               </a:ext>
             </a:extLst>
           </p:cNvPr>
@@ -9691,7 +9835,7 @@
           <p:cNvPr id="10" name="">
             <a:extLst xmlns:a="http://schemas.openxmlformats.org/drawingml/2006/main">
               <a:ext uri="{FF2B5EF4-FFF2-40B4-BE49-F238E27FC236}">
-                <a16:creationId xmlns:a16="http://schemas.microsoft.com/office/drawing/2014/main" id="{73F1A856-2011-4A36-AE67-F145A54A4A18}"/>
+                <a16:creationId xmlns:a16="http://schemas.microsoft.com/office/drawing/2014/main" id="{0ADCEA17-28A7-46A2-BBFE-FE4431BB9E04}"/>
               </a:ext>
             </a:extLst>
           </p:cNvPr>
@@ -9731,7 +9875,7 @@
                   <a:srgbClr val="111111"/>
                 </a:solidFill>
               </a:rPr>
-              <a:t>THRESHOLD CHOICE</a:t>
+              <a:t>SCORE CALIBRATION</a:t>
             </a:r>
           </a:p>
         </p:txBody>
@@ -9741,7 +9885,7 @@
           <p:cNvPr id="11" name="">
             <a:extLst xmlns:a="http://schemas.openxmlformats.org/drawingml/2006/main">
               <a:ext uri="{FF2B5EF4-FFF2-40B4-BE49-F238E27FC236}">
-                <a16:creationId xmlns:a16="http://schemas.microsoft.com/office/drawing/2014/main" id="{11290204-5B5B-4EC8-9845-AD05EA901395}"/>
+                <a16:creationId xmlns:a16="http://schemas.microsoft.com/office/drawing/2014/main" id="{D3E79BFC-20C3-4F4D-B8BA-48DE7847ED90}"/>
               </a:ext>
             </a:extLst>
           </p:cNvPr>
@@ -9781,7 +9925,7 @@
                   <a:srgbClr val="5F6368"/>
                 </a:solidFill>
               </a:rPr>
-              <a:t>Precision and recall move as the risk quantile changes.</a:t>
+              <a:t>Class weighting makes the output a risk score—not a literal probability.</a:t>
             </a:r>
           </a:p>
         </p:txBody>
@@ -9791,7 +9935,7 @@
           <p:cNvPr id="12" name="">
             <a:extLst xmlns:a="http://schemas.openxmlformats.org/drawingml/2006/main">
               <a:ext uri="{FF2B5EF4-FFF2-40B4-BE49-F238E27FC236}">
-                <a16:creationId xmlns:a16="http://schemas.microsoft.com/office/drawing/2014/main" id="{7D19C95D-F0E2-49FD-9459-D27DFB44D62C}"/>
+                <a16:creationId xmlns:a16="http://schemas.microsoft.com/office/drawing/2014/main" id="{F73147C5-7604-4831-8B6C-5FAA6246EB26}"/>
               </a:ext>
             </a:extLst>
           </p:cNvPr>
@@ -9822,7 +9966,7 @@
           <p:cNvPr id="13" name="">
             <a:extLst xmlns:a="http://schemas.openxmlformats.org/drawingml/2006/main">
               <a:ext uri="{FF2B5EF4-FFF2-40B4-BE49-F238E27FC236}">
-                <a16:creationId xmlns:a16="http://schemas.microsoft.com/office/drawing/2014/main" id="{CE563A3C-FECB-47B3-8DED-990AC9EA901D}"/>
+                <a16:creationId xmlns:a16="http://schemas.microsoft.com/office/drawing/2014/main" id="{DA269DBB-44AA-47DE-B9C6-4B976BAE4AAB}"/>
               </a:ext>
             </a:extLst>
           </p:cNvPr>
@@ -9862,7 +10006,7 @@
                   <a:srgbClr val="111111"/>
                 </a:solidFill>
               </a:rPr>
-              <a:t>PROVIDER REVISION</a:t>
+              <a:t>TAIL UNDERPREDICTION</a:t>
             </a:r>
           </a:p>
         </p:txBody>
@@ -9872,7 +10016,7 @@
           <p:cNvPr id="14" name="">
             <a:extLst xmlns:a="http://schemas.openxmlformats.org/drawingml/2006/main">
               <a:ext uri="{FF2B5EF4-FFF2-40B4-BE49-F238E27FC236}">
-                <a16:creationId xmlns:a16="http://schemas.microsoft.com/office/drawing/2014/main" id="{8E6048B2-59DF-43C7-B490-BF166D199EDD}"/>
+                <a16:creationId xmlns:a16="http://schemas.microsoft.com/office/drawing/2014/main" id="{921F1804-3569-4703-B8A1-468B5515C39B}"/>
               </a:ext>
             </a:extLst>
           </p:cNvPr>
@@ -9912,7 +10056,7 @@
                   <a:srgbClr val="5F6368"/>
                 </a:solidFill>
               </a:rPr>
-              <a:t>Adjusted prices and source schemas may change after retrieval.</a:t>
+              <a:t>Ridge understates the most volatile forecast windows.</a:t>
             </a:r>
           </a:p>
         </p:txBody>
@@ -9922,7 +10066,7 @@
           <p:cNvPr id="15" name="source-footer">
             <a:extLst xmlns:a="http://schemas.openxmlformats.org/drawingml/2006/main">
               <a:ext uri="{FF2B5EF4-FFF2-40B4-BE49-F238E27FC236}">
-                <a16:creationId xmlns:a16="http://schemas.microsoft.com/office/drawing/2014/main" id="{9CD19050-897E-4906-83BC-AD5BEBF0F1D8}"/>
+                <a16:creationId xmlns:a16="http://schemas.microsoft.com/office/drawing/2014/main" id="{A3DADC8E-37C2-4783-A4A6-6028795A5532}"/>
               </a:ext>
             </a:extLst>
           </p:cNvPr>
@@ -9962,7 +10106,7 @@
                   <a:srgbClr val="5F6368"/>
                 </a:solidFill>
               </a:rPr>
-              <a:t>Mitigations: immutable data, validation, chronological tests, sensitivity, explicit caveats</a:t>
+              <a:t>Mitigations: hash validation, purged tests, walk-forward checks, tail diagnostics, explicit caveats</a:t>
             </a:r>
           </a:p>
         </p:txBody>
@@ -9972,7 +10116,7 @@
           <p:cNvPr id="16" name="slide-number">
             <a:extLst xmlns:a="http://schemas.openxmlformats.org/drawingml/2006/main">
               <a:ext uri="{FF2B5EF4-FFF2-40B4-BE49-F238E27FC236}">
-                <a16:creationId xmlns:a16="http://schemas.microsoft.com/office/drawing/2014/main" id="{182027E5-BD7F-46ED-92CC-27EAC1A7D2B0}"/>
+                <a16:creationId xmlns:a16="http://schemas.microsoft.com/office/drawing/2014/main" id="{8D636F51-E498-4D99-A99C-EBF9380FFF1A}"/>
               </a:ext>
             </a:extLst>
           </p:cNvPr>
@@ -10020,7 +10164,7 @@
     </p:spTree>
     <p:extLst>
       <p:ext uri="{BB962C8B-B14F-4D97-AF65-F5344CB8AC3E}">
-        <p14:creationId xmlns:p14="http://schemas.microsoft.com/office/powerpoint/2010/main" val="1658210526"/>
+        <p14:creationId xmlns:p14="http://schemas.microsoft.com/office/powerpoint/2010/main" val="1245435886"/>
       </p:ext>
     </p:extLst>
   </p:cSld>

</xml_diff>

<commit_message>
Reword the authorship line
</commit_message>
<xml_diff>
--- a/project/reports/stakeholder_presentation.pptx
+++ b/project/reports/stakeholder_presentation.pptx
@@ -5823,7 +5823,7 @@
               </a:defRPr>
             </a:pPr>
             <a:r>
-              <a:t>Paritosh Dwivedi · Sole author</a:t>
+              <a:t>Paritosh Dwivedi · Author</a:t>
             </a:r>
           </a:p>
           <a:p>
@@ -6393,7 +6393,7 @@
               </a:defRPr>
             </a:pPr>
             <a:r>
-              <a:t>Paritosh Dwivedi · Sole author</a:t>
+              <a:t>Paritosh Dwivedi · Author</a:t>
             </a:r>
           </a:p>
         </p:txBody>

</xml_diff>

<commit_message>
Add project stages 07 to 09
</commit_message>
<xml_diff>
--- a/project/reports/stakeholder_presentation.pptx
+++ b/project/reports/stakeholder_presentation.pptx
@@ -161,7 +161,7 @@
                   <c:v>2023-10</c:v>
                 </c:pt>
                 <c:pt idx="2">
-                  <c:v>2023-11</c:v>
+                  <c:v>2023-12</c:v>
                 </c:pt>
                 <c:pt idx="3">
                   <c:v>2024-01</c:v>
@@ -197,7 +197,7 @@
                   <c:v>2025-08</c:v>
                 </c:pt>
                 <c:pt idx="14">
-                  <c:v>2025-09</c:v>
+                  <c:v>2025-10</c:v>
                 </c:pt>
                 <c:pt idx="15">
                   <c:v>2025-11</c:v>
@@ -212,7 +212,7 @@
                   <c:v>2026-05</c:v>
                 </c:pt>
                 <c:pt idx="19">
-                  <c:v>2026-06</c:v>
+                  <c:v>2026-07</c:v>
                 </c:pt>
                 <c:pt idx="20">
                   <c:v>2026-08</c:v>
@@ -227,67 +227,67 @@
                 <c:formatCode>General</c:formatCode>
                 <c:ptCount val="21"/>
                 <c:pt idx="0">
-                  <c:v>429.3385925292969</c:v>
+                  <c:v>420.3211364746094</c:v>
                 </c:pt>
                 <c:pt idx="1">
-                  <c:v>410.4052734375</c:v>
+                  <c:v>421.832763671875</c:v>
                 </c:pt>
                 <c:pt idx="2">
-                  <c:v>439.51556396484375</c:v>
+                  <c:v>441.439453125</c:v>
                 </c:pt>
                 <c:pt idx="3">
-                  <c:v>473.73883056640625</c:v>
+                  <c:v>468.7396545410156</c:v>
                 </c:pt>
                 <c:pt idx="4">
-                  <c:v>506.8083190917969</c:v>
+                  <c:v>505.18231201171875</c:v>
                 </c:pt>
                 <c:pt idx="5">
-                  <c:v>509.5543518066406</c:v>
+                  <c:v>516.13671875</c:v>
                 </c:pt>
                 <c:pt idx="6">
-                  <c:v>548.3388671875</c:v>
+                  <c:v>551.7969970703125</c:v>
                 </c:pt>
                 <c:pt idx="7">
-                  <c:v>539.3126220703125</c:v>
+                  <c:v>533.7737426757812</c:v>
                 </c:pt>
                 <c:pt idx="8">
-                  <c:v>567.3840942382812</c:v>
+                  <c:v>557.1934814453125</c:v>
                 </c:pt>
                 <c:pt idx="9">
-                  <c:v>574.302001953125</c:v>
+                  <c:v>591.2184448242188</c:v>
                 </c:pt>
                 <c:pt idx="10">
-                  <c:v>601.1975708007812</c:v>
+                  <c:v>587.1578979492188</c:v>
                 </c:pt>
                 <c:pt idx="11">
-                  <c:v>526.5321044921875</c:v>
+                  <c:v>519.1064453125</c:v>
                 </c:pt>
                 <c:pt idx="12">
-                  <c:v>590.8275146484375</c:v>
+                  <c:v>595.37353515625</c:v>
                 </c:pt>
                 <c:pt idx="13">
-                  <c:v>614.9066162109375</c:v>
+                  <c:v>625.3212890625</c:v>
                 </c:pt>
                 <c:pt idx="14">
-                  <c:v>652.6429443359375</c:v>
+                  <c:v>662.95751953125</c:v>
                 </c:pt>
                 <c:pt idx="15">
-                  <c:v>654.65625</c:v>
+                  <c:v>663.235107421875</c:v>
                 </c:pt>
                 <c:pt idx="16">
-                  <c:v>686.7106323242188</c:v>
+                  <c:v>681.77685546875</c:v>
                 </c:pt>
                 <c:pt idx="17">
-                  <c:v>672.7548217773438</c:v>
+                  <c:v>667.2440185546875</c:v>
                 </c:pt>
                 <c:pt idx="18">
-                  <c:v>721.9102172851562</c:v>
+                  <c:v>737.4002685546875</c:v>
                 </c:pt>
                 <c:pt idx="19">
-                  <c:v>746.77001953125</c:v>
+                  <c:v>747.7100219726562</c:v>
                 </c:pt>
                 <c:pt idx="20">
-                  <c:v>772.6699829101562</c:v>
+                  <c:v>765.719970703125</c:v>
                 </c:pt>
               </c:numCache>
             </c:numRef>
@@ -482,25 +482,25 @@
                   <c:v>2016-10</c:v>
                 </c:pt>
                 <c:pt idx="10">
-                  <c:v>2017-07</c:v>
+                  <c:v>2017-08</c:v>
                 </c:pt>
                 <c:pt idx="11">
-                  <c:v>2018-04</c:v>
+                  <c:v>2018-05</c:v>
                 </c:pt>
                 <c:pt idx="12">
-                  <c:v>2019-01</c:v>
+                  <c:v>2019-02</c:v>
                 </c:pt>
                 <c:pt idx="13">
-                  <c:v>2019-10</c:v>
+                  <c:v>2019-11</c:v>
                 </c:pt>
                 <c:pt idx="14">
-                  <c:v>2020-07</c:v>
+                  <c:v>2020-08</c:v>
                 </c:pt>
                 <c:pt idx="15">
-                  <c:v>2021-04</c:v>
+                  <c:v>2021-05</c:v>
                 </c:pt>
                 <c:pt idx="16">
-                  <c:v>2022-01</c:v>
+                  <c:v>2022-02</c:v>
                 </c:pt>
                 <c:pt idx="17">
                   <c:v>2022-11</c:v>
@@ -509,13 +509,13 @@
                   <c:v>2023-08</c:v>
                 </c:pt>
                 <c:pt idx="19">
-                  <c:v>2024-05</c:v>
+                  <c:v>2024-06</c:v>
                 </c:pt>
                 <c:pt idx="20">
-                  <c:v>2025-02</c:v>
+                  <c:v>2025-03</c:v>
                 </c:pt>
                 <c:pt idx="21">
-                  <c:v>2025-11</c:v>
+                  <c:v>2025-12</c:v>
                 </c:pt>
                 <c:pt idx="22">
                   <c:v>2026-08</c:v>
@@ -530,73 +530,73 @@
                 <c:formatCode>General</c:formatCode>
                 <c:ptCount val="23"/>
                 <c:pt idx="0">
-                  <c:v>84.57848358154297</c:v>
+                  <c:v>84.57846069335938</c:v>
                 </c:pt>
                 <c:pt idx="1">
-                  <c:v>87.83907318115234</c:v>
+                  <c:v>87.83150482177734</c:v>
                 </c:pt>
                 <c:pt idx="2">
-                  <c:v>103.96295166015625</c:v>
+                  <c:v>101.35928344726562</c:v>
                 </c:pt>
                 <c:pt idx="3">
-                  <c:v>107.85619354248047</c:v>
+                  <c:v>108.30094146728516</c:v>
                 </c:pt>
                 <c:pt idx="4">
-                  <c:v>116.80296325683594</c:v>
+                  <c:v>116.77908325195312</c:v>
                 </c:pt>
                 <c:pt idx="5">
-                  <c:v>137.1967010498047</c:v>
+                  <c:v>140.524658203125</c:v>
                 </c:pt>
                 <c:pt idx="6">
-                  <c:v>161.8634033203125</c:v>
+                  <c:v>162.4275360107422</c:v>
                 </c:pt>
                 <c:pt idx="7">
-                  <c:v>172.53610229492188</c:v>
+                  <c:v>175.43174743652344</c:v>
                 </c:pt>
                 <c:pt idx="8">
-                  <c:v>158.54550170898438</c:v>
+                  <c:v>163.3172149658203</c:v>
                 </c:pt>
                 <c:pt idx="9">
-                  <c:v>182.96054077148438</c:v>
+                  <c:v>181.96749877929688</c:v>
                 </c:pt>
                 <c:pt idx="10">
-                  <c:v>214.56993103027344</c:v>
+                  <c:v>215.030517578125</c:v>
                 </c:pt>
                 <c:pt idx="11">
-                  <c:v>231.79591369628906</c:v>
+                  <c:v>237.54273986816406</c:v>
                 </c:pt>
                 <c:pt idx="12">
-                  <c:v>237.76144409179688</c:v>
+                  <c:v>245.20436096191406</c:v>
                 </c:pt>
                 <c:pt idx="13">
-                  <c:v>273.5692138671875</c:v>
+                  <c:v>280.3721008300781</c:v>
                 </c:pt>
                 <c:pt idx="14">
-                  <c:v>299.40765380859375</c:v>
+                  <c:v>311.8583984375</c:v>
                 </c:pt>
                 <c:pt idx="15">
-                  <c:v>388.74951171875</c:v>
+                  <c:v>386.551025390625</c:v>
                 </c:pt>
                 <c:pt idx="16">
-                  <c:v>423.32891845703125</c:v>
+                  <c:v>397.0208740234375</c:v>
                 </c:pt>
                 <c:pt idx="17">
-                  <c:v>365.99114990234375</c:v>
+                  <c:v>382.9429626464844</c:v>
                 </c:pt>
                 <c:pt idx="18">
-                  <c:v>434.2133483886719</c:v>
+                  <c:v>433.8665466308594</c:v>
                 </c:pt>
                 <c:pt idx="19">
-                  <c:v>503.6047058105469</c:v>
+                  <c:v>520.6255493164062</c:v>
                 </c:pt>
                 <c:pt idx="20">
-                  <c:v>595.1217041015625</c:v>
+                  <c:v>549.4632568359375</c:v>
                 </c:pt>
                 <c:pt idx="21">
-                  <c:v>677.7648315429688</c:v>
+                  <c:v>676.1580810546875</c:v>
                 </c:pt>
                 <c:pt idx="22">
-                  <c:v>772.6699829101562</c:v>
+                  <c:v>765.719970703125</c:v>
                 </c:pt>
               </c:numCache>
             </c:numRef>
@@ -763,10 +763,10 @@
                 <c:formatCode>General</c:formatCode>
                 <c:ptCount val="2"/>
                 <c:pt idx="0">
-                  <c:v>4.0208102609277105</c:v>
+                  <c:v>3.997351119803928</c:v>
                 </c:pt>
                 <c:pt idx="1">
-                  <c:v>6.5829837629020895</c:v>
+                  <c:v>6.56511669302305</c:v>
                 </c:pt>
               </c:numCache>
             </c:numRef>
@@ -815,10 +815,10 @@
                 <c:formatCode>General</c:formatCode>
                 <c:ptCount val="2"/>
                 <c:pt idx="0">
-                  <c:v>5.0736439313003405</c:v>
+                  <c:v>5.066843563244119</c:v>
                 </c:pt>
                 <c:pt idx="1">
-                  <c:v>8.64132648900294</c:v>
+                  <c:v>8.631893145317354</c:v>
                 </c:pt>
               </c:numCache>
             </c:numRef>
@@ -867,10 +867,10 @@
                 <c:formatCode>General</c:formatCode>
                 <c:ptCount val="2"/>
                 <c:pt idx="0">
-                  <c:v>5.171261266767612</c:v>
+                  <c:v>5.162876014673304</c:v>
                 </c:pt>
                 <c:pt idx="1">
-                  <c:v>8.211973743994577</c:v>
+                  <c:v>8.201856421046429</c:v>
                 </c:pt>
               </c:numCache>
             </c:numRef>
@@ -1082,16 +1082,16 @@
                 <c:formatCode>General</c:formatCode>
                 <c:ptCount val="4"/>
                 <c:pt idx="0">
-                  <c:v>72.68864168035438</c:v>
+                  <c:v>72.38707673190432</c:v>
                 </c:pt>
                 <c:pt idx="1">
-                  <c:v>37.15846994535519</c:v>
+                  <c:v>37.22222222222222</c:v>
                 </c:pt>
                 <c:pt idx="2">
-                  <c:v>61.261261261261254</c:v>
+                  <c:v>60.36036036036037</c:v>
                 </c:pt>
                 <c:pt idx="3">
-                  <c:v>77.67408292270169</c:v>
+                  <c:v>77.83659521590556</c:v>
                 </c:pt>
               </c:numCache>
             </c:numRef>
@@ -1294,13 +1294,13 @@
                 <c:formatCode>General</c:formatCode>
                 <c:ptCount val="3"/>
                 <c:pt idx="0">
-                  <c:v>13.493320335371816</c:v>
+                  <c:v>13.147258293105518</c:v>
                 </c:pt>
                 <c:pt idx="1">
-                  <c:v>11.290565874276576</c:v>
+                  <c:v>13.178000306709961</c:v>
                 </c:pt>
                 <c:pt idx="2">
-                  <c:v>17.14655195338459</c:v>
+                  <c:v>17.139276851402677</c:v>
                 </c:pt>
               </c:numCache>
             </c:numRef>
@@ -1837,7 +1837,7 @@
           </a:p>
           <a:p>
             <a:r>
-              <a:t>- project/data/raw/spy_daily_20260817T224143Z.csv</a:t>
+              <a:t>- project/data/raw/spy_daily_20260822T145555677609Z.csv</a:t>
             </a:r>
           </a:p>
           <a:p>
@@ -2097,7 +2097,7 @@
           </a:p>
           <a:p>
             <a:r>
-              <a:t>- project/data/raw/spy_daily_20260817T224143Z.manifest.json</a:t>
+              <a:t>- project/data/raw/spy_daily_20260822T145555677609Z.manifest.json</a:t>
             </a:r>
           </a:p>
           <a:p>
@@ -5842,7 +5842,7 @@
               </a:defRPr>
             </a:pPr>
             <a:r>
-              <a:t>Data through August 17, 2026</a:t>
+              <a:t>Data through August 21, 2026</a:t>
             </a:r>
           </a:p>
         </p:txBody>
@@ -7245,7 +7245,7 @@
               </a:defRPr>
             </a:pPr>
             <a:r>
-              <a:t>4,180 validated trading days anchor the analysis</a:t>
+              <a:t>4,184 validated trading days anchor the analysis</a:t>
             </a:r>
           </a:p>
         </p:txBody>
@@ -7476,7 +7476,7 @@
               </a:defRPr>
             </a:pPr>
             <a:r>
-              <a:t>4,180</a:t>
+              <a:t>4,184</a:t>
             </a:r>
           </a:p>
         </p:txBody>
@@ -7772,7 +7772,7 @@
               </a:defRPr>
             </a:pPr>
             <a:r>
-              <a:t>2010-01-04 to 2026-08-17</a:t>
+              <a:t>2010-01-04 to 2026-08-21</a:t>
             </a:r>
           </a:p>
         </p:txBody>
@@ -9007,7 +9007,7 @@
               </a:defRPr>
             </a:pPr>
             <a:r>
-              <a:t>Ridge cut forecast MAE by 20.8% versus recent volatility</a:t>
+              <a:t>Ridge cut forecast MAE by 21.1% versus recent volatility</a:t>
             </a:r>
           </a:p>
         </p:txBody>
@@ -9238,7 +9238,7 @@
               </a:defRPr>
             </a:pPr>
             <a:r>
-              <a:t>4.02 pp</a:t>
+              <a:t>4.00 pp</a:t>
             </a:r>
           </a:p>
         </p:txBody>
@@ -9450,7 +9450,7 @@
               </a:defRPr>
             </a:pPr>
             <a:r>
-              <a:t>0.336</a:t>
+              <a:t>0.338</a:t>
             </a:r>
           </a:p>
         </p:txBody>
@@ -9662,7 +9662,7 @@
               </a:defRPr>
             </a:pPr>
             <a:r>
-              <a:t>20.8%</a:t>
+              <a:t>21.1%</a:t>
             </a:r>
           </a:p>
         </p:txBody>
@@ -9788,7 +9788,7 @@
               </a:defRPr>
             </a:pPr>
             <a:r>
-              <a:t>Test period: 2023-04-12 to 2026-08-10</a:t>
+              <a:t>Test period: 2023-04-17 to 2026-08-14</a:t>
             </a:r>
           </a:p>
         </p:txBody>
@@ -9898,7 +9898,7 @@
               </a:defRPr>
             </a:pPr>
             <a:r>
-              <a:t>The warning model catches 61% of elevated-risk windows</a:t>
+              <a:t>The warning model catches 60% of elevated-risk windows</a:t>
             </a:r>
           </a:p>
         </p:txBody>
@@ -10044,7 +10044,7 @@
               </a:defRPr>
             </a:pPr>
             <a:r>
-              <a:t>68</a:t>
+              <a:t>67</a:t>
             </a:r>
           </a:p>
         </p:txBody>
@@ -10128,7 +10128,7 @@
               </a:defRPr>
             </a:pPr>
             <a:r>
-              <a:t>43 elevated-risk windows were missed</a:t>
+              <a:t>44 elevated-risk windows were missed</a:t>
             </a:r>
           </a:p>
         </p:txBody>
@@ -10872,7 +10872,7 @@
               </a:defRPr>
             </a:pPr>
             <a:r>
-              <a:t>74.1%</a:t>
+              <a:t>74.0%</a:t>
             </a:r>
           </a:p>
         </p:txBody>
@@ -10956,7 +10956,7 @@
               </a:defRPr>
             </a:pPr>
             <a:r>
-              <a:t>4 expanding folds with a 5-session embargo; balanced accuracy 79.3%.</a:t>
+              <a:t>4 expanding folds with a 5-session embargo; balanced accuracy 79.1%.</a:t>
             </a:r>
           </a:p>
         </p:txBody>
@@ -11404,7 +11404,7 @@
               </a:defRPr>
             </a:pPr>
             <a:r>
-              <a:t>As of 2026-08-17</a:t>
+              <a:t>As of 2026-08-21</a:t>
             </a:r>
           </a:p>
         </p:txBody>
@@ -11590,7 +11590,7 @@
               </a:defRPr>
             </a:pPr>
             <a:r>
-              <a:t>Risk score: 25.2% · elevated at 50%</a:t>
+              <a:t>Risk score: 35.3% · elevated at 50%</a:t>
             </a:r>
           </a:p>
         </p:txBody>

</xml_diff>

<commit_message>
Refresh SPY data through August 25
</commit_message>
<xml_diff>
--- a/project/reports/stakeholder_presentation.pptx
+++ b/project/reports/stakeholder_presentation.pptx
@@ -164,7 +164,7 @@
                   <c:v>2023-12</c:v>
                 </c:pt>
                 <c:pt idx="3">
-                  <c:v>2024-01</c:v>
+                  <c:v>2024-02</c:v>
                 </c:pt>
                 <c:pt idx="4">
                   <c:v>2024-03</c:v>
@@ -179,7 +179,7 @@
                   <c:v>2024-09</c:v>
                 </c:pt>
                 <c:pt idx="8">
-                  <c:v>2024-10</c:v>
+                  <c:v>2024-11</c:v>
                 </c:pt>
                 <c:pt idx="9">
                   <c:v>2024-12</c:v>
@@ -227,67 +227,67 @@
                 <c:formatCode>General</c:formatCode>
                 <c:ptCount val="21"/>
                 <c:pt idx="0">
-                  <c:v>420.3211364746094</c:v>
+                  <c:v>423.2596435546875</c:v>
                 </c:pt>
                 <c:pt idx="1">
-                  <c:v>421.832763671875</c:v>
+                  <c:v>417.1728210449219</c:v>
                 </c:pt>
                 <c:pt idx="2">
-                  <c:v>441.439453125</c:v>
+                  <c:v>443.01531982421875</c:v>
                 </c:pt>
                 <c:pt idx="3">
-                  <c:v>468.7396545410156</c:v>
+                  <c:v>479.873779296875</c:v>
                 </c:pt>
                 <c:pt idx="4">
-                  <c:v>505.18231201171875</c:v>
+                  <c:v>509.33026123046875</c:v>
                 </c:pt>
                 <c:pt idx="5">
-                  <c:v>516.13671875</c:v>
+                  <c:v>515.912841796875</c:v>
                 </c:pt>
                 <c:pt idx="6">
-                  <c:v>551.7969970703125</c:v>
+                  <c:v>539.8790893554688</c:v>
                 </c:pt>
                 <c:pt idx="7">
-                  <c:v>533.7737426757812</c:v>
+                  <c:v>541.5985717773438</c:v>
                 </c:pt>
                 <c:pt idx="8">
-                  <c:v>557.1934814453125</c:v>
+                  <c:v>558.3399658203125</c:v>
                 </c:pt>
                 <c:pt idx="9">
-                  <c:v>591.2184448242188</c:v>
+                  <c:v>578.3192138671875</c:v>
                 </c:pt>
                 <c:pt idx="10">
-                  <c:v>587.1578979492188</c:v>
+                  <c:v>584.5328369140625</c:v>
                 </c:pt>
                 <c:pt idx="11">
-                  <c:v>519.1064453125</c:v>
+                  <c:v>519.9349365234375</c:v>
                 </c:pt>
                 <c:pt idx="12">
-                  <c:v>595.37353515625</c:v>
+                  <c:v>594.3182983398438</c:v>
                 </c:pt>
                 <c:pt idx="13">
-                  <c:v>625.3212890625</c:v>
+                  <c:v>628.9509887695312</c:v>
                 </c:pt>
                 <c:pt idx="14">
-                  <c:v>662.95751953125</c:v>
+                  <c:v>663.7112426757812</c:v>
                 </c:pt>
                 <c:pt idx="15">
-                  <c:v>663.235107421875</c:v>
+                  <c:v>674.09521484375</c:v>
                 </c:pt>
                 <c:pt idx="16">
-                  <c:v>681.77685546875</c:v>
+                  <c:v>685.5865478515625</c:v>
                 </c:pt>
                 <c:pt idx="17">
-                  <c:v>667.2440185546875</c:v>
+                  <c:v>656.3121337890625</c:v>
                 </c:pt>
                 <c:pt idx="18">
-                  <c:v>737.4002685546875</c:v>
+                  <c:v>740.4025268554688</c:v>
                 </c:pt>
                 <c:pt idx="19">
-                  <c:v>747.7100219726562</c:v>
+                  <c:v>751.7100219726562</c:v>
                 </c:pt>
                 <c:pt idx="20">
-                  <c:v>765.719970703125</c:v>
+                  <c:v>765.9099731445312</c:v>
                 </c:pt>
               </c:numCache>
             </c:numRef>
@@ -530,73 +530,73 @@
                 <c:formatCode>General</c:formatCode>
                 <c:ptCount val="23"/>
                 <c:pt idx="0">
-                  <c:v>84.57846069335938</c:v>
+                  <c:v>84.57847595214844</c:v>
                 </c:pt>
                 <c:pt idx="1">
-                  <c:v>87.83150482177734</c:v>
+                  <c:v>87.83148956298828</c:v>
                 </c:pt>
                 <c:pt idx="2">
-                  <c:v>101.35928344726562</c:v>
+                  <c:v>101.35924530029297</c:v>
                 </c:pt>
                 <c:pt idx="3">
-                  <c:v>108.30094146728516</c:v>
+                  <c:v>108.30091857910156</c:v>
                 </c:pt>
                 <c:pt idx="4">
-                  <c:v>116.77908325195312</c:v>
+                  <c:v>116.77906799316406</c:v>
                 </c:pt>
                 <c:pt idx="5">
-                  <c:v>140.524658203125</c:v>
+                  <c:v>140.52471923828125</c:v>
                 </c:pt>
                 <c:pt idx="6">
-                  <c:v>162.4275360107422</c:v>
+                  <c:v>162.42758178710938</c:v>
                 </c:pt>
                 <c:pt idx="7">
                   <c:v>175.43174743652344</c:v>
                 </c:pt>
                 <c:pt idx="8">
-                  <c:v>163.3172149658203</c:v>
+                  <c:v>163.31724548339844</c:v>
                 </c:pt>
                 <c:pt idx="9">
-                  <c:v>181.96749877929688</c:v>
+                  <c:v>181.96746826171875</c:v>
                 </c:pt>
                 <c:pt idx="10">
-                  <c:v>215.030517578125</c:v>
+                  <c:v>215.03053283691406</c:v>
                 </c:pt>
                 <c:pt idx="11">
-                  <c:v>237.54273986816406</c:v>
+                  <c:v>237.54275512695312</c:v>
                 </c:pt>
                 <c:pt idx="12">
-                  <c:v>245.20436096191406</c:v>
+                  <c:v>245.2042999267578</c:v>
                 </c:pt>
                 <c:pt idx="13">
-                  <c:v>280.3721008300781</c:v>
+                  <c:v>280.3722229003906</c:v>
                 </c:pt>
                 <c:pt idx="14">
-                  <c:v>311.8583984375</c:v>
+                  <c:v>311.85833740234375</c:v>
                 </c:pt>
                 <c:pt idx="15">
-                  <c:v>386.551025390625</c:v>
+                  <c:v>386.55108642578125</c:v>
                 </c:pt>
                 <c:pt idx="16">
-                  <c:v>397.0208740234375</c:v>
+                  <c:v>397.0208435058594</c:v>
                 </c:pt>
                 <c:pt idx="17">
-                  <c:v>382.9429626464844</c:v>
+                  <c:v>382.9429931640625</c:v>
                 </c:pt>
                 <c:pt idx="18">
-                  <c:v>433.8665466308594</c:v>
+                  <c:v>433.8665771484375</c:v>
                 </c:pt>
                 <c:pt idx="19">
-                  <c:v>520.6255493164062</c:v>
+                  <c:v>520.6256713867188</c:v>
                 </c:pt>
                 <c:pt idx="20">
                   <c:v>549.4632568359375</c:v>
                 </c:pt>
                 <c:pt idx="21">
-                  <c:v>676.1580810546875</c:v>
+                  <c:v>676.1581420898438</c:v>
                 </c:pt>
                 <c:pt idx="22">
-                  <c:v>765.719970703125</c:v>
+                  <c:v>765.9099731445312</c:v>
                 </c:pt>
               </c:numCache>
             </c:numRef>
@@ -763,10 +763,10 @@
                 <c:formatCode>General</c:formatCode>
                 <c:ptCount val="2"/>
                 <c:pt idx="0">
-                  <c:v>3.997351119803928</c:v>
+                  <c:v>3.990764204608996</c:v>
                 </c:pt>
                 <c:pt idx="1">
-                  <c:v>6.56511669302305</c:v>
+                  <c:v>6.556949092920923</c:v>
                 </c:pt>
               </c:numCache>
             </c:numRef>
@@ -815,10 +815,10 @@
                 <c:formatCode>General</c:formatCode>
                 <c:ptCount val="2"/>
                 <c:pt idx="0">
-                  <c:v>5.066843563244119</c:v>
+                  <c:v>5.063987670794168</c:v>
                 </c:pt>
                 <c:pt idx="1">
-                  <c:v>8.631893145317354</c:v>
+                  <c:v>8.626174723041489</c:v>
                 </c:pt>
               </c:numCache>
             </c:numRef>
@@ -867,10 +867,10 @@
                 <c:formatCode>General</c:formatCode>
                 <c:ptCount val="2"/>
                 <c:pt idx="0">
-                  <c:v>5.162876014673304</c:v>
+                  <c:v>5.158660985550454</c:v>
                 </c:pt>
                 <c:pt idx="1">
-                  <c:v>8.201856421046429</c:v>
+                  <c:v>8.1947443672594</c:v>
                 </c:pt>
               </c:numCache>
             </c:numRef>
@@ -1082,7 +1082,7 @@
                 <c:formatCode>General</c:formatCode>
                 <c:ptCount val="4"/>
                 <c:pt idx="0">
-                  <c:v>72.38707673190432</c:v>
+                  <c:v>72.39781103417468</c:v>
                 </c:pt>
                 <c:pt idx="1">
                   <c:v>37.22222222222222</c:v>
@@ -1091,7 +1091,7 @@
                   <c:v>60.36036036036037</c:v>
                 </c:pt>
                 <c:pt idx="3">
-                  <c:v>77.83659521590556</c:v>
+                  <c:v>77.85347330801876</c:v>
                 </c:pt>
               </c:numCache>
             </c:numRef>
@@ -1294,13 +1294,13 @@
                 <c:formatCode>General</c:formatCode>
                 <c:ptCount val="3"/>
                 <c:pt idx="0">
-                  <c:v>13.147258293105518</c:v>
+                  <c:v>13.253763789870987</c:v>
                 </c:pt>
                 <c:pt idx="1">
-                  <c:v>13.178000306709961</c:v>
+                  <c:v>11.25118123222827</c:v>
                 </c:pt>
                 <c:pt idx="2">
-                  <c:v>17.139276851402677</c:v>
+                  <c:v>17.136329245241306</c:v>
                 </c:pt>
               </c:numCache>
             </c:numRef>
@@ -1837,7 +1837,7 @@
           </a:p>
           <a:p>
             <a:r>
-              <a:t>- project/data/raw/spy_daily_20260822T145555677609Z.csv</a:t>
+              <a:t>- project/data/raw/spy_daily_20260826T030031701985Z.csv</a:t>
             </a:r>
           </a:p>
           <a:p>
@@ -2097,7 +2097,7 @@
           </a:p>
           <a:p>
             <a:r>
-              <a:t>- project/data/raw/spy_daily_20260822T145555677609Z.manifest.json</a:t>
+              <a:t>- project/data/raw/spy_daily_20260826T030031701985Z.manifest.json</a:t>
             </a:r>
           </a:p>
           <a:p>
@@ -5842,7 +5842,7 @@
               </a:defRPr>
             </a:pPr>
             <a:r>
-              <a:t>Data through August 21, 2026</a:t>
+              <a:t>Data through August 25, 2026</a:t>
             </a:r>
           </a:p>
         </p:txBody>
@@ -7245,7 +7245,7 @@
               </a:defRPr>
             </a:pPr>
             <a:r>
-              <a:t>4,184 validated trading days anchor the analysis</a:t>
+              <a:t>4,186 validated trading days anchor the analysis</a:t>
             </a:r>
           </a:p>
         </p:txBody>
@@ -7476,7 +7476,7 @@
               </a:defRPr>
             </a:pPr>
             <a:r>
-              <a:t>4,184</a:t>
+              <a:t>4,186</a:t>
             </a:r>
           </a:p>
         </p:txBody>
@@ -7772,7 +7772,7 @@
               </a:defRPr>
             </a:pPr>
             <a:r>
-              <a:t>2010-01-04 to 2026-08-21</a:t>
+              <a:t>2010-01-04 to 2026-08-25</a:t>
             </a:r>
           </a:p>
         </p:txBody>
@@ -9007,7 +9007,7 @@
               </a:defRPr>
             </a:pPr>
             <a:r>
-              <a:t>Ridge cut forecast MAE by 21.1% versus recent volatility</a:t>
+              <a:t>Ridge cut forecast MAE by 21.2% versus recent volatility</a:t>
             </a:r>
           </a:p>
         </p:txBody>
@@ -9238,7 +9238,7 @@
               </a:defRPr>
             </a:pPr>
             <a:r>
-              <a:t>4.00 pp</a:t>
+              <a:t>3.99 pp</a:t>
             </a:r>
           </a:p>
         </p:txBody>
@@ -9662,7 +9662,7 @@
               </a:defRPr>
             </a:pPr>
             <a:r>
-              <a:t>21.1%</a:t>
+              <a:t>21.2%</a:t>
             </a:r>
           </a:p>
         </p:txBody>
@@ -9788,7 +9788,7 @@
               </a:defRPr>
             </a:pPr>
             <a:r>
-              <a:t>Test period: 2023-04-17 to 2026-08-14</a:t>
+              <a:t>Test period: 2023-04-18 to 2026-08-18</a:t>
             </a:r>
           </a:p>
         </p:txBody>
@@ -10872,7 +10872,7 @@
               </a:defRPr>
             </a:pPr>
             <a:r>
-              <a:t>74.0%</a:t>
+              <a:t>73.9%</a:t>
             </a:r>
           </a:p>
         </p:txBody>
@@ -11404,7 +11404,7 @@
               </a:defRPr>
             </a:pPr>
             <a:r>
-              <a:t>As of 2026-08-21</a:t>
+              <a:t>As of 2026-08-25</a:t>
             </a:r>
           </a:p>
         </p:txBody>
@@ -11590,7 +11590,7 @@
               </a:defRPr>
             </a:pPr>
             <a:r>
-              <a:t>Risk score: 35.3% · elevated at 50%</a:t>
+              <a:t>Risk score: 25.1% · elevated at 50%</a:t>
             </a:r>
           </a:p>
         </p:txBody>

</xml_diff>